<commit_message>
Updated README and included slides
</commit_message>
<xml_diff>
--- a/slides/cre-ai-agent-system.pptx
+++ b/slides/cre-ai-agent-system.pptx
@@ -4,6 +4,9 @@
   <p:sldMasterIdLst>
     <p:sldMasterId id="2147483648" r:id="rId1"/>
   </p:sldMasterIdLst>
+  <p:notesMasterIdLst>
+    <p:notesMasterId r:id="rId7"/>
+  </p:notesMasterIdLst>
   <p:sldIdLst>
     <p:sldId id="256" r:id="rId2"/>
     <p:sldId id="257" r:id="rId3"/>
@@ -11,9 +14,6 @@
     <p:sldId id="259" r:id="rId5"/>
     <p:sldId id="260" r:id="rId6"/>
   </p:sldIdLst>
-  <p:notesMasterIdLst>
-    <p:notesMasterId r:id="rId7"/>
-  </p:notesMasterIdLst>
   <p:sldSz cx="12192000" cy="6858000"/>
   <p:notesSz cx="6858000" cy="12192000"/>
   <p:defaultTextStyle>
@@ -108,6 +108,11 @@
       </a:defRPr>
     </a:lvl9pPr>
   </p:defaultTextStyle>
+  <p:extLst>
+    <p:ext uri="{EFAFB233-063F-42B5-8137-9DF3F51BA10A}">
+      <p15:sldGuideLst xmlns:p15="http://schemas.microsoft.com/office/powerpoint/2012/main"/>
+    </p:ext>
+  </p:extLst>
 </p:presentation>
 </file>
 
@@ -133,234 +138,10 @@
           <a:chExt cx="0" cy="0"/>
         </a:xfrm>
       </p:grpSpPr>
-      <p:sp>
-        <p:nvSpPr>
-          <p:cNvPr id="2" name="Header Placeholder 1"/>
-          <p:cNvSpPr>
-            <a:spLocks noGrp="1"/>
-          </p:cNvSpPr>
-          <p:nvPr>
-            <p:ph type="hdr" sz="quarter"/>
-          </p:nvPr>
-        </p:nvSpPr>
-        <p:spPr>
-          <a:xfrm>
-            <a:off x="0" y="0"/>
-            <a:ext cx="2971800" cy="458788"/>
-          </a:xfrm>
-          <a:prstGeom prst="rect">
-            <a:avLst/>
-          </a:prstGeom>
-        </p:spPr>
-        <p:txBody>
-          <a:bodyPr vert="horz" lIns="91440" tIns="45720" rIns="91440" bIns="45720" rtlCol="0"/>
-          <a:lstStyle>
-            <a:lvl1pPr algn="l">
-              <a:defRPr sz="1200"/>
-            </a:lvl1pPr>
-          </a:lstStyle>
-          <a:p>
-            <a:endParaRPr lang="en-US"/>
-          </a:p>
-        </p:txBody>
-      </p:sp>
-      <p:sp>
-        <p:nvSpPr>
-          <p:cNvPr id="3" name="Date Placeholder 2"/>
-          <p:cNvSpPr>
-            <a:spLocks noGrp="1"/>
-          </p:cNvSpPr>
-          <p:nvPr>
-            <p:ph type="dt" idx="1"/>
-          </p:nvPr>
-        </p:nvSpPr>
-        <p:spPr>
-          <a:xfrm>
-            <a:off x="3884613" y="0"/>
-            <a:ext cx="2971800" cy="458788"/>
-          </a:xfrm>
-          <a:prstGeom prst="rect">
-            <a:avLst/>
-          </a:prstGeom>
-        </p:spPr>
-        <p:txBody>
-          <a:bodyPr vert="horz" lIns="91440" tIns="45720" rIns="91440" bIns="45720" rtlCol="0"/>
-          <a:lstStyle>
-            <a:lvl1pPr algn="r">
-              <a:defRPr sz="1200"/>
-            </a:lvl1pPr>
-          </a:lstStyle>
-          <a:p>
-            <a:fld id="{5282F153-3F37-0F45-9E97-73ACFA13230C}" type="datetimeFigureOut">
-              <a:rPr lang="en-US"/>
-              <a:t>7/23/19</a:t>
-            </a:fld>
-            <a:endParaRPr lang="en-US"/>
-          </a:p>
-        </p:txBody>
-      </p:sp>
-      <p:sp>
-        <p:nvSpPr>
-          <p:cNvPr id="4" name="Slide Image Placeholder 3"/>
-          <p:cNvSpPr>
-            <a:spLocks noGrp="1" noRot="1" noChangeAspect="1"/>
-          </p:cNvSpPr>
-          <p:nvPr>
-            <p:ph type="sldImg" idx="2"/>
-          </p:nvPr>
-        </p:nvSpPr>
-        <p:spPr>
-          <a:xfrm>
-            <a:off x="685800" y="1143000"/>
-            <a:ext cx="5486400" cy="3086100"/>
-          </a:xfrm>
-          <a:prstGeom prst="rect">
-            <a:avLst/>
-          </a:prstGeom>
-          <a:noFill/>
-          <a:ln w="12700">
-            <a:solidFill>
-              <a:prstClr val="black"/>
-            </a:solidFill>
-          </a:ln>
-        </p:spPr>
-        <p:txBody>
-          <a:bodyPr vert="horz" lIns="91440" tIns="45720" rIns="91440" bIns="45720" rtlCol="0" anchor="ctr"/>
-          <a:lstStyle/>
-          <a:p>
-            <a:endParaRPr lang="en-US"/>
-          </a:p>
-        </p:txBody>
-      </p:sp>
-      <p:sp>
-        <p:nvSpPr>
-          <p:cNvPr id="5" name="Notes Placeholder 4"/>
-          <p:cNvSpPr>
-            <a:spLocks noGrp="1"/>
-          </p:cNvSpPr>
-          <p:nvPr>
-            <p:ph type="body" sz="quarter" idx="3"/>
-          </p:nvPr>
-        </p:nvSpPr>
-        <p:spPr>
-          <a:xfrm>
-            <a:off x="685800" y="4400550"/>
-            <a:ext cx="5486400" cy="3600450"/>
-          </a:xfrm>
-          <a:prstGeom prst="rect">
-            <a:avLst/>
-          </a:prstGeom>
-        </p:spPr>
-        <p:txBody>
-          <a:bodyPr vert="horz" lIns="91440" tIns="45720" rIns="91440" bIns="45720" rtlCol="0"/>
-          <a:lstStyle/>
-          <a:p>
-            <a:pPr lvl="0"/>
-            <a:r>
-              <a:rPr lang="en-US"/>
-              <a:t>Click to edit Master text styles</a:t>
-            </a:r>
-          </a:p>
-          <a:p>
-            <a:pPr lvl="1"/>
-            <a:r>
-              <a:rPr lang="en-US"/>
-              <a:t>Second level</a:t>
-            </a:r>
-          </a:p>
-          <a:p>
-            <a:pPr lvl="2"/>
-            <a:r>
-              <a:rPr lang="en-US"/>
-              <a:t>Third level</a:t>
-            </a:r>
-          </a:p>
-          <a:p>
-            <a:pPr lvl="3"/>
-            <a:r>
-              <a:rPr lang="en-US"/>
-              <a:t>Fourth level</a:t>
-            </a:r>
-          </a:p>
-          <a:p>
-            <a:pPr lvl="4"/>
-            <a:r>
-              <a:rPr lang="en-US"/>
-              <a:t>Fifth level</a:t>
-            </a:r>
-          </a:p>
-        </p:txBody>
-      </p:sp>
-      <p:sp>
-        <p:nvSpPr>
-          <p:cNvPr id="6" name="Footer Placeholder 5"/>
-          <p:cNvSpPr>
-            <a:spLocks noGrp="1"/>
-          </p:cNvSpPr>
-          <p:nvPr>
-            <p:ph type="ftr" sz="quarter" idx="4"/>
-          </p:nvPr>
-        </p:nvSpPr>
-        <p:spPr>
-          <a:xfrm>
-            <a:off x="0" y="8685213"/>
-            <a:ext cx="2971800" cy="458787"/>
-          </a:xfrm>
-          <a:prstGeom prst="rect">
-            <a:avLst/>
-          </a:prstGeom>
-        </p:spPr>
-        <p:txBody>
-          <a:bodyPr vert="horz" lIns="91440" tIns="45720" rIns="91440" bIns="45720" rtlCol="0" anchor="b"/>
-          <a:lstStyle>
-            <a:lvl1pPr algn="l">
-              <a:defRPr sz="1200"/>
-            </a:lvl1pPr>
-          </a:lstStyle>
-          <a:p>
-            <a:endParaRPr lang="en-US"/>
-          </a:p>
-        </p:txBody>
-      </p:sp>
-      <p:sp>
-        <p:nvSpPr>
-          <p:cNvPr id="7" name="Slide Number Placeholder 6"/>
-          <p:cNvSpPr>
-            <a:spLocks noGrp="1"/>
-          </p:cNvSpPr>
-          <p:nvPr>
-            <p:ph type="sldNum" sz="quarter" idx="5"/>
-          </p:nvPr>
-        </p:nvSpPr>
-        <p:spPr>
-          <a:xfrm>
-            <a:off x="3884613" y="8685213"/>
-            <a:ext cx="2971800" cy="458787"/>
-          </a:xfrm>
-          <a:prstGeom prst="rect">
-            <a:avLst/>
-          </a:prstGeom>
-        </p:spPr>
-        <p:txBody>
-          <a:bodyPr vert="horz" lIns="91440" tIns="45720" rIns="91440" bIns="45720" rtlCol="0" anchor="b"/>
-          <a:lstStyle>
-            <a:lvl1pPr algn="r">
-              <a:defRPr sz="1200"/>
-            </a:lvl1pPr>
-          </a:lstStyle>
-          <a:p>
-            <a:fld id="{CE5E9CC1-C706-0F49-92D6-E571CC5EEA8F}" type="slidenum">
-              <a:rPr lang="en-US"/>
-              <a:t>‹#›</a:t>
-            </a:fld>
-            <a:endParaRPr lang="en-US"/>
-          </a:p>
-        </p:txBody>
-      </p:sp>
     </p:spTree>
     <p:extLst>
       <p:ext uri="{BB962C8B-B14F-4D97-AF65-F5344CB8AC3E}">
-        <p14:creationId xmlns:p14="http://schemas.microsoft.com/office/powerpoint/2010/main" val="1024086991"/>
+        <p14:creationId xmlns:p14="http://schemas.microsoft.com/office/powerpoint/2010/main" val="1689567199"/>
       </p:ext>
     </p:extLst>
   </p:cSld>
@@ -508,7 +289,6 @@
               <a:rPr lang="en-US" dirty="0"/>
               <a:t>Deterministic spine, agentic edges. Every market figure is real and sourced; the three holdings are fictional so the relevance matching has something to match against.</a:t>
             </a:r>
-            <a:endParaRPr lang="en-US" dirty="0"/>
           </a:p>
         </p:txBody>
       </p:sp>
@@ -596,7 +376,6 @@
               <a:rPr lang="en-US" dirty="0"/>
               <a:t>Adoption is not the issue: 92% of CRE teams are piloting AI (JLL, October 2025) and 66% use it weekly or daily (First American / DealGround, May 2026). Trust is: 5% will let it inform a deal decision. Because the model is the source, every figure has to be re-derived by hand, which is exactly the labour it was bought to remove.</a:t>
             </a:r>
-            <a:endParaRPr lang="en-US" dirty="0"/>
           </a:p>
         </p:txBody>
       </p:sp>
@@ -682,9 +461,8 @@
           <a:p>
             <a:r>
               <a:rPr lang="en-US" dirty="0"/>
-              <a:t>Five rows, and the last column is a mechanism rather than a promise: the model never computes. Python produces every figure, Gemini narrates it. If asked what was cut: reporting what changed since last quarter (ranked deltas), which the demo shows anyway.</a:t>
-            </a:r>
-            <a:endParaRPr lang="en-US" dirty="0"/>
+              <a:t>Four rows, one verdict word each. The last column is a mechanism rather than a promise: the model never computes. Python produces every figure, Gemini narrates it, and where the sources do not carry an answer the agent declines rather than inventing one. Row 3 is the only row published research also wins, which is the point: this system is built on those sources, not against them.</a:t>
+            </a:r>
           </a:p>
         </p:txBody>
       </p:sp>
@@ -770,9 +548,8 @@
           <a:p>
             <a:r>
               <a:rPr lang="en-US" dirty="0"/>
-              <a:t>Open on the brief, not on a prompt. The point to make out loud: the ordering is not the model's opinion, it is severity ranking in code, and it is identical on every run.</a:t>
-            </a:r>
-            <a:endParaRPr lang="en-US" dirty="0"/>
+              <a:t>Two tool calls, and the screenshot says so. The first is the one worth pausing on: the question never mentioned that The Bailey belongs to us, so the agent read the portfolio before it read the market. Step three is the architecture in one sentence. Python produced every figure in that table; the model only laid it out. The footline is the refusal, and it happened inside a correct answer rather than instead of one. If anyone challenges the 1999 date: 16 Old Bailey is a Grade II listed 1912 front block with a 1999 extension holding about 90% of the floor area, deep-retrofitted by Orms to completion in April 2021. We index the vintage that holds the area, and the roster note records that choice.</a:t>
+            </a:r>
           </a:p>
         </p:txBody>
       </p:sp>
@@ -858,9 +635,8 @@
           <a:p>
             <a:r>
               <a:rPr lang="en-US" dirty="0"/>
-              <a:t>End the walkthrough on the refusal. An agent declining to invent a macro figure is a stronger close than another correct answer, because it is the only demonstration of the trust gap actually being closed.</a:t>
-            </a:r>
-            <a:endParaRPr lang="en-US" dirty="0"/>
+              <a:t>Eleven tool calls for one question, against two for The Bailey: the work scales with the question, and the panel can see it. Step three is the one to slow down on. The agent asked for Tech &amp; Media take-up, the store answered that no level is published for the half, and rather than estimate one it reported the change the source does carry, 64% above the long-run average. That is the whole trust argument in a single tool call. Step four is why the answer ends on hold at 99 City Road and Regent Quarter: it read the holdings before it decided.</a:t>
+            </a:r>
           </a:p>
         </p:txBody>
       </p:sp>
@@ -933,6 +709,11 @@
 <file path=ppt/slideMasters/slideMaster1.xml><?xml version="1.0" encoding="utf-8"?>
 <p:sldMaster xmlns:a="http://schemas.openxmlformats.org/drawingml/2006/main" xmlns:r="http://schemas.openxmlformats.org/officeDocument/2006/relationships" xmlns:p="http://schemas.openxmlformats.org/presentationml/2006/main">
   <p:cSld>
+    <p:bg>
+      <p:bgRef idx="1001">
+        <a:schemeClr val="bg1"/>
+      </p:bgRef>
+    </p:bg>
     <p:spTree>
       <p:nvGrpSpPr>
         <p:cNvPr id="1" name=""/>
@@ -1215,6 +996,7 @@
         <a:solidFill>
           <a:srgbClr val="F6F2E8"/>
         </a:solidFill>
+        <a:effectLst/>
       </p:bgPr>
     </p:bg>
     <p:spTree>
@@ -1233,14 +1015,14 @@
       </p:grpSpPr>
       <p:pic>
         <p:nvPicPr>
-          <p:cNvPr id="2" name="Image 0" descr="/Users/ethanlee/Desktop/projects/cre_market_agent/slides/assets/title-bg-16x9.jpg">    </p:cNvPr>
+          <p:cNvPr id="2" name="Image 0" descr="/Users/ethanlee/Desktop/projects/cre_market_agent/slides/assets/title-bg-16x9.jpg"/>
           <p:cNvPicPr>
             <a:picLocks noChangeAspect="1"/>
           </p:cNvPicPr>
           <p:nvPr/>
         </p:nvPicPr>
         <p:blipFill>
-          <a:blip r:embed="rId1"/>
+          <a:blip r:embed="rId3"/>
           <a:stretch>
             <a:fillRect/>
           </a:stretch>
@@ -1276,6 +1058,13 @@
           </a:solidFill>
           <a:ln/>
         </p:spPr>
+        <p:txBody>
+          <a:bodyPr/>
+          <a:lstStyle/>
+          <a:p>
+            <a:endParaRPr lang="en-US"/>
+          </a:p>
+        </p:txBody>
       </p:sp>
       <p:sp>
         <p:nvSpPr>
@@ -1298,11 +1087,11 @@
           <a:bodyPr wrap="square" lIns="0" tIns="0" rIns="0" bIns="0" rtlCol="0" anchor="t"/>
           <a:lstStyle/>
           <a:p>
-            <a:pPr algn="ctr" indent="0" marL="0">
+            <a:pPr marL="0" indent="0" algn="ctr">
               <a:buNone/>
             </a:pPr>
             <a:r>
-              <a:rPr lang="en-US" sz="1100" b="1" spc="220" kern="0" dirty="0">
+              <a:rPr lang="en-US" sz="1100" b="1" kern="0" spc="220" dirty="0">
                 <a:solidFill>
                   <a:srgbClr val="E6E0D2"/>
                 </a:solidFill>
@@ -1337,7 +1126,7 @@
           <a:bodyPr wrap="square" lIns="0" tIns="0" rIns="0" bIns="0" rtlCol="0" anchor="t"/>
           <a:lstStyle/>
           <a:p>
-            <a:pPr algn="ctr" indent="0" marL="0">
+            <a:pPr marL="0" indent="0" algn="ctr">
               <a:buNone/>
             </a:pPr>
             <a:r>
@@ -1376,7 +1165,7 @@
           <a:bodyPr wrap="square" lIns="0" tIns="0" rIns="0" bIns="0" rtlCol="0" anchor="t"/>
           <a:lstStyle/>
           <a:p>
-            <a:pPr algn="ctr" indent="0" marL="0">
+            <a:pPr marL="0" indent="0" algn="ctr">
               <a:buNone/>
             </a:pPr>
             <a:r>
@@ -1415,7 +1204,7 @@
           <a:bodyPr wrap="square" lIns="0" tIns="0" rIns="0" bIns="0" rtlCol="0" anchor="t"/>
           <a:lstStyle/>
           <a:p>
-            <a:pPr algn="ctr" indent="0" marL="0">
+            <a:pPr marL="0" indent="0" algn="ctr">
               <a:lnSpc>
                 <a:spcPts val="2800"/>
               </a:lnSpc>
@@ -1457,7 +1246,7 @@
           <a:bodyPr wrap="square" lIns="0" tIns="0" rIns="0" bIns="0" rtlCol="0" anchor="t"/>
           <a:lstStyle/>
           <a:p>
-            <a:pPr indent="0" marL="0">
+            <a:pPr marL="0" indent="0">
               <a:lnSpc>
                 <a:spcPts val="1400"/>
               </a:lnSpc>
@@ -1499,7 +1288,7 @@
           <a:bodyPr wrap="square" lIns="0" tIns="0" rIns="0" bIns="0" rtlCol="0" anchor="t"/>
           <a:lstStyle/>
           <a:p>
-            <a:pPr algn="r" indent="0" marL="0">
+            <a:pPr marL="0" indent="0" algn="r">
               <a:buNone/>
             </a:pPr>
             <a:r>
@@ -1533,6 +1322,7 @@
         <a:solidFill>
           <a:srgbClr val="F6F2E8"/>
         </a:solidFill>
+        <a:effectLst/>
       </p:bgPr>
     </p:bg>
     <p:spTree>
@@ -1570,11 +1360,11 @@
           <a:bodyPr wrap="square" lIns="0" tIns="0" rIns="0" bIns="0" rtlCol="0" anchor="t"/>
           <a:lstStyle/>
           <a:p>
-            <a:pPr indent="0" marL="0">
+            <a:pPr marL="0" indent="0">
               <a:buNone/>
             </a:pPr>
             <a:r>
-              <a:rPr lang="en-US" sz="1100" b="1" spc="220" kern="0" dirty="0">
+              <a:rPr lang="en-US" sz="1100" b="1" kern="0" spc="220" dirty="0">
                 <a:solidFill>
                   <a:srgbClr val="5C564C"/>
                 </a:solidFill>
@@ -1609,7 +1399,7 @@
           <a:bodyPr wrap="square" lIns="0" tIns="0" rIns="0" bIns="0" rtlCol="0" anchor="t"/>
           <a:lstStyle/>
           <a:p>
-            <a:pPr indent="0" marL="0">
+            <a:pPr marL="0" indent="0">
               <a:buNone/>
             </a:pPr>
             <a:r>
@@ -1648,7 +1438,7 @@
           <a:bodyPr wrap="square" lIns="0" tIns="0" rIns="0" bIns="0" rtlCol="0" anchor="t"/>
           <a:lstStyle/>
           <a:p>
-            <a:pPr indent="0" marL="0">
+            <a:pPr marL="0" indent="0">
               <a:lnSpc>
                 <a:spcPts val="2400"/>
               </a:lnSpc>
@@ -1665,12 +1455,6 @@
               </a:rPr>
               <a:t>Only </a:t>
             </a:r>
-            <a:pPr indent="0" marL="0">
-              <a:lnSpc>
-                <a:spcPts val="2400"/>
-              </a:lnSpc>
-              <a:buNone/>
-            </a:pPr>
             <a:r>
               <a:rPr lang="en-US" sz="1750" b="1" dirty="0">
                 <a:solidFill>
@@ -1682,12 +1466,6 @@
               </a:rPr>
               <a:t>5%</a:t>
             </a:r>
-            <a:pPr indent="0" marL="0">
-              <a:lnSpc>
-                <a:spcPts val="2400"/>
-              </a:lnSpc>
-              <a:buNone/>
-            </a:pPr>
             <a:r>
               <a:rPr lang="en-US" sz="1750" dirty="0">
                 <a:solidFill>
@@ -1699,12 +1477,6 @@
               </a:rPr>
               <a:t> trust it enough to inform a deal decision, and </a:t>
             </a:r>
-            <a:pPr indent="0" marL="0">
-              <a:lnSpc>
-                <a:spcPts val="2400"/>
-              </a:lnSpc>
-              <a:buNone/>
-            </a:pPr>
             <a:r>
               <a:rPr lang="en-US" sz="1750" b="1" dirty="0">
                 <a:solidFill>
@@ -1716,12 +1488,6 @@
               </a:rPr>
               <a:t>32%</a:t>
             </a:r>
-            <a:pPr indent="0" marL="0">
-              <a:lnSpc>
-                <a:spcPts val="2400"/>
-              </a:lnSpc>
-              <a:buNone/>
-            </a:pPr>
             <a:r>
               <a:rPr lang="en-US" sz="1750" dirty="0">
                 <a:solidFill>
@@ -1758,7 +1524,7 @@
           <a:bodyPr wrap="square" lIns="0" tIns="0" rIns="0" bIns="0" rtlCol="0" anchor="t"/>
           <a:lstStyle/>
           <a:p>
-            <a:pPr indent="0" marL="0">
+            <a:pPr marL="0" indent="0">
               <a:buNone/>
             </a:pPr>
             <a:r>
@@ -1795,6 +1561,13 @@
           </a:solidFill>
           <a:ln/>
         </p:spPr>
+        <p:txBody>
+          <a:bodyPr/>
+          <a:lstStyle/>
+          <a:p>
+            <a:endParaRPr lang="en-US"/>
+          </a:p>
+        </p:txBody>
       </p:sp>
       <p:sp>
         <p:nvSpPr>
@@ -1817,7 +1590,7 @@
           <a:bodyPr wrap="square" lIns="0" tIns="0" rIns="0" bIns="0" rtlCol="0" anchor="t"/>
           <a:lstStyle/>
           <a:p>
-            <a:pPr indent="0" marL="0">
+            <a:pPr marL="0" indent="0" algn="just">
               <a:lnSpc>
                 <a:spcPts val="2000"/>
               </a:lnSpc>
@@ -1834,12 +1607,6 @@
               </a:rPr>
               <a:t>General-purpose AI replies with whatever it retrieves from the web and whatever it was trained on. It might </a:t>
             </a:r>
-            <a:pPr indent="0" marL="0">
-              <a:lnSpc>
-                <a:spcPts val="2000"/>
-              </a:lnSpc>
-              <a:buNone/>
-            </a:pPr>
             <a:r>
               <a:rPr lang="en-US" sz="1500" b="1" dirty="0">
                 <a:solidFill>
@@ -1851,12 +1618,6 @@
               </a:rPr>
               <a:t>hallucinate</a:t>
             </a:r>
-            <a:pPr indent="0" marL="0">
-              <a:lnSpc>
-                <a:spcPts val="2000"/>
-              </a:lnSpc>
-              <a:buNone/>
-            </a:pPr>
             <a:r>
               <a:rPr lang="en-US" sz="1500" dirty="0">
                 <a:solidFill>
@@ -1891,6 +1652,13 @@
           </a:solidFill>
           <a:ln/>
         </p:spPr>
+        <p:txBody>
+          <a:bodyPr/>
+          <a:lstStyle/>
+          <a:p>
+            <a:endParaRPr lang="en-US"/>
+          </a:p>
+        </p:txBody>
       </p:sp>
       <p:sp>
         <p:nvSpPr>
@@ -1911,6 +1679,14 @@
           </a:solidFill>
           <a:ln/>
         </p:spPr>
+        <p:txBody>
+          <a:bodyPr/>
+          <a:lstStyle/>
+          <a:p>
+            <a:pPr algn="just"/>
+            <a:endParaRPr lang="en-US"/>
+          </a:p>
+        </p:txBody>
       </p:sp>
       <p:sp>
         <p:nvSpPr>
@@ -1933,7 +1709,7 @@
           <a:bodyPr wrap="square" lIns="0" tIns="0" rIns="0" bIns="0" rtlCol="0" anchor="t"/>
           <a:lstStyle/>
           <a:p>
-            <a:pPr indent="0" marL="0">
+            <a:pPr marL="0" indent="0">
               <a:lnSpc>
                 <a:spcPts val="2000"/>
               </a:lnSpc>
@@ -1950,12 +1726,6 @@
               </a:rPr>
               <a:t>So the analyst drills back down to the source anyway: the geography, blueprints, lease terms, floor plans, and the reversion maths by hand. </a:t>
             </a:r>
-            <a:pPr indent="0" marL="0">
-              <a:lnSpc>
-                <a:spcPts val="2000"/>
-              </a:lnSpc>
-              <a:buNone/>
-            </a:pPr>
             <a:r>
               <a:rPr lang="en-US" sz="1500" b="1" dirty="0">
                 <a:solidFill>
@@ -1973,14 +1743,14 @@
       </p:sp>
       <p:pic>
         <p:nvPicPr>
-          <p:cNvPr id="11" name="Image 0" descr="/Users/ethanlee/Desktop/projects/cre_market_agent/slides/assets/problem-chatgpt-arithmetic.jpg">    </p:cNvPr>
+          <p:cNvPr id="11" name="Image 0" descr="/Users/ethanlee/Desktop/projects/cre_market_agent/slides/assets/problem-chatgpt-arithmetic.jpg"/>
           <p:cNvPicPr>
             <a:picLocks noChangeAspect="1"/>
           </p:cNvPicPr>
           <p:nvPr/>
         </p:nvPicPr>
         <p:blipFill>
-          <a:blip r:embed="rId1"/>
+          <a:blip r:embed="rId3"/>
           <a:stretch>
             <a:fillRect/>
           </a:stretch>
@@ -1997,14 +1767,14 @@
       </p:pic>
       <p:pic>
         <p:nvPicPr>
-          <p:cNvPr id="12" name="Image 1" descr="/Users/ethanlee/Desktop/projects/cre_market_agent/slides/assets/problem-claude-misalignment.png">    </p:cNvPr>
+          <p:cNvPr id="12" name="Image 1" descr="/Users/ethanlee/Desktop/projects/cre_market_agent/slides/assets/problem-claude-misalignment.png"/>
           <p:cNvPicPr>
             <a:picLocks noChangeAspect="1"/>
           </p:cNvPicPr>
           <p:nvPr/>
         </p:nvPicPr>
         <p:blipFill>
-          <a:blip r:embed="rId2"/>
+          <a:blip r:embed="rId4"/>
           <a:stretch>
             <a:fillRect/>
           </a:stretch>
@@ -2040,7 +1810,7 @@
           <a:bodyPr wrap="square" lIns="0" tIns="0" rIns="0" bIns="0" rtlCol="0" anchor="t"/>
           <a:lstStyle/>
           <a:p>
-            <a:pPr algn="ctr" indent="0" marL="0">
+            <a:pPr marL="0" indent="0" algn="ctr">
               <a:lnSpc>
                 <a:spcPts val="1350"/>
               </a:lnSpc>
@@ -2080,6 +1850,13 @@
           </a:solidFill>
           <a:ln/>
         </p:spPr>
+        <p:txBody>
+          <a:bodyPr/>
+          <a:lstStyle/>
+          <a:p>
+            <a:endParaRPr lang="en-US"/>
+          </a:p>
+        </p:txBody>
       </p:sp>
       <p:sp>
         <p:nvSpPr>
@@ -2102,7 +1879,7 @@
           <a:bodyPr wrap="square" lIns="0" tIns="0" rIns="0" bIns="0" rtlCol="0" anchor="ctr"/>
           <a:lstStyle/>
           <a:p>
-            <a:pPr indent="0" marL="0">
+            <a:pPr marL="0" indent="0" algn="just">
               <a:lnSpc>
                 <a:spcPts val="2000"/>
               </a:lnSpc>
@@ -2119,12 +1896,6 @@
               </a:rPr>
               <a:t>The solution is to bridge the trust gap by grounding AI with credible information and robust agentic tools  →  </a:t>
             </a:r>
-            <a:pPr indent="0" marL="0">
-              <a:lnSpc>
-                <a:spcPts val="2000"/>
-              </a:lnSpc>
-              <a:buNone/>
-            </a:pPr>
             <a:r>
               <a:rPr lang="en-US" sz="1450" b="1" dirty="0">
                 <a:solidFill>
@@ -2156,6 +1927,7 @@
         <a:solidFill>
           <a:srgbClr val="F6F2E8"/>
         </a:solidFill>
+        <a:effectLst/>
       </p:bgPr>
     </p:bg>
     <p:spTree>
@@ -2193,11 +1965,11 @@
           <a:bodyPr wrap="square" lIns="0" tIns="0" rIns="0" bIns="0" rtlCol="0" anchor="t"/>
           <a:lstStyle/>
           <a:p>
-            <a:pPr indent="0" marL="0">
+            <a:pPr marL="0" indent="0">
               <a:buNone/>
             </a:pPr>
             <a:r>
-              <a:rPr lang="en-US" sz="1100" b="1" spc="220" kern="0" dirty="0">
+              <a:rPr lang="en-US" sz="1100" b="1" kern="0" spc="220" dirty="0">
                 <a:solidFill>
                   <a:srgbClr val="5C564C"/>
                 </a:solidFill>
@@ -2232,7 +2004,7 @@
           <a:bodyPr wrap="square" lIns="0" tIns="0" rIns="0" bIns="0" rtlCol="0" anchor="t"/>
           <a:lstStyle/>
           <a:p>
-            <a:pPr indent="0" marL="0">
+            <a:pPr marL="0" indent="0">
               <a:buNone/>
             </a:pPr>
             <a:r>
@@ -2244,7 +2016,7 @@
                 <a:ea typeface="Cambria" pitchFamily="34" charset="-122"/>
                 <a:cs typeface="Cambria" pitchFamily="34" charset="-120"/>
               </a:rPr>
-              <a:t>Fast, sourced, and about your buildings</a:t>
+              <a:t>Rapid, reliable, and relevant</a:t>
             </a:r>
             <a:endParaRPr lang="en-US" sz="3400" dirty="0"/>
           </a:p>
@@ -2259,24 +2031,48 @@
           <p:nvPr>
             <p:extLst>
               <p:ext uri="{D42A27DB-BD31-4B8C-83A1-F6EECF244321}">
-                <p14:modId xmlns:p14="http://schemas.microsoft.com/office/powerpoint/2010/main" val="1579011935"/>
+                <p14:modId xmlns:p14="http://schemas.microsoft.com/office/powerpoint/2010/main" val="1137474753"/>
               </p:ext>
             </p:extLst>
           </p:nvPr>
         </p:nvGraphicFramePr>
         <p:xfrm>
           <a:off x="640080" y="1783080"/>
-          <a:ext cx="10911535" cy="914400"/>
+          <a:ext cx="10908792" cy="3913632"/>
         </p:xfrm>
         <a:graphic>
           <a:graphicData uri="http://schemas.openxmlformats.org/drawingml/2006/table">
             <a:tbl>
               <a:tblPr/>
               <a:tblGrid>
-                <a:gridCol w="2615184"/>
-                <a:gridCol w="2688336"/>
-                <a:gridCol w="2688336"/>
-                <a:gridCol w="2916936"/>
+                <a:gridCol w="2615184">
+                  <a:extLst>
+                    <a:ext uri="{9D8B030D-6E8A-4147-A177-3AD203B41FA5}">
+                      <a16:colId xmlns:a16="http://schemas.microsoft.com/office/drawing/2014/main" val="20000"/>
+                    </a:ext>
+                  </a:extLst>
+                </a:gridCol>
+                <a:gridCol w="2688336">
+                  <a:extLst>
+                    <a:ext uri="{9D8B030D-6E8A-4147-A177-3AD203B41FA5}">
+                      <a16:colId xmlns:a16="http://schemas.microsoft.com/office/drawing/2014/main" val="20001"/>
+                    </a:ext>
+                  </a:extLst>
+                </a:gridCol>
+                <a:gridCol w="2688336">
+                  <a:extLst>
+                    <a:ext uri="{9D8B030D-6E8A-4147-A177-3AD203B41FA5}">
+                      <a16:colId xmlns:a16="http://schemas.microsoft.com/office/drawing/2014/main" val="20002"/>
+                    </a:ext>
+                  </a:extLst>
+                </a:gridCol>
+                <a:gridCol w="2916936">
+                  <a:extLst>
+                    <a:ext uri="{9D8B030D-6E8A-4147-A177-3AD203B41FA5}">
+                      <a16:colId xmlns:a16="http://schemas.microsoft.com/office/drawing/2014/main" val="20003"/>
+                    </a:ext>
+                  </a:extLst>
+                </a:gridCol>
               </a:tblGrid>
               <a:tr h="621792">
                 <a:tc>
@@ -2284,17 +2080,17 @@
                     <a:bodyPr/>
                     <a:lstStyle/>
                     <a:p>
-                      <a:pPr indent="0" marL="0">
+                      <a:pPr marL="0" indent="0">
                         <a:buNone/>
                       </a:pPr>
-                      <a:endParaRPr lang="en-US" sz="1300" dirty="0">
+                      <a:endParaRPr lang="en-US" sz="1400" dirty="0">
                         <a:latin typeface="Calibri" charset="0"/>
                         <a:ea typeface="Calibri" charset="0"/>
                         <a:cs typeface="Calibri" charset="0"/>
                       </a:endParaRPr>
                     </a:p>
                   </a:txBody>
-                  <a:tcPr marL="101600" marR="101600" marT="203200" marB="203200" anchor="ctr">
+                  <a:tcPr marL="127000" marR="127000" marT="177800" marB="177800" anchor="ctr">
                     <a:lnL w="0" cap="flat" cmpd="sng" algn="ctr">
                       <a:noFill/>
                     </a:lnL>
@@ -2323,11 +2119,11 @@
                     <a:bodyPr/>
                     <a:lstStyle/>
                     <a:p>
-                      <a:pPr indent="0" marL="0">
+                      <a:pPr marL="0" indent="0">
                         <a:buNone/>
                       </a:pPr>
                       <a:r>
-                        <a:rPr lang="en-US" sz="1300" b="1" dirty="0">
+                        <a:rPr lang="en-US" sz="1400" b="1" dirty="0">
                           <a:solidFill>
                             <a:srgbClr val="F7F4EC"/>
                           </a:solidFill>
@@ -2337,18 +2133,18 @@
                         </a:rPr>
                         <a:t>Published research</a:t>
                       </a:r>
-                      <a:endParaRPr lang="en-US" sz="1300" dirty="0">
+                      <a:endParaRPr lang="en-US" sz="1400" dirty="0">
                         <a:latin typeface="Calibri" charset="0"/>
                         <a:ea typeface="Calibri" charset="0"/>
                         <a:cs typeface="Calibri" charset="0"/>
                       </a:endParaRPr>
                     </a:p>
                     <a:p>
-                      <a:pPr indent="0" marL="0">
+                      <a:pPr marL="0" indent="0">
                         <a:buNone/>
                       </a:pPr>
                       <a:r>
-                        <a:rPr lang="en-US" sz="950" i="1" dirty="0">
+                        <a:rPr lang="en-US" sz="1000" i="1" dirty="0">
                           <a:solidFill>
                             <a:srgbClr val="BDB6A6"/>
                           </a:solidFill>
@@ -2358,7 +2154,7 @@
                         </a:rPr>
                         <a:t>Savills · CBRE · CoStar</a:t>
                       </a:r>
-                      <a:endParaRPr lang="en-US" sz="1300" dirty="0">
+                      <a:endParaRPr lang="en-US" sz="1400" dirty="0">
                         <a:latin typeface="Calibri" charset="0"/>
                         <a:ea typeface="Calibri" charset="0"/>
                         <a:cs typeface="Calibri" charset="0"/>
@@ -2400,11 +2196,11 @@
                     <a:bodyPr/>
                     <a:lstStyle/>
                     <a:p>
-                      <a:pPr indent="0" marL="0">
+                      <a:pPr marL="0" indent="0">
                         <a:buNone/>
                       </a:pPr>
                       <a:r>
-                        <a:rPr lang="en-US" sz="1300" b="1" dirty="0">
+                        <a:rPr lang="en-US" sz="1400" b="1" dirty="0">
                           <a:solidFill>
                             <a:srgbClr val="F7F4EC"/>
                           </a:solidFill>
@@ -2414,18 +2210,18 @@
                         </a:rPr>
                         <a:t>General-purpose AI</a:t>
                       </a:r>
-                      <a:endParaRPr lang="en-US" sz="1300" dirty="0">
+                      <a:endParaRPr lang="en-US" sz="1400" dirty="0">
                         <a:latin typeface="Calibri" charset="0"/>
                         <a:ea typeface="Calibri" charset="0"/>
                         <a:cs typeface="Calibri" charset="0"/>
                       </a:endParaRPr>
                     </a:p>
                     <a:p>
-                      <a:pPr indent="0" marL="0">
+                      <a:pPr marL="0" indent="0">
                         <a:buNone/>
                       </a:pPr>
                       <a:r>
-                        <a:rPr lang="en-US" sz="950" i="1" dirty="0">
+                        <a:rPr lang="en-US" sz="1000" i="1" dirty="0">
                           <a:solidFill>
                             <a:srgbClr val="BDB6A6"/>
                           </a:solidFill>
@@ -2435,7 +2231,7 @@
                         </a:rPr>
                         <a:t>ChatGPT · Gemini · Claude</a:t>
                       </a:r>
-                      <a:endParaRPr lang="en-US" sz="1300" dirty="0">
+                      <a:endParaRPr lang="en-US" sz="1400" dirty="0">
                         <a:latin typeface="Calibri" charset="0"/>
                         <a:ea typeface="Calibri" charset="0"/>
                         <a:cs typeface="Calibri" charset="0"/>
@@ -2477,11 +2273,11 @@
                     <a:bodyPr/>
                     <a:lstStyle/>
                     <a:p>
-                      <a:pPr indent="0" marL="0">
+                      <a:pPr marL="0" indent="0">
                         <a:buNone/>
                       </a:pPr>
                       <a:r>
-                        <a:rPr lang="en-US" sz="1300" b="1" dirty="0">
+                        <a:rPr lang="en-US" sz="1400" b="1" dirty="0">
                           <a:solidFill>
                             <a:srgbClr val="F7F4EC"/>
                           </a:solidFill>
@@ -2491,18 +2287,18 @@
                         </a:rPr>
                         <a:t>This system</a:t>
                       </a:r>
-                      <a:endParaRPr lang="en-US" sz="1300" dirty="0">
+                      <a:endParaRPr lang="en-US" sz="1400" dirty="0">
                         <a:latin typeface="Calibri" charset="0"/>
                         <a:ea typeface="Calibri" charset="0"/>
                         <a:cs typeface="Calibri" charset="0"/>
                       </a:endParaRPr>
                     </a:p>
                     <a:p>
-                      <a:pPr indent="0" marL="0">
+                      <a:pPr marL="0" indent="0">
                         <a:buNone/>
                       </a:pPr>
                       <a:r>
-                        <a:rPr lang="en-US" sz="950" i="1" dirty="0">
+                        <a:rPr lang="en-US" sz="1000" i="1" dirty="0">
                           <a:solidFill>
                             <a:srgbClr val="BDB6A6"/>
                           </a:solidFill>
@@ -2512,7 +2308,7 @@
                         </a:rPr>
                         <a:t>Deterministic spine, agentic edges</a:t>
                       </a:r>
-                      <a:endParaRPr lang="en-US" sz="1300" dirty="0">
+                      <a:endParaRPr lang="en-US" sz="1400" dirty="0">
                         <a:latin typeface="Calibri" charset="0"/>
                         <a:ea typeface="Calibri" charset="0"/>
                         <a:cs typeface="Calibri" charset="0"/>
@@ -2549,18 +2345,23 @@
                     </a:solidFill>
                   </a:tcPr>
                 </a:tc>
+                <a:extLst>
+                  <a:ext uri="{0D108BD9-81ED-4DB2-BD59-A6C34878D82A}">
+                    <a16:rowId xmlns:a16="http://schemas.microsoft.com/office/drawing/2014/main" val="10000"/>
+                  </a:ext>
+                </a:extLst>
               </a:tr>
-              <a:tr h="658368">
+              <a:tr h="822960">
                 <a:tc>
                   <a:txBody>
                     <a:bodyPr/>
                     <a:lstStyle/>
                     <a:p>
-                      <a:pPr indent="0" marL="0">
+                      <a:pPr marL="0" indent="0">
                         <a:buNone/>
                       </a:pPr>
                       <a:r>
-                        <a:rPr lang="en-US" sz="1300" b="1" dirty="0">
+                        <a:rPr lang="en-US" sz="1600" b="1" dirty="0">
                           <a:solidFill>
                             <a:srgbClr val="141414"/>
                           </a:solidFill>
@@ -2568,16 +2369,16 @@
                           <a:ea typeface="Calibri" pitchFamily="34" charset="-122"/>
                           <a:cs typeface="Calibri" pitchFamily="34" charset="-120"/>
                         </a:rPr>
-                        <a:t>Time to an answer</a:t>
+                        <a:t>Efficiency</a:t>
                       </a:r>
-                      <a:endParaRPr lang="en-US" sz="1300" dirty="0">
+                      <a:endParaRPr lang="en-US" sz="1600" dirty="0">
                         <a:latin typeface="Calibri" charset="0"/>
                         <a:ea typeface="Calibri" charset="0"/>
                         <a:cs typeface="Calibri" charset="0"/>
                       </a:endParaRPr>
                     </a:p>
                   </a:txBody>
-                  <a:tcPr marL="101600" marR="101600" marT="203200" marB="203200" anchor="ctr">
+                  <a:tcPr marL="127000" marR="127000" marT="177800" marB="177800" anchor="ctr">
                     <a:lnL w="0" cap="flat" cmpd="sng" algn="ctr">
                       <a:noFill/>
                     </a:lnL>
@@ -2612,28 +2413,49 @@
                     <a:bodyPr/>
                     <a:lstStyle/>
                     <a:p>
-                      <a:pPr indent="0" marL="0">
+                      <a:pPr marL="0" indent="0">
                         <a:buNone/>
                       </a:pPr>
                       <a:r>
-                        <a:rPr lang="en-US" sz="1300" dirty="0">
+                        <a:rPr lang="en-US" sz="1600" b="1" dirty="0">
                           <a:solidFill>
-                            <a:srgbClr val="9B2C2C"/>
+                            <a:srgbClr val="8A5E15"/>
                           </a:solidFill>
                           <a:latin typeface="Calibri" pitchFamily="34" charset="0"/>
                           <a:ea typeface="Calibri" pitchFamily="34" charset="-122"/>
                           <a:cs typeface="Calibri" pitchFamily="34" charset="-120"/>
                         </a:rPr>
-                        <a:t>Days</a:t>
+                        <a:t>Low</a:t>
                       </a:r>
-                      <a:endParaRPr lang="en-US" sz="1300" dirty="0">
+                      <a:endParaRPr lang="en-US" sz="1400" dirty="0">
+                        <a:latin typeface="Calibri" charset="0"/>
+                        <a:ea typeface="Calibri" charset="0"/>
+                        <a:cs typeface="Calibri" charset="0"/>
+                      </a:endParaRPr>
+                    </a:p>
+                    <a:p>
+                      <a:pPr marL="0" indent="0">
+                        <a:buNone/>
+                      </a:pPr>
+                      <a:r>
+                        <a:rPr lang="en-US" sz="1200" dirty="0">
+                          <a:solidFill>
+                            <a:srgbClr val="5C564C"/>
+                          </a:solidFill>
+                          <a:latin typeface="Calibri" pitchFamily="34" charset="0"/>
+                          <a:ea typeface="Calibri" pitchFamily="34" charset="-122"/>
+                          <a:cs typeface="Calibri" pitchFamily="34" charset="-120"/>
+                        </a:rPr>
+                        <a:t>You consolidate and analyse it yourself</a:t>
+                      </a:r>
+                      <a:endParaRPr lang="en-US" sz="1400" dirty="0">
                         <a:latin typeface="Calibri" charset="0"/>
                         <a:ea typeface="Calibri" charset="0"/>
                         <a:cs typeface="Calibri" charset="0"/>
                       </a:endParaRPr>
                     </a:p>
                   </a:txBody>
-                  <a:tcPr marL="101600" marR="101600" marT="203200" marB="203200" anchor="ctr">
+                  <a:tcPr marL="127000" marR="127000" marT="177800" marB="177800" anchor="ctr">
                     <a:lnL w="0" cap="flat" cmpd="sng" algn="ctr">
                       <a:noFill/>
                     </a:lnL>
@@ -2665,28 +2487,49 @@
                     <a:bodyPr/>
                     <a:lstStyle/>
                     <a:p>
-                      <a:pPr indent="0" marL="0">
+                      <a:pPr marL="0" indent="0">
                         <a:buNone/>
                       </a:pPr>
                       <a:r>
-                        <a:rPr lang="en-US" sz="1300" dirty="0">
+                        <a:rPr lang="en-US" sz="1600" b="1" dirty="0">
                           <a:solidFill>
-                            <a:srgbClr val="3C6444"/>
+                            <a:srgbClr val="8A5E15"/>
                           </a:solidFill>
                           <a:latin typeface="Calibri" pitchFamily="34" charset="0"/>
                           <a:ea typeface="Calibri" pitchFamily="34" charset="-122"/>
                           <a:cs typeface="Calibri" pitchFamily="34" charset="-120"/>
                         </a:rPr>
-                        <a:t>Seconds</a:t>
+                        <a:t>Low</a:t>
                       </a:r>
-                      <a:endParaRPr lang="en-US" sz="1300" dirty="0">
+                      <a:endParaRPr lang="en-US" sz="1400" dirty="0">
+                        <a:latin typeface="Calibri" charset="0"/>
+                        <a:ea typeface="Calibri" charset="0"/>
+                        <a:cs typeface="Calibri" charset="0"/>
+                      </a:endParaRPr>
+                    </a:p>
+                    <a:p>
+                      <a:pPr marL="0" indent="0">
+                        <a:buNone/>
+                      </a:pPr>
+                      <a:r>
+                        <a:rPr lang="en-US" sz="1200" dirty="0">
+                          <a:solidFill>
+                            <a:srgbClr val="5C564C"/>
+                          </a:solidFill>
+                          <a:latin typeface="Calibri" pitchFamily="34" charset="0"/>
+                          <a:ea typeface="Calibri" pitchFamily="34" charset="-122"/>
+                          <a:cs typeface="Calibri" pitchFamily="34" charset="-120"/>
+                        </a:rPr>
+                        <a:t>You verify everything before you use it</a:t>
+                      </a:r>
+                      <a:endParaRPr lang="en-US" sz="1400" dirty="0">
                         <a:latin typeface="Calibri" charset="0"/>
                         <a:ea typeface="Calibri" charset="0"/>
                         <a:cs typeface="Calibri" charset="0"/>
                       </a:endParaRPr>
                     </a:p>
                   </a:txBody>
-                  <a:tcPr marL="101600" marR="101600" marT="203200" marB="203200" anchor="ctr">
+                  <a:tcPr marL="127000" marR="127000" marT="177800" marB="177800" anchor="ctr">
                     <a:lnL w="0" cap="flat" cmpd="sng" algn="ctr">
                       <a:noFill/>
                     </a:lnL>
@@ -2718,11 +2561,11 @@
                     <a:bodyPr/>
                     <a:lstStyle/>
                     <a:p>
-                      <a:pPr indent="0" marL="0">
+                      <a:pPr marL="0" indent="0">
                         <a:buNone/>
                       </a:pPr>
                       <a:r>
-                        <a:rPr lang="en-US" sz="1300" dirty="0">
+                        <a:rPr lang="en-US" sz="1600" b="1" dirty="0">
                           <a:solidFill>
                             <a:srgbClr val="3C6444"/>
                           </a:solidFill>
@@ -2730,16 +2573,37 @@
                           <a:ea typeface="Calibri" pitchFamily="34" charset="-122"/>
                           <a:cs typeface="Calibri" pitchFamily="34" charset="-120"/>
                         </a:rPr>
-                        <a:t>Seconds</a:t>
+                        <a:t>High</a:t>
                       </a:r>
-                      <a:endParaRPr lang="en-US" sz="1300" dirty="0">
+                      <a:endParaRPr lang="en-US" sz="1400" dirty="0">
+                        <a:latin typeface="Calibri" charset="0"/>
+                        <a:ea typeface="Calibri" charset="0"/>
+                        <a:cs typeface="Calibri" charset="0"/>
+                      </a:endParaRPr>
+                    </a:p>
+                    <a:p>
+                      <a:pPr marL="0" indent="0">
+                        <a:buNone/>
+                      </a:pPr>
+                      <a:r>
+                        <a:rPr lang="en-US" sz="1200" dirty="0">
+                          <a:solidFill>
+                            <a:srgbClr val="5C564C"/>
+                          </a:solidFill>
+                          <a:latin typeface="Calibri" pitchFamily="34" charset="0"/>
+                          <a:ea typeface="Calibri" pitchFamily="34" charset="-122"/>
+                          <a:cs typeface="Calibri" pitchFamily="34" charset="-120"/>
+                        </a:rPr>
+                        <a:t>Insight from credible sources in seconds</a:t>
+                      </a:r>
+                      <a:endParaRPr lang="en-US" sz="1400" dirty="0">
                         <a:latin typeface="Calibri" charset="0"/>
                         <a:ea typeface="Calibri" charset="0"/>
                         <a:cs typeface="Calibri" charset="0"/>
                       </a:endParaRPr>
                     </a:p>
                   </a:txBody>
-                  <a:tcPr marL="101600" marR="101600" marT="203200" marB="203200" anchor="ctr">
+                  <a:tcPr marL="127000" marR="127000" marT="177800" marB="177800" anchor="ctr">
                     <a:lnL w="0" cap="flat" cmpd="sng" algn="ctr">
                       <a:noFill/>
                     </a:lnL>
@@ -2769,18 +2633,23 @@
                     </a:solidFill>
                   </a:tcPr>
                 </a:tc>
+                <a:extLst>
+                  <a:ext uri="{0D108BD9-81ED-4DB2-BD59-A6C34878D82A}">
+                    <a16:rowId xmlns:a16="http://schemas.microsoft.com/office/drawing/2014/main" val="10001"/>
+                  </a:ext>
+                </a:extLst>
               </a:tr>
-              <a:tr h="658368">
+              <a:tr h="822960">
                 <a:tc>
                   <a:txBody>
                     <a:bodyPr/>
                     <a:lstStyle/>
                     <a:p>
-                      <a:pPr indent="0" marL="0">
+                      <a:pPr marL="0" indent="0">
                         <a:buNone/>
                       </a:pPr>
                       <a:r>
-                        <a:rPr lang="en-US" sz="1300" b="1" dirty="0">
+                        <a:rPr lang="en-US" sz="1600" b="1" dirty="0">
                           <a:solidFill>
                             <a:srgbClr val="141414"/>
                           </a:solidFill>
@@ -2788,16 +2657,16 @@
                           <a:ea typeface="Calibri" pitchFamily="34" charset="-122"/>
                           <a:cs typeface="Calibri" pitchFamily="34" charset="-120"/>
                         </a:rPr>
-                        <a:t>Every figure sourced</a:t>
+                        <a:t>Know your portfolio</a:t>
                       </a:r>
-                      <a:endParaRPr lang="en-US" sz="1300" dirty="0">
+                      <a:endParaRPr lang="en-US" sz="1600" dirty="0">
                         <a:latin typeface="Calibri" charset="0"/>
                         <a:ea typeface="Calibri" charset="0"/>
                         <a:cs typeface="Calibri" charset="0"/>
                       </a:endParaRPr>
                     </a:p>
                   </a:txBody>
-                  <a:tcPr marL="101600" marR="101600" marT="203200" marB="203200" anchor="ctr">
+                  <a:tcPr marL="127000" marR="127000" marT="177800" marB="177800" anchor="ctr">
                     <a:lnL w="0" cap="flat" cmpd="sng" algn="ctr">
                       <a:noFill/>
                     </a:lnL>
@@ -2832,28 +2701,49 @@
                     <a:bodyPr/>
                     <a:lstStyle/>
                     <a:p>
-                      <a:pPr indent="0" marL="0">
+                      <a:pPr marL="0" indent="0">
                         <a:buNone/>
                       </a:pPr>
                       <a:r>
-                        <a:rPr lang="en-US" sz="1300" dirty="0">
+                        <a:rPr lang="en-US" sz="1600" b="1" dirty="0">
                           <a:solidFill>
-                            <a:srgbClr val="3C6444"/>
+                            <a:srgbClr val="9B2C2C"/>
                           </a:solidFill>
                           <a:latin typeface="Calibri" pitchFamily="34" charset="0"/>
                           <a:ea typeface="Calibri" pitchFamily="34" charset="-122"/>
                           <a:cs typeface="Calibri" pitchFamily="34" charset="-120"/>
                         </a:rPr>
-                        <a:t>Yes, fully cited</a:t>
+                        <a:t>No</a:t>
                       </a:r>
-                      <a:endParaRPr lang="en-US" sz="1300" dirty="0">
+                      <a:endParaRPr lang="en-US" sz="1400" dirty="0">
+                        <a:latin typeface="Calibri" charset="0"/>
+                        <a:ea typeface="Calibri" charset="0"/>
+                        <a:cs typeface="Calibri" charset="0"/>
+                      </a:endParaRPr>
+                    </a:p>
+                    <a:p>
+                      <a:pPr marL="0" indent="0">
+                        <a:buNone/>
+                      </a:pPr>
+                      <a:r>
+                        <a:rPr lang="en-US" sz="1200" dirty="0">
+                          <a:solidFill>
+                            <a:srgbClr val="5C564C"/>
+                          </a:solidFill>
+                          <a:latin typeface="Calibri" pitchFamily="34" charset="0"/>
+                          <a:ea typeface="Calibri" pitchFamily="34" charset="-122"/>
+                          <a:cs typeface="Calibri" pitchFamily="34" charset="-120"/>
+                        </a:rPr>
+                        <a:t>Market-wide data only</a:t>
+                      </a:r>
+                      <a:endParaRPr lang="en-US" sz="1400" dirty="0">
                         <a:latin typeface="Calibri" charset="0"/>
                         <a:ea typeface="Calibri" charset="0"/>
                         <a:cs typeface="Calibri" charset="0"/>
                       </a:endParaRPr>
                     </a:p>
                   </a:txBody>
-                  <a:tcPr marL="101600" marR="101600" marT="203200" marB="203200" anchor="ctr">
+                  <a:tcPr marL="127000" marR="127000" marT="177800" marB="177800" anchor="ctr">
                     <a:lnL w="0" cap="flat" cmpd="sng" algn="ctr">
                       <a:noFill/>
                     </a:lnL>
@@ -2885,11 +2775,11 @@
                     <a:bodyPr/>
                     <a:lstStyle/>
                     <a:p>
-                      <a:pPr indent="0" marL="0">
+                      <a:pPr marL="0" indent="0">
                         <a:buNone/>
                       </a:pPr>
                       <a:r>
-                        <a:rPr lang="en-US" sz="1300" dirty="0">
+                        <a:rPr lang="en-US" sz="1600" b="1" dirty="0">
                           <a:solidFill>
                             <a:srgbClr val="9B2C2C"/>
                           </a:solidFill>
@@ -2897,16 +2787,37 @@
                           <a:ea typeface="Calibri" pitchFamily="34" charset="-122"/>
                           <a:cs typeface="Calibri" pitchFamily="34" charset="-120"/>
                         </a:rPr>
-                        <a:t>No, rarely attributed</a:t>
+                        <a:t>No</a:t>
                       </a:r>
-                      <a:endParaRPr lang="en-US" sz="1300" dirty="0">
+                      <a:endParaRPr lang="en-US" sz="1400" dirty="0">
+                        <a:latin typeface="Calibri" charset="0"/>
+                        <a:ea typeface="Calibri" charset="0"/>
+                        <a:cs typeface="Calibri" charset="0"/>
+                      </a:endParaRPr>
+                    </a:p>
+                    <a:p>
+                      <a:pPr marL="0" indent="0">
+                        <a:buNone/>
+                      </a:pPr>
+                      <a:r>
+                        <a:rPr lang="en-US" sz="1200" dirty="0">
+                          <a:solidFill>
+                            <a:srgbClr val="5C564C"/>
+                          </a:solidFill>
+                          <a:latin typeface="Calibri" pitchFamily="34" charset="0"/>
+                          <a:ea typeface="Calibri" pitchFamily="34" charset="-122"/>
+                          <a:cs typeface="Calibri" pitchFamily="34" charset="-120"/>
+                        </a:rPr>
+                        <a:t>Only what you paste in</a:t>
+                      </a:r>
+                      <a:endParaRPr lang="en-US" sz="1400" dirty="0">
                         <a:latin typeface="Calibri" charset="0"/>
                         <a:ea typeface="Calibri" charset="0"/>
                         <a:cs typeface="Calibri" charset="0"/>
                       </a:endParaRPr>
                     </a:p>
                   </a:txBody>
-                  <a:tcPr marL="101600" marR="101600" marT="203200" marB="203200" anchor="ctr">
+                  <a:tcPr marL="127000" marR="127000" marT="177800" marB="177800" anchor="ctr">
                     <a:lnL w="0" cap="flat" cmpd="sng" algn="ctr">
                       <a:noFill/>
                     </a:lnL>
@@ -2938,11 +2849,11 @@
                     <a:bodyPr/>
                     <a:lstStyle/>
                     <a:p>
-                      <a:pPr indent="0" marL="0">
+                      <a:pPr marL="0" indent="0">
                         <a:buNone/>
                       </a:pPr>
                       <a:r>
-                        <a:rPr lang="en-US" sz="1300" dirty="0">
+                        <a:rPr lang="en-US" sz="1600" b="1" dirty="0">
                           <a:solidFill>
                             <a:srgbClr val="3C6444"/>
                           </a:solidFill>
@@ -2950,16 +2861,37 @@
                           <a:ea typeface="Calibri" pitchFamily="34" charset="-122"/>
                           <a:cs typeface="Calibri" pitchFamily="34" charset="-120"/>
                         </a:rPr>
-                        <a:t>Yes, or it declines</a:t>
+                        <a:t>Yes</a:t>
                       </a:r>
-                      <a:endParaRPr lang="en-US" sz="1300" dirty="0">
+                      <a:endParaRPr lang="en-US" sz="1400" dirty="0">
+                        <a:latin typeface="Calibri" charset="0"/>
+                        <a:ea typeface="Calibri" charset="0"/>
+                        <a:cs typeface="Calibri" charset="0"/>
+                      </a:endParaRPr>
+                    </a:p>
+                    <a:p>
+                      <a:pPr marL="0" indent="0">
+                        <a:buNone/>
+                      </a:pPr>
+                      <a:r>
+                        <a:rPr lang="en-US" sz="1200" dirty="0">
+                          <a:solidFill>
+                            <a:srgbClr val="5C564C"/>
+                          </a:solidFill>
+                          <a:latin typeface="Calibri" pitchFamily="34" charset="0"/>
+                          <a:ea typeface="Calibri" pitchFamily="34" charset="-122"/>
+                          <a:cs typeface="Calibri" pitchFamily="34" charset="-120"/>
+                        </a:rPr>
+                        <a:t>Analysis matched to your holdings</a:t>
+                      </a:r>
+                      <a:endParaRPr lang="en-US" sz="1400" dirty="0">
                         <a:latin typeface="Calibri" charset="0"/>
                         <a:ea typeface="Calibri" charset="0"/>
                         <a:cs typeface="Calibri" charset="0"/>
                       </a:endParaRPr>
                     </a:p>
                   </a:txBody>
-                  <a:tcPr marL="101600" marR="101600" marT="203200" marB="203200" anchor="ctr">
+                  <a:tcPr marL="127000" marR="127000" marT="177800" marB="177800" anchor="ctr">
                     <a:lnL w="0" cap="flat" cmpd="sng" algn="ctr">
                       <a:noFill/>
                     </a:lnL>
@@ -2989,18 +2921,23 @@
                     </a:solidFill>
                   </a:tcPr>
                 </a:tc>
+                <a:extLst>
+                  <a:ext uri="{0D108BD9-81ED-4DB2-BD59-A6C34878D82A}">
+                    <a16:rowId xmlns:a16="http://schemas.microsoft.com/office/drawing/2014/main" val="10002"/>
+                  </a:ext>
+                </a:extLst>
               </a:tr>
-              <a:tr h="658368">
+              <a:tr h="822960">
                 <a:tc>
                   <a:txBody>
                     <a:bodyPr/>
                     <a:lstStyle/>
                     <a:p>
-                      <a:pPr indent="0" marL="0">
+                      <a:pPr marL="0" indent="0">
                         <a:buNone/>
                       </a:pPr>
                       <a:r>
-                        <a:rPr lang="en-US" sz="1300" b="1" dirty="0">
+                        <a:rPr lang="en-US" sz="1600" b="1" dirty="0">
                           <a:solidFill>
                             <a:srgbClr val="141414"/>
                           </a:solidFill>
@@ -3008,16 +2945,16 @@
                           <a:ea typeface="Calibri" pitchFamily="34" charset="-122"/>
                           <a:cs typeface="Calibri" pitchFamily="34" charset="-120"/>
                         </a:rPr>
-                        <a:t>Arithmetic you can check</a:t>
+                        <a:t>Credibility</a:t>
                       </a:r>
-                      <a:endParaRPr lang="en-US" sz="1300" dirty="0">
+                      <a:endParaRPr lang="en-US" sz="1600" dirty="0">
                         <a:latin typeface="Calibri" charset="0"/>
                         <a:ea typeface="Calibri" charset="0"/>
                         <a:cs typeface="Calibri" charset="0"/>
                       </a:endParaRPr>
                     </a:p>
                   </a:txBody>
-                  <a:tcPr marL="101600" marR="101600" marT="203200" marB="203200" anchor="ctr">
+                  <a:tcPr marL="127000" marR="127000" marT="177800" marB="177800" anchor="ctr">
                     <a:lnL w="0" cap="flat" cmpd="sng" algn="ctr">
                       <a:noFill/>
                     </a:lnL>
@@ -3052,28 +2989,49 @@
                     <a:bodyPr/>
                     <a:lstStyle/>
                     <a:p>
-                      <a:pPr indent="0" marL="0">
+                      <a:pPr marL="0" indent="0">
                         <a:buNone/>
                       </a:pPr>
                       <a:r>
-                        <a:rPr lang="en-US" sz="1300" dirty="0">
+                        <a:rPr lang="en-US" sz="1600" b="1" dirty="0">
                           <a:solidFill>
-                            <a:srgbClr val="8A5E15"/>
+                            <a:srgbClr val="3C6444"/>
                           </a:solidFill>
                           <a:latin typeface="Calibri" pitchFamily="34" charset="0"/>
                           <a:ea typeface="Calibri" pitchFamily="34" charset="-122"/>
                           <a:cs typeface="Calibri" pitchFamily="34" charset="-120"/>
                         </a:rPr>
-                        <a:t>You redo it by hand</a:t>
+                        <a:t>High</a:t>
                       </a:r>
-                      <a:endParaRPr lang="en-US" sz="1300" dirty="0">
+                      <a:endParaRPr lang="en-US" sz="1400" dirty="0">
+                        <a:latin typeface="Calibri" charset="0"/>
+                        <a:ea typeface="Calibri" charset="0"/>
+                        <a:cs typeface="Calibri" charset="0"/>
+                      </a:endParaRPr>
+                    </a:p>
+                    <a:p>
+                      <a:pPr marL="0" indent="0">
+                        <a:buNone/>
+                      </a:pPr>
+                      <a:r>
+                        <a:rPr lang="en-US" sz="1200" dirty="0">
+                          <a:solidFill>
+                            <a:srgbClr val="5C564C"/>
+                          </a:solidFill>
+                          <a:latin typeface="Calibri" pitchFamily="34" charset="0"/>
+                          <a:ea typeface="Calibri" pitchFamily="34" charset="-122"/>
+                          <a:cs typeface="Calibri" pitchFamily="34" charset="-120"/>
+                        </a:rPr>
+                        <a:t>Enterprise research</a:t>
+                      </a:r>
+                      <a:endParaRPr lang="en-US" sz="1400" dirty="0">
                         <a:latin typeface="Calibri" charset="0"/>
                         <a:ea typeface="Calibri" charset="0"/>
                         <a:cs typeface="Calibri" charset="0"/>
                       </a:endParaRPr>
                     </a:p>
                   </a:txBody>
-                  <a:tcPr marL="101600" marR="101600" marT="203200" marB="203200" anchor="ctr">
+                  <a:tcPr marL="127000" marR="127000" marT="177800" marB="177800" anchor="ctr">
                     <a:lnL w="0" cap="flat" cmpd="sng" algn="ctr">
                       <a:noFill/>
                     </a:lnL>
@@ -3105,28 +3063,49 @@
                     <a:bodyPr/>
                     <a:lstStyle/>
                     <a:p>
-                      <a:pPr indent="0" marL="0">
+                      <a:pPr marL="0" indent="0">
                         <a:buNone/>
                       </a:pPr>
                       <a:r>
-                        <a:rPr lang="en-US" sz="1300" dirty="0">
+                        <a:rPr lang="en-US" sz="1600" b="1" dirty="0">
                           <a:solidFill>
-                            <a:srgbClr val="9B2C2C"/>
+                            <a:srgbClr val="8A5E15"/>
                           </a:solidFill>
                           <a:latin typeface="Calibri" pitchFamily="34" charset="0"/>
                           <a:ea typeface="Calibri" pitchFamily="34" charset="-122"/>
                           <a:cs typeface="Calibri" pitchFamily="34" charset="-120"/>
                         </a:rPr>
-                        <a:t>Done in the model’s head</a:t>
+                        <a:t>Low</a:t>
                       </a:r>
-                      <a:endParaRPr lang="en-US" sz="1300" dirty="0">
+                      <a:endParaRPr lang="en-US" sz="1400" dirty="0">
+                        <a:latin typeface="Calibri" charset="0"/>
+                        <a:ea typeface="Calibri" charset="0"/>
+                        <a:cs typeface="Calibri" charset="0"/>
+                      </a:endParaRPr>
+                    </a:p>
+                    <a:p>
+                      <a:pPr marL="0" indent="0">
+                        <a:buNone/>
+                      </a:pPr>
+                      <a:r>
+                        <a:rPr lang="en-US" sz="1200" dirty="0">
+                          <a:solidFill>
+                            <a:srgbClr val="5C564C"/>
+                          </a:solidFill>
+                          <a:latin typeface="Calibri" pitchFamily="34" charset="0"/>
+                          <a:ea typeface="Calibri" pitchFamily="34" charset="-122"/>
+                          <a:cs typeface="Calibri" pitchFamily="34" charset="-120"/>
+                        </a:rPr>
+                        <a:t>Fragmented internet data</a:t>
+                      </a:r>
+                      <a:endParaRPr lang="en-US" sz="1400" dirty="0">
                         <a:latin typeface="Calibri" charset="0"/>
                         <a:ea typeface="Calibri" charset="0"/>
                         <a:cs typeface="Calibri" charset="0"/>
                       </a:endParaRPr>
                     </a:p>
                   </a:txBody>
-                  <a:tcPr marL="101600" marR="101600" marT="203200" marB="203200" anchor="ctr">
+                  <a:tcPr marL="127000" marR="127000" marT="177800" marB="177800" anchor="ctr">
                     <a:lnL w="0" cap="flat" cmpd="sng" algn="ctr">
                       <a:noFill/>
                     </a:lnL>
@@ -3158,11 +3137,11 @@
                     <a:bodyPr/>
                     <a:lstStyle/>
                     <a:p>
-                      <a:pPr indent="0" marL="0">
+                      <a:pPr marL="0" indent="0">
                         <a:buNone/>
                       </a:pPr>
                       <a:r>
-                        <a:rPr lang="en-US" sz="1300" dirty="0">
+                        <a:rPr lang="en-US" sz="1600" b="1" dirty="0">
                           <a:solidFill>
                             <a:srgbClr val="3C6444"/>
                           </a:solidFill>
@@ -3170,16 +3149,37 @@
                           <a:ea typeface="Calibri" pitchFamily="34" charset="-122"/>
                           <a:cs typeface="Calibri" pitchFamily="34" charset="-120"/>
                         </a:rPr>
-                        <a:t>Done in Python, same every run</a:t>
+                        <a:t>High</a:t>
                       </a:r>
-                      <a:endParaRPr lang="en-US" sz="1300" dirty="0">
+                      <a:endParaRPr lang="en-US" sz="1400" dirty="0">
+                        <a:latin typeface="Calibri" charset="0"/>
+                        <a:ea typeface="Calibri" charset="0"/>
+                        <a:cs typeface="Calibri" charset="0"/>
+                      </a:endParaRPr>
+                    </a:p>
+                    <a:p>
+                      <a:pPr marL="0" indent="0">
+                        <a:buNone/>
+                      </a:pPr>
+                      <a:r>
+                        <a:rPr lang="en-US" sz="1200" dirty="0">
+                          <a:solidFill>
+                            <a:srgbClr val="5C564C"/>
+                          </a:solidFill>
+                          <a:latin typeface="Calibri" pitchFamily="34" charset="0"/>
+                          <a:ea typeface="Calibri" pitchFamily="34" charset="-122"/>
+                          <a:cs typeface="Calibri" pitchFamily="34" charset="-120"/>
+                        </a:rPr>
+                        <a:t>Named sources: Savills, VOA, EPC register</a:t>
+                      </a:r>
+                      <a:endParaRPr lang="en-US" sz="1400" dirty="0">
                         <a:latin typeface="Calibri" charset="0"/>
                         <a:ea typeface="Calibri" charset="0"/>
                         <a:cs typeface="Calibri" charset="0"/>
                       </a:endParaRPr>
                     </a:p>
                   </a:txBody>
-                  <a:tcPr marL="101600" marR="101600" marT="203200" marB="203200" anchor="ctr">
+                  <a:tcPr marL="127000" marR="127000" marT="177800" marB="177800" anchor="ctr">
                     <a:lnL w="0" cap="flat" cmpd="sng" algn="ctr">
                       <a:noFill/>
                     </a:lnL>
@@ -3209,18 +3209,23 @@
                     </a:solidFill>
                   </a:tcPr>
                 </a:tc>
+                <a:extLst>
+                  <a:ext uri="{0D108BD9-81ED-4DB2-BD59-A6C34878D82A}">
+                    <a16:rowId xmlns:a16="http://schemas.microsoft.com/office/drawing/2014/main" val="10003"/>
+                  </a:ext>
+                </a:extLst>
               </a:tr>
-              <a:tr h="658368">
+              <a:tr h="822960">
                 <a:tc>
                   <a:txBody>
                     <a:bodyPr/>
                     <a:lstStyle/>
                     <a:p>
-                      <a:pPr indent="0" marL="0">
+                      <a:pPr marL="0" indent="0">
                         <a:buNone/>
                       </a:pPr>
                       <a:r>
-                        <a:rPr lang="en-US" sz="1300" b="1" dirty="0">
+                        <a:rPr lang="en-US" sz="1600" b="1" dirty="0">
                           <a:solidFill>
                             <a:srgbClr val="141414"/>
                           </a:solidFill>
@@ -3228,16 +3233,16 @@
                           <a:ea typeface="Calibri" pitchFamily="34" charset="-122"/>
                           <a:cs typeface="Calibri" pitchFamily="34" charset="-120"/>
                         </a:rPr>
-                        <a:t>Knows your portfolio</a:t>
+                        <a:t>Strategic insight</a:t>
                       </a:r>
-                      <a:endParaRPr lang="en-US" sz="1300" dirty="0">
+                      <a:endParaRPr lang="en-US" sz="1600" dirty="0">
                         <a:latin typeface="Calibri" charset="0"/>
                         <a:ea typeface="Calibri" charset="0"/>
                         <a:cs typeface="Calibri" charset="0"/>
                       </a:endParaRPr>
                     </a:p>
                   </a:txBody>
-                  <a:tcPr marL="101600" marR="101600" marT="203200" marB="203200" anchor="ctr">
+                  <a:tcPr marL="127000" marR="127000" marT="177800" marB="177800" anchor="ctr">
                     <a:lnL w="0" cap="flat" cmpd="sng" algn="ctr">
                       <a:noFill/>
                     </a:lnL>
@@ -3272,11 +3277,11 @@
                     <a:bodyPr/>
                     <a:lstStyle/>
                     <a:p>
-                      <a:pPr indent="0" marL="0">
+                      <a:pPr marL="0" indent="0">
                         <a:buNone/>
                       </a:pPr>
                       <a:r>
-                        <a:rPr lang="en-US" sz="1300" dirty="0">
+                        <a:rPr lang="en-US" sz="1600" b="1" dirty="0">
                           <a:solidFill>
                             <a:srgbClr val="9B2C2C"/>
                           </a:solidFill>
@@ -3284,16 +3289,37 @@
                           <a:ea typeface="Calibri" pitchFamily="34" charset="-122"/>
                           <a:cs typeface="Calibri" pitchFamily="34" charset="-120"/>
                         </a:rPr>
-                        <a:t>No, market-wide only</a:t>
+                        <a:t>No</a:t>
                       </a:r>
-                      <a:endParaRPr lang="en-US" sz="1300" dirty="0">
+                      <a:endParaRPr lang="en-US" sz="1400" dirty="0">
+                        <a:latin typeface="Calibri" charset="0"/>
+                        <a:ea typeface="Calibri" charset="0"/>
+                        <a:cs typeface="Calibri" charset="0"/>
+                      </a:endParaRPr>
+                    </a:p>
+                    <a:p>
+                      <a:pPr marL="0" indent="0">
+                        <a:buNone/>
+                      </a:pPr>
+                      <a:r>
+                        <a:rPr lang="en-US" sz="1200" dirty="0">
+                          <a:solidFill>
+                            <a:srgbClr val="5C564C"/>
+                          </a:solidFill>
+                          <a:latin typeface="Calibri" pitchFamily="34" charset="0"/>
+                          <a:ea typeface="Calibri" pitchFamily="34" charset="-122"/>
+                          <a:cs typeface="Calibri" pitchFamily="34" charset="-120"/>
+                        </a:rPr>
+                        <a:t>You do your own research</a:t>
+                      </a:r>
+                      <a:endParaRPr lang="en-US" sz="1400" dirty="0">
                         <a:latin typeface="Calibri" charset="0"/>
                         <a:ea typeface="Calibri" charset="0"/>
                         <a:cs typeface="Calibri" charset="0"/>
                       </a:endParaRPr>
                     </a:p>
                   </a:txBody>
-                  <a:tcPr marL="101600" marR="101600" marT="203200" marB="203200" anchor="ctr">
+                  <a:tcPr marL="127000" marR="127000" marT="177800" marB="177800" anchor="ctr">
                     <a:lnL w="0" cap="flat" cmpd="sng" algn="ctr">
                       <a:noFill/>
                     </a:lnL>
@@ -3325,11 +3351,11 @@
                     <a:bodyPr/>
                     <a:lstStyle/>
                     <a:p>
-                      <a:pPr indent="0" marL="0">
+                      <a:pPr marL="0" indent="0">
                         <a:buNone/>
                       </a:pPr>
                       <a:r>
-                        <a:rPr lang="en-US" sz="1300" dirty="0">
+                        <a:rPr lang="en-US" sz="1600" b="1" dirty="0">
                           <a:solidFill>
                             <a:srgbClr val="8A5E15"/>
                           </a:solidFill>
@@ -3337,16 +3363,37 @@
                           <a:ea typeface="Calibri" pitchFamily="34" charset="-122"/>
                           <a:cs typeface="Calibri" pitchFamily="34" charset="-120"/>
                         </a:rPr>
-                        <a:t>Only what you paste in</a:t>
+                        <a:t>Low</a:t>
                       </a:r>
-                      <a:endParaRPr lang="en-US" sz="1300" dirty="0">
+                      <a:endParaRPr lang="en-US" sz="1400" dirty="0">
+                        <a:latin typeface="Calibri" charset="0"/>
+                        <a:ea typeface="Calibri" charset="0"/>
+                        <a:cs typeface="Calibri" charset="0"/>
+                      </a:endParaRPr>
+                    </a:p>
+                    <a:p>
+                      <a:pPr marL="0" indent="0">
+                        <a:buNone/>
+                      </a:pPr>
+                      <a:r>
+                        <a:rPr lang="en-US" sz="1200" dirty="0">
+                          <a:solidFill>
+                            <a:srgbClr val="5C564C"/>
+                          </a:solidFill>
+                          <a:latin typeface="Calibri" pitchFamily="34" charset="0"/>
+                          <a:ea typeface="Calibri" pitchFamily="34" charset="-122"/>
+                          <a:cs typeface="Calibri" pitchFamily="34" charset="-120"/>
+                        </a:rPr>
+                        <a:t>Generic advice</a:t>
+                      </a:r>
+                      <a:endParaRPr lang="en-US" sz="1400" dirty="0">
                         <a:latin typeface="Calibri" charset="0"/>
                         <a:ea typeface="Calibri" charset="0"/>
                         <a:cs typeface="Calibri" charset="0"/>
                       </a:endParaRPr>
                     </a:p>
                   </a:txBody>
-                  <a:tcPr marL="101600" marR="101600" marT="203200" marB="203200" anchor="ctr">
+                  <a:tcPr marL="127000" marR="127000" marT="177800" marB="177800" anchor="ctr">
                     <a:lnL w="0" cap="flat" cmpd="sng" algn="ctr">
                       <a:noFill/>
                     </a:lnL>
@@ -3378,11 +3425,11 @@
                     <a:bodyPr/>
                     <a:lstStyle/>
                     <a:p>
-                      <a:pPr indent="0" marL="0">
+                      <a:pPr marL="0" indent="0">
                         <a:buNone/>
                       </a:pPr>
                       <a:r>
-                        <a:rPr lang="en-US" sz="1300" dirty="0">
+                        <a:rPr lang="en-US" sz="1600" b="1" dirty="0">
                           <a:solidFill>
                             <a:srgbClr val="3C6444"/>
                           </a:solidFill>
@@ -3390,16 +3437,37 @@
                           <a:ea typeface="Calibri" pitchFamily="34" charset="-122"/>
                           <a:cs typeface="Calibri" pitchFamily="34" charset="-120"/>
                         </a:rPr>
-                        <a:t>Yes, matched to your holdings</a:t>
+                        <a:t>High</a:t>
                       </a:r>
-                      <a:endParaRPr lang="en-US" sz="1300" dirty="0">
+                      <a:endParaRPr lang="en-US" sz="1400" dirty="0">
+                        <a:latin typeface="Calibri" charset="0"/>
+                        <a:ea typeface="Calibri" charset="0"/>
+                        <a:cs typeface="Calibri" charset="0"/>
+                      </a:endParaRPr>
+                    </a:p>
+                    <a:p>
+                      <a:pPr marL="0" indent="0">
+                        <a:buNone/>
+                      </a:pPr>
+                      <a:r>
+                        <a:rPr lang="en-US" sz="1200" dirty="0">
+                          <a:solidFill>
+                            <a:srgbClr val="5C564C"/>
+                          </a:solidFill>
+                          <a:latin typeface="Calibri" pitchFamily="34" charset="0"/>
+                          <a:ea typeface="Calibri" pitchFamily="34" charset="-122"/>
+                          <a:cs typeface="Calibri" pitchFamily="34" charset="-120"/>
+                        </a:rPr>
+                        <a:t>Specific to the buildings you hold</a:t>
+                      </a:r>
+                      <a:endParaRPr lang="en-US" sz="1400" dirty="0">
                         <a:latin typeface="Calibri" charset="0"/>
                         <a:ea typeface="Calibri" charset="0"/>
                         <a:cs typeface="Calibri" charset="0"/>
                       </a:endParaRPr>
                     </a:p>
                   </a:txBody>
-                  <a:tcPr marL="101600" marR="101600" marT="203200" marB="203200" anchor="ctr">
+                  <a:tcPr marL="127000" marR="127000" marT="177800" marB="177800" anchor="ctr">
                     <a:lnL w="0" cap="flat" cmpd="sng" algn="ctr">
                       <a:noFill/>
                     </a:lnL>
@@ -3429,273 +3497,16 @@
                     </a:solidFill>
                   </a:tcPr>
                 </a:tc>
-              </a:tr>
-              <a:tr h="658368">
-                <a:tc>
-                  <a:txBody>
-                    <a:bodyPr/>
-                    <a:lstStyle/>
-                    <a:p>
-                      <a:pPr indent="0" marL="0">
-                        <a:buNone/>
-                      </a:pPr>
-                      <a:r>
-                        <a:rPr lang="en-US" sz="1300" b="1" dirty="0">
-                          <a:solidFill>
-                            <a:srgbClr val="141414"/>
-                          </a:solidFill>
-                          <a:latin typeface="Calibri" pitchFamily="34" charset="0"/>
-                          <a:ea typeface="Calibri" pitchFamily="34" charset="-122"/>
-                          <a:cs typeface="Calibri" pitchFamily="34" charset="-120"/>
-                        </a:rPr>
-                        <a:t>Ends in a decision</a:t>
-                      </a:r>
-                      <a:endParaRPr lang="en-US" sz="1300" dirty="0">
-                        <a:latin typeface="Calibri" charset="0"/>
-                        <a:ea typeface="Calibri" charset="0"/>
-                        <a:cs typeface="Calibri" charset="0"/>
-                      </a:endParaRPr>
-                    </a:p>
-                  </a:txBody>
-                  <a:tcPr marL="101600" marR="101600" marT="203200" marB="203200" anchor="ctr">
-                    <a:lnL w="0" cap="flat" cmpd="sng" algn="ctr">
-                      <a:noFill/>
-                    </a:lnL>
-                    <a:lnR w="0" cap="flat" cmpd="sng" algn="ctr">
-                      <a:noFill/>
-                    </a:lnR>
-                    <a:lnT w="6350" cap="flat" cmpd="sng" algn="ctr">
-                      <a:solidFill>
-                        <a:srgbClr val="C6BDA9"/>
-                      </a:solidFill>
-                      <a:prstDash val="solid"/>
-                      <a:round/>
-                      <a:headEnd type="none" w="med" len="med"/>
-                      <a:tailEnd type="none" w="med" len="med"/>
-                    </a:lnT>
-                    <a:lnB w="6350" cap="flat" cmpd="sng" algn="ctr">
-                      <a:solidFill>
-                        <a:srgbClr val="C6BDA9"/>
-                      </a:solidFill>
-                      <a:prstDash val="solid"/>
-                      <a:round/>
-                      <a:headEnd type="none" w="med" len="med"/>
-                      <a:tailEnd type="none" w="med" len="med"/>
-                    </a:lnB>
-                    <a:solidFill>
-                      <a:srgbClr val="F6F2E8"/>
-                    </a:solidFill>
-                  </a:tcPr>
-                </a:tc>
-                <a:tc>
-                  <a:txBody>
-                    <a:bodyPr/>
-                    <a:lstStyle/>
-                    <a:p>
-                      <a:pPr indent="0" marL="0">
-                        <a:buNone/>
-                      </a:pPr>
-                      <a:r>
-                        <a:rPr lang="en-US" sz="1300" dirty="0">
-                          <a:solidFill>
-                            <a:srgbClr val="8A5E15"/>
-                          </a:solidFill>
-                          <a:latin typeface="Calibri" pitchFamily="34" charset="0"/>
-                          <a:ea typeface="Calibri" pitchFamily="34" charset="-122"/>
-                          <a:cs typeface="Calibri" pitchFamily="34" charset="-120"/>
-                        </a:rPr>
-                        <a:t>No, it informs one</a:t>
-                      </a:r>
-                      <a:endParaRPr lang="en-US" sz="1300" dirty="0">
-                        <a:latin typeface="Calibri" charset="0"/>
-                        <a:ea typeface="Calibri" charset="0"/>
-                        <a:cs typeface="Calibri" charset="0"/>
-                      </a:endParaRPr>
-                    </a:p>
-                  </a:txBody>
-                  <a:tcPr marL="101600" marR="101600" marT="203200" marB="203200" anchor="ctr">
-                    <a:lnL w="0" cap="flat" cmpd="sng" algn="ctr">
-                      <a:noFill/>
-                    </a:lnL>
-                    <a:lnR w="0" cap="flat" cmpd="sng" algn="ctr">
-                      <a:noFill/>
-                    </a:lnR>
-                    <a:lnT w="6350" cap="flat" cmpd="sng" algn="ctr">
-                      <a:solidFill>
-                        <a:srgbClr val="C6BDA9"/>
-                      </a:solidFill>
-                      <a:prstDash val="solid"/>
-                      <a:round/>
-                      <a:headEnd type="none" w="med" len="med"/>
-                      <a:tailEnd type="none" w="med" len="med"/>
-                    </a:lnT>
-                    <a:lnB w="6350" cap="flat" cmpd="sng" algn="ctr">
-                      <a:solidFill>
-                        <a:srgbClr val="C6BDA9"/>
-                      </a:solidFill>
-                      <a:prstDash val="solid"/>
-                      <a:round/>
-                      <a:headEnd type="none" w="med" len="med"/>
-                      <a:tailEnd type="none" w="med" len="med"/>
-                    </a:lnB>
-                  </a:tcPr>
-                </a:tc>
-                <a:tc>
-                  <a:txBody>
-                    <a:bodyPr/>
-                    <a:lstStyle/>
-                    <a:p>
-                      <a:pPr indent="0" marL="0">
-                        <a:buNone/>
-                      </a:pPr>
-                      <a:r>
-                        <a:rPr lang="en-US" sz="1300" dirty="0">
-                          <a:solidFill>
-                            <a:srgbClr val="9B2C2C"/>
-                          </a:solidFill>
-                          <a:latin typeface="Calibri" pitchFamily="34" charset="0"/>
-                          <a:ea typeface="Calibri" pitchFamily="34" charset="-122"/>
-                          <a:cs typeface="Calibri" pitchFamily="34" charset="-120"/>
-                        </a:rPr>
-                        <a:t>Generic advice</a:t>
-                      </a:r>
-                      <a:endParaRPr lang="en-US" sz="1300" dirty="0">
-                        <a:latin typeface="Calibri" charset="0"/>
-                        <a:ea typeface="Calibri" charset="0"/>
-                        <a:cs typeface="Calibri" charset="0"/>
-                      </a:endParaRPr>
-                    </a:p>
-                  </a:txBody>
-                  <a:tcPr marL="101600" marR="101600" marT="203200" marB="203200" anchor="ctr">
-                    <a:lnL w="0" cap="flat" cmpd="sng" algn="ctr">
-                      <a:noFill/>
-                    </a:lnL>
-                    <a:lnR w="0" cap="flat" cmpd="sng" algn="ctr">
-                      <a:noFill/>
-                    </a:lnR>
-                    <a:lnT w="6350" cap="flat" cmpd="sng" algn="ctr">
-                      <a:solidFill>
-                        <a:srgbClr val="C6BDA9"/>
-                      </a:solidFill>
-                      <a:prstDash val="solid"/>
-                      <a:round/>
-                      <a:headEnd type="none" w="med" len="med"/>
-                      <a:tailEnd type="none" w="med" len="med"/>
-                    </a:lnT>
-                    <a:lnB w="6350" cap="flat" cmpd="sng" algn="ctr">
-                      <a:solidFill>
-                        <a:srgbClr val="C6BDA9"/>
-                      </a:solidFill>
-                      <a:prstDash val="solid"/>
-                      <a:round/>
-                      <a:headEnd type="none" w="med" len="med"/>
-                      <a:tailEnd type="none" w="med" len="med"/>
-                    </a:lnB>
-                  </a:tcPr>
-                </a:tc>
-                <a:tc>
-                  <a:txBody>
-                    <a:bodyPr/>
-                    <a:lstStyle/>
-                    <a:p>
-                      <a:pPr indent="0" marL="0">
-                        <a:buNone/>
-                      </a:pPr>
-                      <a:r>
-                        <a:rPr lang="en-US" sz="1300" dirty="0">
-                          <a:solidFill>
-                            <a:srgbClr val="3C6444"/>
-                          </a:solidFill>
-                          <a:latin typeface="Calibri" pitchFamily="34" charset="0"/>
-                          <a:ea typeface="Calibri" pitchFamily="34" charset="-122"/>
-                          <a:cs typeface="Calibri" pitchFamily="34" charset="-120"/>
-                        </a:rPr>
-                        <a:t>A closed set of verbs</a:t>
-                      </a:r>
-                      <a:endParaRPr lang="en-US" sz="1300" dirty="0">
-                        <a:latin typeface="Calibri" charset="0"/>
-                        <a:ea typeface="Calibri" charset="0"/>
-                        <a:cs typeface="Calibri" charset="0"/>
-                      </a:endParaRPr>
-                    </a:p>
-                  </a:txBody>
-                  <a:tcPr marL="101600" marR="101600" marT="203200" marB="203200" anchor="ctr">
-                    <a:lnL w="0" cap="flat" cmpd="sng" algn="ctr">
-                      <a:noFill/>
-                    </a:lnL>
-                    <a:lnR w="0" cap="flat" cmpd="sng" algn="ctr">
-                      <a:noFill/>
-                    </a:lnR>
-                    <a:lnT w="6350" cap="flat" cmpd="sng" algn="ctr">
-                      <a:solidFill>
-                        <a:srgbClr val="C6BDA9"/>
-                      </a:solidFill>
-                      <a:prstDash val="solid"/>
-                      <a:round/>
-                      <a:headEnd type="none" w="med" len="med"/>
-                      <a:tailEnd type="none" w="med" len="med"/>
-                    </a:lnT>
-                    <a:lnB w="6350" cap="flat" cmpd="sng" algn="ctr">
-                      <a:solidFill>
-                        <a:srgbClr val="C6BDA9"/>
-                      </a:solidFill>
-                      <a:prstDash val="solid"/>
-                      <a:round/>
-                      <a:headEnd type="none" w="med" len="med"/>
-                      <a:tailEnd type="none" w="med" len="med"/>
-                    </a:lnB>
-                    <a:solidFill>
-                      <a:srgbClr val="E3DAC5"/>
-                    </a:solidFill>
-                  </a:tcPr>
-                </a:tc>
+                <a:extLst>
+                  <a:ext uri="{0D108BD9-81ED-4DB2-BD59-A6C34878D82A}">
+                    <a16:rowId xmlns:a16="http://schemas.microsoft.com/office/drawing/2014/main" val="10004"/>
+                  </a:ext>
+                </a:extLst>
               </a:tr>
             </a:tbl>
           </a:graphicData>
         </a:graphic>
       </p:graphicFrame>
-      <p:sp>
-        <p:nvSpPr>
-          <p:cNvPr id="5" name="Text 2"/>
-          <p:cNvSpPr txBox="1"/>
-          <p:nvPr/>
-        </p:nvSpPr>
-        <p:spPr>
-          <a:xfrm>
-            <a:off x="640080" y="5961888"/>
-            <a:ext cx="10911535" cy="384048"/>
-          </a:xfrm>
-          <a:prstGeom prst="rect">
-            <a:avLst/>
-          </a:prstGeom>
-          <a:noFill/>
-          <a:ln/>
-        </p:spPr>
-        <p:txBody>
-          <a:bodyPr wrap="square" lIns="0" tIns="0" rIns="0" bIns="0" rtlCol="0" anchor="t"/>
-          <a:lstStyle/>
-          <a:p>
-            <a:pPr indent="0" marL="0">
-              <a:lnSpc>
-                <a:spcPts val="1700"/>
-              </a:lnSpc>
-              <a:buNone/>
-            </a:pPr>
-            <a:r>
-              <a:rPr lang="en-US" sz="1250" i="1" dirty="0">
-                <a:solidFill>
-                  <a:srgbClr val="5C564C"/>
-                </a:solidFill>
-                <a:latin typeface="Cambria" pitchFamily="34" charset="0"/>
-                <a:ea typeface="Cambria" pitchFamily="34" charset="-122"/>
-                <a:cs typeface="Cambria" pitchFamily="34" charset="-120"/>
-              </a:rPr>
-              <a:t>Scope: Central London offices, from one quarterly release. Published research covers the whole market; this does not.</a:t>
-            </a:r>
-            <a:endParaRPr lang="en-US" sz="1250" dirty="0"/>
-          </a:p>
-        </p:txBody>
-      </p:sp>
     </p:spTree>
   </p:cSld>
   <p:clrMapOvr>
@@ -3712,6 +3523,7 @@
         <a:solidFill>
           <a:srgbClr val="F6F2E8"/>
         </a:solidFill>
+        <a:effectLst/>
       </p:bgPr>
     </p:bg>
     <p:spTree>
@@ -3749,11 +3561,11 @@
           <a:bodyPr wrap="square" lIns="0" tIns="0" rIns="0" bIns="0" rtlCol="0" anchor="t"/>
           <a:lstStyle/>
           <a:p>
-            <a:pPr indent="0" marL="0">
+            <a:pPr marL="0" indent="0">
               <a:buNone/>
             </a:pPr>
             <a:r>
-              <a:rPr lang="en-US" sz="1100" b="1" spc="220" kern="0" dirty="0">
+              <a:rPr lang="en-US" sz="1100" b="1" kern="0" spc="220" dirty="0">
                 <a:solidFill>
                   <a:srgbClr val="5C564C"/>
                 </a:solidFill>
@@ -3761,7 +3573,7 @@
                 <a:ea typeface="Calibri" pitchFamily="34" charset="-122"/>
                 <a:cs typeface="Calibri" pitchFamily="34" charset="-120"/>
               </a:rPr>
-              <a:t>DEMO  ·  THE BRIEF</a:t>
+              <a:t>DEMO  ·  SUBMARKET DYNAMICS</a:t>
             </a:r>
             <a:endParaRPr lang="en-US" sz="1100" dirty="0"/>
           </a:p>
@@ -3788,11 +3600,11 @@
           <a:bodyPr wrap="square" lIns="0" tIns="0" rIns="0" bIns="0" rtlCol="0" anchor="t"/>
           <a:lstStyle/>
           <a:p>
-            <a:pPr indent="0" marL="0">
+            <a:pPr marL="0" indent="0">
               <a:buNone/>
             </a:pPr>
             <a:r>
-              <a:rPr lang="en-US" sz="3400" b="1" dirty="0">
+              <a:rPr lang="en-US" sz="3200" b="1" dirty="0">
                 <a:solidFill>
                   <a:srgbClr val="141414"/>
                 </a:solidFill>
@@ -3800,22 +3612,73 @@
                 <a:ea typeface="Cambria" pitchFamily="34" charset="-122"/>
                 <a:cs typeface="Cambria" pitchFamily="34" charset="-120"/>
               </a:rPr>
-              <a:t>It has already read the quarter before you type</a:t>
-            </a:r>
-            <a:endParaRPr lang="en-US" sz="3400" dirty="0"/>
-          </a:p>
-        </p:txBody>
-      </p:sp>
-      <p:sp>
-        <p:nvSpPr>
-          <p:cNvPr id="4" name="Text 2"/>
+              <a:t>Is The Bailey priced right against its peers?</a:t>
+            </a:r>
+            <a:endParaRPr lang="en-US" sz="3200" dirty="0"/>
+          </a:p>
+        </p:txBody>
+      </p:sp>
+      <p:pic>
+        <p:nvPicPr>
+          <p:cNvPr id="5" name="Image 0" descr="/Users/ethanlee/Desktop/projects/cre_market_agent/slides/assets/demo-bailey-peers.png"/>
+          <p:cNvPicPr>
+            <a:picLocks noChangeAspect="1"/>
+          </p:cNvPicPr>
+          <p:nvPr/>
+        </p:nvPicPr>
+        <p:blipFill>
+          <a:blip r:embed="rId3"/>
+          <a:stretch>
+            <a:fillRect/>
+          </a:stretch>
+        </p:blipFill>
+        <p:spPr>
+          <a:xfrm>
+            <a:off x="7642758" y="1453896"/>
+            <a:ext cx="4250561" cy="4882896"/>
+          </a:xfrm>
+          <a:prstGeom prst="rect">
+            <a:avLst/>
+          </a:prstGeom>
+        </p:spPr>
+      </p:pic>
+      <p:sp>
+        <p:nvSpPr>
+          <p:cNvPr id="6" name="Shape 3"/>
+          <p:cNvSpPr/>
+          <p:nvPr/>
+        </p:nvSpPr>
+        <p:spPr>
+          <a:xfrm>
+            <a:off x="640080" y="1700784"/>
+            <a:ext cx="6842455" cy="667512"/>
+          </a:xfrm>
+          <a:prstGeom prst="rect">
+            <a:avLst/>
+          </a:prstGeom>
+          <a:solidFill>
+            <a:srgbClr val="EDE7D8"/>
+          </a:solidFill>
+          <a:ln/>
+        </p:spPr>
+        <p:txBody>
+          <a:bodyPr/>
+          <a:lstStyle/>
+          <a:p>
+            <a:endParaRPr lang="en-US"/>
+          </a:p>
+        </p:txBody>
+      </p:sp>
+      <p:sp>
+        <p:nvSpPr>
+          <p:cNvPr id="8" name="Text 5"/>
           <p:cNvSpPr txBox="1"/>
           <p:nvPr/>
         </p:nvSpPr>
         <p:spPr>
           <a:xfrm>
-            <a:off x="640080" y="1737360"/>
-            <a:ext cx="365760" cy="384048"/>
+            <a:off x="868679" y="1803348"/>
+            <a:ext cx="6385255" cy="464364"/>
           </a:xfrm>
           <a:prstGeom prst="rect">
             <a:avLst/>
@@ -3827,11 +3690,92 @@
           <a:bodyPr wrap="square" lIns="0" tIns="0" rIns="0" bIns="0" rtlCol="0" anchor="t"/>
           <a:lstStyle/>
           <a:p>
-            <a:pPr indent="0" marL="0">
+            <a:pPr marL="0" indent="0">
+              <a:lnSpc>
+                <a:spcPts val="1800"/>
+              </a:lnSpc>
               <a:buNone/>
             </a:pPr>
             <a:r>
-              <a:rPr lang="en-US" sz="2200" b="1" dirty="0">
+              <a:rPr lang="en-US" sz="1350" i="1" dirty="0">
+                <a:solidFill>
+                  <a:srgbClr val="141414"/>
+                </a:solidFill>
+                <a:latin typeface="Cambria" pitchFamily="34" charset="0"/>
+                <a:ea typeface="Cambria" pitchFamily="34" charset="-122"/>
+                <a:cs typeface="Cambria" pitchFamily="34" charset="-120"/>
+              </a:rPr>
+              <a:t>“Compare valuation of The Bailey in London with similar age buildings +- 5 year, output into a concise table.”</a:t>
+            </a:r>
+            <a:endParaRPr lang="en-US" sz="1350" dirty="0"/>
+          </a:p>
+        </p:txBody>
+      </p:sp>
+      <p:sp>
+        <p:nvSpPr>
+          <p:cNvPr id="9" name="Text 6"/>
+          <p:cNvSpPr txBox="1"/>
+          <p:nvPr/>
+        </p:nvSpPr>
+        <p:spPr>
+          <a:xfrm>
+            <a:off x="640080" y="2651760"/>
+            <a:ext cx="6842455" cy="219456"/>
+          </a:xfrm>
+          <a:prstGeom prst="rect">
+            <a:avLst/>
+          </a:prstGeom>
+          <a:noFill/>
+          <a:ln/>
+        </p:spPr>
+        <p:txBody>
+          <a:bodyPr wrap="square" lIns="0" tIns="0" rIns="0" bIns="0" rtlCol="0" anchor="t"/>
+          <a:lstStyle/>
+          <a:p>
+            <a:pPr marL="0" indent="0">
+              <a:buNone/>
+            </a:pPr>
+            <a:r>
+              <a:rPr lang="en-US" sz="1100" b="1" kern="0" spc="160" dirty="0">
+                <a:solidFill>
+                  <a:srgbClr val="5C564C"/>
+                </a:solidFill>
+                <a:latin typeface="Calibri" pitchFamily="34" charset="0"/>
+                <a:ea typeface="Calibri" pitchFamily="34" charset="-122"/>
+                <a:cs typeface="Calibri" pitchFamily="34" charset="-120"/>
+              </a:rPr>
+              <a:t>RELIABLE PRICING ANALYSIS IN SECONDS</a:t>
+            </a:r>
+            <a:endParaRPr lang="en-US" sz="1100" dirty="0"/>
+          </a:p>
+        </p:txBody>
+      </p:sp>
+      <p:sp>
+        <p:nvSpPr>
+          <p:cNvPr id="10" name="Text 7"/>
+          <p:cNvSpPr txBox="1"/>
+          <p:nvPr/>
+        </p:nvSpPr>
+        <p:spPr>
+          <a:xfrm>
+            <a:off x="640080" y="2916936"/>
+            <a:ext cx="365760" cy="365760"/>
+          </a:xfrm>
+          <a:prstGeom prst="rect">
+            <a:avLst/>
+          </a:prstGeom>
+          <a:noFill/>
+          <a:ln/>
+        </p:spPr>
+        <p:txBody>
+          <a:bodyPr wrap="square" lIns="0" tIns="0" rIns="0" bIns="0" rtlCol="0" anchor="t"/>
+          <a:lstStyle/>
+          <a:p>
+            <a:pPr marL="0" indent="0">
+              <a:buNone/>
+            </a:pPr>
+            <a:r>
+              <a:rPr lang="en-US" sz="2100" b="1" dirty="0">
                 <a:solidFill>
                   <a:srgbClr val="9B2C2C"/>
                 </a:solidFill>
@@ -3841,20 +3785,20 @@
               </a:rPr>
               <a:t>1</a:t>
             </a:r>
-            <a:endParaRPr lang="en-US" sz="2200" dirty="0"/>
-          </a:p>
-        </p:txBody>
-      </p:sp>
-      <p:sp>
-        <p:nvSpPr>
-          <p:cNvPr id="5" name="Text 3"/>
+            <a:endParaRPr lang="en-US" sz="2100" dirty="0"/>
+          </a:p>
+        </p:txBody>
+      </p:sp>
+      <p:sp>
+        <p:nvSpPr>
+          <p:cNvPr id="11" name="Text 8"/>
           <p:cNvSpPr txBox="1"/>
           <p:nvPr/>
         </p:nvSpPr>
         <p:spPr>
           <a:xfrm>
-            <a:off x="1042416" y="1773936"/>
-            <a:ext cx="4443984" cy="292608"/>
+            <a:off x="1024128" y="2962656"/>
+            <a:ext cx="6458407" cy="274320"/>
           </a:xfrm>
           <a:prstGeom prst="rect">
             <a:avLst/>
@@ -3866,11 +3810,11 @@
           <a:bodyPr wrap="square" lIns="0" tIns="0" rIns="0" bIns="0" rtlCol="0" anchor="t"/>
           <a:lstStyle/>
           <a:p>
-            <a:pPr indent="0" marL="0">
+            <a:pPr marL="0" indent="0">
               <a:buNone/>
             </a:pPr>
             <a:r>
-              <a:rPr lang="en-US" sz="1450" b="1" dirty="0">
+              <a:rPr lang="en-US" sz="1400" b="1" dirty="0">
                 <a:solidFill>
                   <a:srgbClr val="141414"/>
                 </a:solidFill>
@@ -3878,22 +3822,22 @@
                 <a:ea typeface="Calibri" pitchFamily="34" charset="-122"/>
                 <a:cs typeface="Calibri" pitchFamily="34" charset="-120"/>
               </a:rPr>
-              <a:t>Five ranked signals, waiting</a:t>
-            </a:r>
-            <a:endParaRPr lang="en-US" sz="1450" dirty="0"/>
-          </a:p>
-        </p:txBody>
-      </p:sp>
-      <p:sp>
-        <p:nvSpPr>
-          <p:cNvPr id="6" name="Text 4"/>
+              <a:t>Recalled what you own.</a:t>
+            </a:r>
+            <a:endParaRPr lang="en-US" sz="1400" dirty="0"/>
+          </a:p>
+        </p:txBody>
+      </p:sp>
+      <p:sp>
+        <p:nvSpPr>
+          <p:cNvPr id="12" name="Text 9"/>
           <p:cNvSpPr txBox="1"/>
           <p:nvPr/>
         </p:nvSpPr>
         <p:spPr>
           <a:xfrm>
-            <a:off x="1042416" y="2103120"/>
-            <a:ext cx="4443984" cy="1005840"/>
+            <a:off x="1024128" y="3255264"/>
+            <a:ext cx="6458407" cy="640080"/>
           </a:xfrm>
           <a:prstGeom prst="rect">
             <a:avLst/>
@@ -3905,9 +3849,9 @@
           <a:bodyPr wrap="square" lIns="0" tIns="0" rIns="0" bIns="0" rtlCol="0" anchor="t"/>
           <a:lstStyle/>
           <a:p>
-            <a:pPr indent="0" marL="0">
+            <a:pPr marL="0" indent="0" algn="just">
               <a:lnSpc>
-                <a:spcPts val="1650"/>
+                <a:spcPts val="1550"/>
               </a:lnSpc>
               <a:buNone/>
             </a:pPr>
@@ -3920,7 +3864,7 @@
                 <a:ea typeface="Calibri" pitchFamily="34" charset="-122"/>
                 <a:cs typeface="Calibri" pitchFamily="34" charset="-120"/>
               </a:rPr>
-              <a:t>No prompt, no blank box. Vacancy, supply, the quality spread, sector demand and lease events, all ranked by severity in Python, so the same data produces the same brief every time.</a:t>
+              <a:t>The agent opened the portfolio first, found The Bailey among your five London holdings, and took its 1999 completion and City Core address from there.</a:t>
             </a:r>
             <a:endParaRPr lang="en-US" sz="1200" dirty="0"/>
           </a:p>
@@ -3928,14 +3872,14 @@
       </p:sp>
       <p:sp>
         <p:nvSpPr>
-          <p:cNvPr id="7" name="Text 5"/>
+          <p:cNvPr id="14" name="Text 11"/>
           <p:cNvSpPr txBox="1"/>
           <p:nvPr/>
         </p:nvSpPr>
         <p:spPr>
           <a:xfrm>
-            <a:off x="640080" y="3218688"/>
-            <a:ext cx="365760" cy="384048"/>
+            <a:off x="640080" y="4050792"/>
+            <a:ext cx="365760" cy="365760"/>
           </a:xfrm>
           <a:prstGeom prst="rect">
             <a:avLst/>
@@ -3947,11 +3891,11 @@
           <a:bodyPr wrap="square" lIns="0" tIns="0" rIns="0" bIns="0" rtlCol="0" anchor="t"/>
           <a:lstStyle/>
           <a:p>
-            <a:pPr indent="0" marL="0">
+            <a:pPr marL="0" indent="0">
               <a:buNone/>
             </a:pPr>
             <a:r>
-              <a:rPr lang="en-US" sz="2200" b="1" dirty="0">
+              <a:rPr lang="en-US" sz="2100" b="1" dirty="0">
                 <a:solidFill>
                   <a:srgbClr val="9B2C2C"/>
                 </a:solidFill>
@@ -3961,20 +3905,20 @@
               </a:rPr>
               <a:t>2</a:t>
             </a:r>
-            <a:endParaRPr lang="en-US" sz="2200" dirty="0"/>
-          </a:p>
-        </p:txBody>
-      </p:sp>
-      <p:sp>
-        <p:nvSpPr>
-          <p:cNvPr id="8" name="Text 6"/>
+            <a:endParaRPr lang="en-US" sz="2100" dirty="0"/>
+          </a:p>
+        </p:txBody>
+      </p:sp>
+      <p:sp>
+        <p:nvSpPr>
+          <p:cNvPr id="15" name="Text 12"/>
           <p:cNvSpPr txBox="1"/>
           <p:nvPr/>
         </p:nvSpPr>
         <p:spPr>
           <a:xfrm>
-            <a:off x="1042416" y="3255264"/>
-            <a:ext cx="4443984" cy="292608"/>
+            <a:off x="1024128" y="4096512"/>
+            <a:ext cx="6458407" cy="274320"/>
           </a:xfrm>
           <a:prstGeom prst="rect">
             <a:avLst/>
@@ -3986,11 +3930,11 @@
           <a:bodyPr wrap="square" lIns="0" tIns="0" rIns="0" bIns="0" rtlCol="0" anchor="t"/>
           <a:lstStyle/>
           <a:p>
-            <a:pPr indent="0" marL="0">
+            <a:pPr marL="0" indent="0">
               <a:buNone/>
             </a:pPr>
             <a:r>
-              <a:rPr lang="en-US" sz="1450" b="1" dirty="0">
+              <a:rPr lang="en-US" sz="1400" b="1" dirty="0">
                 <a:solidFill>
                   <a:srgbClr val="141414"/>
                 </a:solidFill>
@@ -3998,22 +3942,22 @@
                 <a:ea typeface="Calibri" pitchFamily="34" charset="-122"/>
                 <a:cs typeface="Calibri" pitchFamily="34" charset="-120"/>
               </a:rPr>
-              <a:t>Your buildings sort to the top</a:t>
-            </a:r>
-            <a:endParaRPr lang="en-US" sz="1450" dirty="0"/>
-          </a:p>
-        </p:txBody>
-      </p:sp>
-      <p:sp>
-        <p:nvSpPr>
-          <p:cNvPr id="9" name="Text 7"/>
+              <a:t>Picked comparable buildings, then measured the gap.</a:t>
+            </a:r>
+            <a:endParaRPr lang="en-US" sz="1400" dirty="0"/>
+          </a:p>
+        </p:txBody>
+      </p:sp>
+      <p:sp>
+        <p:nvSpPr>
+          <p:cNvPr id="16" name="Text 13"/>
           <p:cNvSpPr txBox="1"/>
           <p:nvPr/>
         </p:nvSpPr>
         <p:spPr>
           <a:xfrm>
-            <a:off x="1042416" y="3584448"/>
-            <a:ext cx="4443984" cy="1005840"/>
+            <a:off x="1024128" y="4389120"/>
+            <a:ext cx="6458407" cy="640080"/>
           </a:xfrm>
           <a:prstGeom prst="rect">
             <a:avLst/>
@@ -4025,9 +3969,9 @@
           <a:bodyPr wrap="square" lIns="0" tIns="0" rIns="0" bIns="0" rtlCol="0" anchor="t"/>
           <a:lstStyle/>
           <a:p>
-            <a:pPr indent="0" marL="0">
+            <a:pPr marL="0" indent="0" algn="just">
               <a:lnSpc>
-                <a:spcPts val="1650"/>
+                <a:spcPts val="1550"/>
               </a:lnSpc>
               <a:buNone/>
             </a:pPr>
@@ -4040,7 +3984,7 @@
                 <a:ea typeface="Calibri" pitchFamily="34" charset="-122"/>
                 <a:cs typeface="Calibri" pitchFamily="34" charset="-120"/>
               </a:rPr>
-              <a:t>Anything touching a holding is promoted and opened by default. A signal may only claim a building it can name a reason for: submarket, lease window or sector.</a:t>
+              <a:t>It pulled every City Core building in the VOA rating list, kept the ones completed within five years of The Bailey as you asked, and computed the median and the gap.</a:t>
             </a:r>
             <a:endParaRPr lang="en-US" sz="1200" dirty="0"/>
           </a:p>
@@ -4048,14 +3992,14 @@
       </p:sp>
       <p:sp>
         <p:nvSpPr>
-          <p:cNvPr id="10" name="Text 8"/>
+          <p:cNvPr id="18" name="Text 15"/>
           <p:cNvSpPr txBox="1"/>
           <p:nvPr/>
         </p:nvSpPr>
         <p:spPr>
           <a:xfrm>
-            <a:off x="640080" y="4700016"/>
-            <a:ext cx="365760" cy="384048"/>
+            <a:off x="640080" y="5184648"/>
+            <a:ext cx="365760" cy="365760"/>
           </a:xfrm>
           <a:prstGeom prst="rect">
             <a:avLst/>
@@ -4067,11 +4011,11 @@
           <a:bodyPr wrap="square" lIns="0" tIns="0" rIns="0" bIns="0" rtlCol="0" anchor="t"/>
           <a:lstStyle/>
           <a:p>
-            <a:pPr indent="0" marL="0">
+            <a:pPr marL="0" indent="0">
               <a:buNone/>
             </a:pPr>
             <a:r>
-              <a:rPr lang="en-US" sz="2200" b="1" dirty="0">
+              <a:rPr lang="en-US" sz="2100" b="1" dirty="0">
                 <a:solidFill>
                   <a:srgbClr val="9B2C2C"/>
                 </a:solidFill>
@@ -4081,20 +4025,20 @@
               </a:rPr>
               <a:t>3</a:t>
             </a:r>
-            <a:endParaRPr lang="en-US" sz="2200" dirty="0"/>
-          </a:p>
-        </p:txBody>
-      </p:sp>
-      <p:sp>
-        <p:nvSpPr>
-          <p:cNvPr id="11" name="Text 9"/>
+            <a:endParaRPr lang="en-US" sz="2100" dirty="0"/>
+          </a:p>
+        </p:txBody>
+      </p:sp>
+      <p:sp>
+        <p:nvSpPr>
+          <p:cNvPr id="19" name="Text 16"/>
           <p:cNvSpPr txBox="1"/>
           <p:nvPr/>
         </p:nvSpPr>
         <p:spPr>
           <a:xfrm>
-            <a:off x="1042416" y="4736592"/>
-            <a:ext cx="4443984" cy="292608"/>
+            <a:off x="1024128" y="5230368"/>
+            <a:ext cx="6458407" cy="274320"/>
           </a:xfrm>
           <a:prstGeom prst="rect">
             <a:avLst/>
@@ -4106,11 +4050,11 @@
           <a:bodyPr wrap="square" lIns="0" tIns="0" rIns="0" bIns="0" rtlCol="0" anchor="t"/>
           <a:lstStyle/>
           <a:p>
-            <a:pPr indent="0" marL="0">
+            <a:pPr marL="0" indent="0">
               <a:buNone/>
             </a:pPr>
             <a:r>
-              <a:rPr lang="en-US" sz="1450" b="1" dirty="0">
+              <a:rPr lang="en-US" sz="1400" b="1" dirty="0">
                 <a:solidFill>
                   <a:srgbClr val="141414"/>
                 </a:solidFill>
@@ -4118,22 +4062,22 @@
                 <a:ea typeface="Calibri" pitchFamily="34" charset="-122"/>
                 <a:cs typeface="Calibri" pitchFamily="34" charset="-120"/>
               </a:rPr>
-              <a:t>Each one closes on a decision</a:t>
-            </a:r>
-            <a:endParaRPr lang="en-US" sz="1450" dirty="0"/>
-          </a:p>
-        </p:txBody>
-      </p:sp>
-      <p:sp>
-        <p:nvSpPr>
-          <p:cNvPr id="12" name="Text 10"/>
+              <a:t>Turned findings into strategy.</a:t>
+            </a:r>
+            <a:endParaRPr lang="en-US" sz="1400" dirty="0"/>
+          </a:p>
+        </p:txBody>
+      </p:sp>
+      <p:sp>
+        <p:nvSpPr>
+          <p:cNvPr id="20" name="Text 17"/>
           <p:cNvSpPr txBox="1"/>
           <p:nvPr/>
         </p:nvSpPr>
         <p:spPr>
           <a:xfrm>
-            <a:off x="1042416" y="5065776"/>
-            <a:ext cx="4443984" cy="1005840"/>
+            <a:off x="1024128" y="5522976"/>
+            <a:ext cx="6458407" cy="640080"/>
           </a:xfrm>
           <a:prstGeom prst="rect">
             <a:avLst/>
@@ -4145,130 +4089,12 @@
           <a:bodyPr wrap="square" lIns="0" tIns="0" rIns="0" bIns="0" rtlCol="0" anchor="t"/>
           <a:lstStyle/>
           <a:p>
-            <a:pPr indent="0" marL="0">
-              <a:lnSpc>
-                <a:spcPts val="1650"/>
-              </a:lnSpc>
-              <a:buNone/>
-            </a:pPr>
-            <a:r>
-              <a:rPr lang="en-US" sz="1200" dirty="0">
-                <a:solidFill>
-                  <a:srgbClr val="141414"/>
-                </a:solidFill>
-                <a:latin typeface="Calibri" pitchFamily="34" charset="0"/>
-                <a:ea typeface="Calibri" pitchFamily="34" charset="-122"/>
-                <a:cs typeface="Calibri" pitchFamily="34" charset="-120"/>
-              </a:rPr>
-              <a:t>Every matched building gets its own sentence and a verb from a fixed set: regear, refurbish, re-price, hold, defer capex, start the conversation.</a:t>
-            </a:r>
-            <a:endParaRPr lang="en-US" sz="1200" dirty="0"/>
-          </a:p>
-        </p:txBody>
-      </p:sp>
-      <p:sp>
-        <p:nvSpPr>
-          <p:cNvPr id="13" name="Shape 11"/>
-          <p:cNvSpPr/>
-          <p:nvPr/>
-        </p:nvSpPr>
-        <p:spPr>
-          <a:xfrm>
-            <a:off x="5989320" y="1700784"/>
-            <a:ext cx="5562295" cy="4023360"/>
-          </a:xfrm>
-          <a:prstGeom prst="rect">
-            <a:avLst/>
-          </a:prstGeom>
-          <a:solidFill>
-            <a:srgbClr val="EDE7D8"/>
-          </a:solidFill>
-          <a:ln w="12700">
-            <a:solidFill>
-              <a:srgbClr val="C6BDA9"/>
-            </a:solidFill>
-            <a:prstDash val="dash"/>
-          </a:ln>
-        </p:spPr>
-      </p:sp>
-      <p:sp>
-        <p:nvSpPr>
-          <p:cNvPr id="14" name="Text 12"/>
-          <p:cNvSpPr txBox="1"/>
-          <p:nvPr/>
-        </p:nvSpPr>
-        <p:spPr>
-          <a:xfrm>
-            <a:off x="6263640" y="3438144"/>
-            <a:ext cx="5013655" cy="548640"/>
-          </a:xfrm>
-          <a:prstGeom prst="rect">
-            <a:avLst/>
-          </a:prstGeom>
-          <a:noFill/>
-          <a:ln/>
-        </p:spPr>
-        <p:txBody>
-          <a:bodyPr wrap="square" lIns="0" tIns="0" rIns="0" bIns="0" rtlCol="0" anchor="ctr"/>
-          <a:lstStyle/>
-          <a:p>
-            <a:pPr algn="ctr" indent="0" marL="0">
-              <a:buNone/>
-            </a:pPr>
-            <a:r>
-              <a:rPr lang="en-US" sz="1300" i="1" dirty="0">
-                <a:solidFill>
-                  <a:srgbClr val="5C564C"/>
-                </a:solidFill>
-                <a:latin typeface="Calibri" pitchFamily="34" charset="0"/>
-                <a:ea typeface="Calibri" pitchFamily="34" charset="-122"/>
-                <a:cs typeface="Calibri" pitchFamily="34" charset="-120"/>
-              </a:rPr>
-              <a:t>Screenshot: the opening brief, holdings filter on</a:t>
-            </a:r>
-            <a:endParaRPr lang="en-US" sz="1300" dirty="0"/>
-          </a:p>
-        </p:txBody>
-      </p:sp>
-      <p:sp>
-        <p:nvSpPr>
-          <p:cNvPr id="15" name="Text 13"/>
-          <p:cNvSpPr txBox="1"/>
-          <p:nvPr/>
-        </p:nvSpPr>
-        <p:spPr>
-          <a:xfrm>
-            <a:off x="640080" y="6144768"/>
-            <a:ext cx="10911535" cy="384048"/>
-          </a:xfrm>
-          <a:prstGeom prst="rect">
-            <a:avLst/>
-          </a:prstGeom>
-          <a:noFill/>
-          <a:ln/>
-        </p:spPr>
-        <p:txBody>
-          <a:bodyPr wrap="square" lIns="0" tIns="0" rIns="0" bIns="0" rtlCol="0" anchor="t"/>
-          <a:lstStyle/>
-          <a:p>
-            <a:pPr indent="0" marL="0">
-              <a:lnSpc>
-                <a:spcPts val="1800"/>
-              </a:lnSpc>
-              <a:buNone/>
-            </a:pPr>
-            <a:r>
-              <a:rPr lang="en-US" sz="1300" i="1" dirty="0">
-                <a:solidFill>
-                  <a:srgbClr val="141414"/>
-                </a:solidFill>
-                <a:latin typeface="Cambria" pitchFamily="34" charset="0"/>
-                <a:ea typeface="Cambria" pitchFamily="34" charset="-122"/>
-                <a:cs typeface="Cambria" pitchFamily="34" charset="-120"/>
-              </a:rPr>
-              <a:t>The ranking is deterministic. Nothing on this page was written by the model; it only narrates what Python computed.</a:t>
-            </a:r>
-            <a:endParaRPr lang="en-US" sz="1300" dirty="0"/>
+            <a:pPr algn="just"/>
+            <a:r>
+              <a:rPr lang="en-HK" sz="1200" dirty="0"/>
+              <a:t>The Bailey sits above its peer group, which is exposure at the next rent review.</a:t>
+            </a:r>
+            <a:endParaRPr lang="en-US" sz="1150" dirty="0"/>
           </a:p>
         </p:txBody>
       </p:sp>
@@ -4288,6 +4114,7 @@
         <a:solidFill>
           <a:srgbClr val="F6F2E8"/>
         </a:solidFill>
+        <a:effectLst/>
       </p:bgPr>
     </p:bg>
     <p:spTree>
@@ -4325,11 +4152,11 @@
           <a:bodyPr wrap="square" lIns="0" tIns="0" rIns="0" bIns="0" rtlCol="0" anchor="t"/>
           <a:lstStyle/>
           <a:p>
-            <a:pPr indent="0" marL="0">
+            <a:pPr marL="0" indent="0">
               <a:buNone/>
             </a:pPr>
             <a:r>
-              <a:rPr lang="en-US" sz="1100" b="1" spc="220" kern="0" dirty="0">
+              <a:rPr lang="en-US" sz="1100" b="1" kern="0" spc="220" dirty="0">
                 <a:solidFill>
                   <a:srgbClr val="5C564C"/>
                 </a:solidFill>
@@ -4337,7 +4164,7 @@
                 <a:ea typeface="Calibri" pitchFamily="34" charset="-122"/>
                 <a:cs typeface="Calibri" pitchFamily="34" charset="-120"/>
               </a:rPr>
-              <a:t>DEMO  ·  THE FOLLOW-UP</a:t>
+              <a:t>DEMO  ·  OCCUPIER DEMAND DRIVERS</a:t>
             </a:r>
             <a:endParaRPr lang="en-US" sz="1100" dirty="0"/>
           </a:p>
@@ -4364,11 +4191,11 @@
           <a:bodyPr wrap="square" lIns="0" tIns="0" rIns="0" bIns="0" rtlCol="0" anchor="t"/>
           <a:lstStyle/>
           <a:p>
-            <a:pPr indent="0" marL="0">
+            <a:pPr marL="0" indent="0">
               <a:buNone/>
             </a:pPr>
             <a:r>
-              <a:rPr lang="en-US" sz="3400" b="1" dirty="0">
+              <a:rPr lang="en-US" sz="3200" b="1" dirty="0">
                 <a:solidFill>
                   <a:srgbClr val="141414"/>
                 </a:solidFill>
@@ -4376,47 +4203,46 @@
                 <a:ea typeface="Cambria" pitchFamily="34" charset="-122"/>
                 <a:cs typeface="Cambria" pitchFamily="34" charset="-120"/>
               </a:rPr>
-              <a:t>Then you interrogate it. It holds up.</a:t>
-            </a:r>
-            <a:endParaRPr lang="en-US" sz="3400" dirty="0"/>
-          </a:p>
-        </p:txBody>
-      </p:sp>
-      <p:sp>
-        <p:nvSpPr>
-          <p:cNvPr id="4" name="Shape 2"/>
-          <p:cNvSpPr/>
-          <p:nvPr/>
-        </p:nvSpPr>
-        <p:spPr>
-          <a:xfrm>
-            <a:off x="640080" y="1700784"/>
-            <a:ext cx="5349240" cy="2670048"/>
+              <a:t>What’s driving demand right now?</a:t>
+            </a:r>
+            <a:endParaRPr lang="en-US" sz="3200" dirty="0"/>
+          </a:p>
+        </p:txBody>
+      </p:sp>
+      <p:pic>
+        <p:nvPicPr>
+          <p:cNvPr id="5" name="Image 0" descr="/Users/ethanlee/Desktop/projects/cre_market_agent/slides/assets/demo-demand-drivers.png"/>
+          <p:cNvPicPr>
+            <a:picLocks noChangeAspect="1"/>
+          </p:cNvPicPr>
+          <p:nvPr/>
+        </p:nvPicPr>
+        <p:blipFill>
+          <a:blip r:embed="rId3"/>
+          <a:stretch>
+            <a:fillRect/>
+          </a:stretch>
+        </p:blipFill>
+        <p:spPr>
+          <a:xfrm>
+            <a:off x="640080" y="1554480"/>
+            <a:ext cx="4892040" cy="4024052"/>
           </a:xfrm>
           <a:prstGeom prst="rect">
             <a:avLst/>
           </a:prstGeom>
-          <a:solidFill>
-            <a:srgbClr val="EDE7D8"/>
-          </a:solidFill>
-          <a:ln w="12700">
-            <a:solidFill>
-              <a:srgbClr val="C6BDA9"/>
-            </a:solidFill>
-            <a:prstDash val="dash"/>
-          </a:ln>
-        </p:spPr>
-      </p:sp>
-      <p:sp>
-        <p:nvSpPr>
-          <p:cNvPr id="5" name="Text 3"/>
+        </p:spPr>
+      </p:pic>
+      <p:sp>
+        <p:nvSpPr>
+          <p:cNvPr id="6" name="Text 3"/>
           <p:cNvSpPr txBox="1"/>
           <p:nvPr/>
         </p:nvSpPr>
         <p:spPr>
           <a:xfrm>
-            <a:off x="914400" y="2761488"/>
-            <a:ext cx="4800600" cy="548640"/>
+            <a:off x="5989320" y="1435608"/>
+            <a:ext cx="5562295" cy="219456"/>
           </a:xfrm>
           <a:prstGeom prst="rect">
             <a:avLst/>
@@ -4425,62 +4251,36 @@
           <a:ln/>
         </p:spPr>
         <p:txBody>
-          <a:bodyPr wrap="square" lIns="0" tIns="0" rIns="0" bIns="0" rtlCol="0" anchor="ctr"/>
-          <a:lstStyle/>
-          <a:p>
-            <a:pPr algn="ctr" indent="0" marL="0">
+          <a:bodyPr wrap="square" lIns="0" tIns="0" rIns="0" bIns="0" rtlCol="0" anchor="t"/>
+          <a:lstStyle/>
+          <a:p>
+            <a:pPr marL="0" indent="0">
               <a:buNone/>
             </a:pPr>
             <a:r>
-              <a:rPr lang="en-US" sz="1300" i="1" dirty="0">
+              <a:rPr lang="en-US" sz="1100" b="1" kern="0" spc="160" dirty="0">
                 <a:solidFill>
                   <a:srgbClr val="5C564C"/>
                 </a:solidFill>
                 <a:latin typeface="Calibri" pitchFamily="34" charset="0"/>
-                <a:ea typeface="Calibri" pitchFamily="34" charset="-122"/>
                 <a:cs typeface="Calibri" pitchFamily="34" charset="-120"/>
               </a:rPr>
-              <a:t>Screenshot: an answer with its tool calls above it</a:t>
-            </a:r>
-            <a:endParaRPr lang="en-US" sz="1300" dirty="0"/>
-          </a:p>
-        </p:txBody>
-      </p:sp>
-      <p:sp>
-        <p:nvSpPr>
-          <p:cNvPr id="6" name="Shape 4"/>
-          <p:cNvSpPr/>
-          <p:nvPr/>
-        </p:nvSpPr>
-        <p:spPr>
-          <a:xfrm>
-            <a:off x="6202375" y="1700784"/>
-            <a:ext cx="5349240" cy="2670048"/>
-          </a:xfrm>
-          <a:prstGeom prst="rect">
-            <a:avLst/>
-          </a:prstGeom>
-          <a:solidFill>
-            <a:srgbClr val="EDE7D8"/>
-          </a:solidFill>
-          <a:ln w="12700">
-            <a:solidFill>
-              <a:srgbClr val="C6BDA9"/>
-            </a:solidFill>
-            <a:prstDash val="dash"/>
-          </a:ln>
-        </p:spPr>
-      </p:sp>
-      <p:sp>
-        <p:nvSpPr>
-          <p:cNvPr id="7" name="Text 5"/>
+              <a:t>RELIABLE DEMAND ANALYSIS IN SECONDS</a:t>
+            </a:r>
+            <a:endParaRPr lang="en-US" sz="1100" dirty="0"/>
+          </a:p>
+        </p:txBody>
+      </p:sp>
+      <p:sp>
+        <p:nvSpPr>
+          <p:cNvPr id="7" name="Text 4"/>
           <p:cNvSpPr txBox="1"/>
           <p:nvPr/>
         </p:nvSpPr>
         <p:spPr>
           <a:xfrm>
-            <a:off x="6476695" y="2761488"/>
-            <a:ext cx="4800600" cy="548640"/>
+            <a:off x="5989320" y="1700784"/>
+            <a:ext cx="365760" cy="365760"/>
           </a:xfrm>
           <a:prstGeom prst="rect">
             <a:avLst/>
@@ -4489,37 +4289,37 @@
           <a:ln/>
         </p:spPr>
         <p:txBody>
-          <a:bodyPr wrap="square" lIns="0" tIns="0" rIns="0" bIns="0" rtlCol="0" anchor="ctr"/>
-          <a:lstStyle/>
-          <a:p>
-            <a:pPr algn="ctr" indent="0" marL="0">
+          <a:bodyPr wrap="square" lIns="0" tIns="0" rIns="0" bIns="0" rtlCol="0" anchor="t"/>
+          <a:lstStyle/>
+          <a:p>
+            <a:pPr marL="0" indent="0">
               <a:buNone/>
             </a:pPr>
             <a:r>
-              <a:rPr lang="en-US" sz="1300" i="1" dirty="0">
+              <a:rPr lang="en-US" sz="2100" b="1" dirty="0">
                 <a:solidFill>
-                  <a:srgbClr val="5C564C"/>
+                  <a:srgbClr val="9B2C2C"/>
                 </a:solidFill>
-                <a:latin typeface="Calibri" pitchFamily="34" charset="0"/>
-                <a:ea typeface="Calibri" pitchFamily="34" charset="-122"/>
-                <a:cs typeface="Calibri" pitchFamily="34" charset="-120"/>
+                <a:latin typeface="Cambria" pitchFamily="34" charset="0"/>
+                <a:ea typeface="Cambria" pitchFamily="34" charset="-122"/>
+                <a:cs typeface="Cambria" pitchFamily="34" charset="-120"/>
               </a:rPr>
-              <a:t>Screenshot: the agent declining a question it cannot source</a:t>
-            </a:r>
-            <a:endParaRPr lang="en-US" sz="1300" dirty="0"/>
-          </a:p>
-        </p:txBody>
-      </p:sp>
-      <p:sp>
-        <p:nvSpPr>
-          <p:cNvPr id="8" name="Text 6"/>
+              <a:t>1</a:t>
+            </a:r>
+            <a:endParaRPr lang="en-US" sz="2100" dirty="0"/>
+          </a:p>
+        </p:txBody>
+      </p:sp>
+      <p:sp>
+        <p:nvSpPr>
+          <p:cNvPr id="8" name="Text 5"/>
           <p:cNvSpPr txBox="1"/>
           <p:nvPr/>
         </p:nvSpPr>
         <p:spPr>
           <a:xfrm>
-            <a:off x="640080" y="4626864"/>
-            <a:ext cx="5349240" cy="219456"/>
+            <a:off x="6373368" y="1746504"/>
+            <a:ext cx="5178247" cy="274320"/>
           </a:xfrm>
           <a:prstGeom prst="rect">
             <a:avLst/>
@@ -4531,53 +4331,11 @@
           <a:bodyPr wrap="square" lIns="0" tIns="0" rIns="0" bIns="0" rtlCol="0" anchor="t"/>
           <a:lstStyle/>
           <a:p>
-            <a:pPr indent="0" marL="0">
+            <a:pPr marL="0" indent="0">
               <a:buNone/>
             </a:pPr>
             <a:r>
-              <a:rPr lang="en-US" sz="1100" b="1" spc="160" kern="0" dirty="0">
-                <a:solidFill>
-                  <a:srgbClr val="5C564C"/>
-                </a:solidFill>
-                <a:latin typeface="Calibri" pitchFamily="34" charset="0"/>
-                <a:ea typeface="Calibri" pitchFamily="34" charset="-122"/>
-                <a:cs typeface="Calibri" pitchFamily="34" charset="-120"/>
-              </a:rPr>
-              <a:t>ASK IT ANYTHING IN SCOPE</a:t>
-            </a:r>
-            <a:endParaRPr lang="en-US" sz="1100" dirty="0"/>
-          </a:p>
-        </p:txBody>
-      </p:sp>
-      <p:sp>
-        <p:nvSpPr>
-          <p:cNvPr id="9" name="Text 7"/>
-          <p:cNvSpPr txBox="1"/>
-          <p:nvPr/>
-        </p:nvSpPr>
-        <p:spPr>
-          <a:xfrm>
-            <a:off x="640080" y="4919472"/>
-            <a:ext cx="5212080" cy="1188720"/>
-          </a:xfrm>
-          <a:prstGeom prst="rect">
-            <a:avLst/>
-          </a:prstGeom>
-          <a:noFill/>
-          <a:ln/>
-        </p:spPr>
-        <p:txBody>
-          <a:bodyPr wrap="square" lIns="0" tIns="0" rIns="0" bIns="0" rtlCol="0" anchor="t"/>
-          <a:lstStyle/>
-          <a:p>
-            <a:pPr indent="0" marL="0">
-              <a:lnSpc>
-                <a:spcPts val="1700"/>
-              </a:lnSpc>
-              <a:buNone/>
-            </a:pPr>
-            <a:r>
-              <a:rPr lang="en-US" sz="1250" dirty="0">
+              <a:rPr lang="en-US" sz="1400" b="1" dirty="0">
                 <a:solidFill>
                   <a:srgbClr val="141414"/>
                 </a:solidFill>
@@ -4585,22 +4343,22 @@
                 <a:ea typeface="Calibri" pitchFamily="34" charset="-122"/>
                 <a:cs typeface="Calibri" pitchFamily="34" charset="-120"/>
               </a:rPr>
-              <a:t>The tool calls sit above the answer, so you can see exactly which figures were looked up. Every number arrives with its source and its as-of date attached: the same figures the brief used, from the same store.</a:t>
-            </a:r>
-            <a:endParaRPr lang="en-US" sz="1250" dirty="0"/>
-          </a:p>
-        </p:txBody>
-      </p:sp>
-      <p:sp>
-        <p:nvSpPr>
-          <p:cNvPr id="10" name="Text 8"/>
+              <a:t>Resolved what you mean.</a:t>
+            </a:r>
+            <a:endParaRPr lang="en-US" sz="1400" dirty="0"/>
+          </a:p>
+        </p:txBody>
+      </p:sp>
+      <p:sp>
+        <p:nvSpPr>
+          <p:cNvPr id="9" name="Text 6"/>
           <p:cNvSpPr txBox="1"/>
           <p:nvPr/>
         </p:nvSpPr>
         <p:spPr>
           <a:xfrm>
-            <a:off x="6202375" y="4626864"/>
-            <a:ext cx="5349240" cy="219456"/>
+            <a:off x="6373368" y="2039112"/>
+            <a:ext cx="5178247" cy="640080"/>
           </a:xfrm>
           <a:prstGeom prst="rect">
             <a:avLst/>
@@ -4612,34 +4370,64 @@
           <a:bodyPr wrap="square" lIns="0" tIns="0" rIns="0" bIns="0" rtlCol="0" anchor="t"/>
           <a:lstStyle/>
           <a:p>
-            <a:pPr indent="0" marL="0">
+            <a:pPr algn="just"/>
+            <a:r>
+              <a:rPr lang="en-HK" sz="1200" dirty="0"/>
+              <a:t>It checked what figures exist on database, then scoped every lookup to Central London at the latest published half.</a:t>
+            </a:r>
+            <a:endParaRPr lang="en-US" sz="1150" dirty="0"/>
+          </a:p>
+        </p:txBody>
+      </p:sp>
+      <p:sp>
+        <p:nvSpPr>
+          <p:cNvPr id="11" name="Text 8"/>
+          <p:cNvSpPr txBox="1"/>
+          <p:nvPr/>
+        </p:nvSpPr>
+        <p:spPr>
+          <a:xfrm>
+            <a:off x="5989320" y="2706624"/>
+            <a:ext cx="365760" cy="365760"/>
+          </a:xfrm>
+          <a:prstGeom prst="rect">
+            <a:avLst/>
+          </a:prstGeom>
+          <a:noFill/>
+          <a:ln/>
+        </p:spPr>
+        <p:txBody>
+          <a:bodyPr wrap="square" lIns="0" tIns="0" rIns="0" bIns="0" rtlCol="0" anchor="t"/>
+          <a:lstStyle/>
+          <a:p>
+            <a:pPr marL="0" indent="0">
               <a:buNone/>
             </a:pPr>
             <a:r>
-              <a:rPr lang="en-US" sz="1100" b="1" spc="160" kern="0" dirty="0">
+              <a:rPr lang="en-US" sz="2100" b="1" dirty="0">
                 <a:solidFill>
-                  <a:srgbClr val="5C564C"/>
+                  <a:srgbClr val="9B2C2C"/>
                 </a:solidFill>
-                <a:latin typeface="Calibri" pitchFamily="34" charset="0"/>
-                <a:ea typeface="Calibri" pitchFamily="34" charset="-122"/>
-                <a:cs typeface="Calibri" pitchFamily="34" charset="-120"/>
+                <a:latin typeface="Cambria" pitchFamily="34" charset="0"/>
+                <a:ea typeface="Cambria" pitchFamily="34" charset="-122"/>
+                <a:cs typeface="Cambria" pitchFamily="34" charset="-120"/>
               </a:rPr>
-              <a:t>THEN ASK IT SOMETHING IT CANNOT KNOW</a:t>
-            </a:r>
-            <a:endParaRPr lang="en-US" sz="1100" dirty="0"/>
-          </a:p>
-        </p:txBody>
-      </p:sp>
-      <p:sp>
-        <p:nvSpPr>
-          <p:cNvPr id="11" name="Text 9"/>
+              <a:t>2</a:t>
+            </a:r>
+            <a:endParaRPr lang="en-US" sz="2100" dirty="0"/>
+          </a:p>
+        </p:txBody>
+      </p:sp>
+      <p:sp>
+        <p:nvSpPr>
+          <p:cNvPr id="12" name="Text 9"/>
           <p:cNvSpPr txBox="1"/>
           <p:nvPr/>
         </p:nvSpPr>
         <p:spPr>
           <a:xfrm>
-            <a:off x="6202375" y="4919472"/>
-            <a:ext cx="5212080" cy="1188720"/>
+            <a:off x="6373368" y="2752344"/>
+            <a:ext cx="5178247" cy="274320"/>
           </a:xfrm>
           <a:prstGeom prst="rect">
             <a:avLst/>
@@ -4651,14 +4439,11 @@
           <a:bodyPr wrap="square" lIns="0" tIns="0" rIns="0" bIns="0" rtlCol="0" anchor="t"/>
           <a:lstStyle/>
           <a:p>
-            <a:pPr indent="0" marL="0">
-              <a:lnSpc>
-                <a:spcPts val="1700"/>
-              </a:lnSpc>
+            <a:pPr marL="0" indent="0">
               <a:buNone/>
             </a:pPr>
             <a:r>
-              <a:rPr lang="en-US" sz="1250" dirty="0">
+              <a:rPr lang="en-US" sz="1400" b="1" dirty="0">
                 <a:solidFill>
                   <a:srgbClr val="141414"/>
                 </a:solidFill>
@@ -4666,22 +4451,22 @@
                 <a:ea typeface="Calibri" pitchFamily="34" charset="-122"/>
                 <a:cs typeface="Calibri" pitchFamily="34" charset="-120"/>
               </a:rPr>
-              <a:t>It declines. No invented figure, no plausible-sounding estimate, no unattributed source. “I don’t have that” is a correct answer, and it is the behaviour that makes the other answers worth trusting.</a:t>
-            </a:r>
-            <a:endParaRPr lang="en-US" sz="1250" dirty="0"/>
-          </a:p>
-        </p:txBody>
-      </p:sp>
-      <p:sp>
-        <p:nvSpPr>
-          <p:cNvPr id="12" name="Text 10"/>
+              <a:t>It pulled six market figures and the deals behind them.</a:t>
+            </a:r>
+            <a:endParaRPr lang="en-US" sz="1400" dirty="0"/>
+          </a:p>
+        </p:txBody>
+      </p:sp>
+      <p:sp>
+        <p:nvSpPr>
+          <p:cNvPr id="13" name="Text 10"/>
           <p:cNvSpPr txBox="1"/>
           <p:nvPr/>
         </p:nvSpPr>
         <p:spPr>
           <a:xfrm>
-            <a:off x="640080" y="6144768"/>
-            <a:ext cx="10911535" cy="384048"/>
+            <a:off x="6373368" y="3044952"/>
+            <a:ext cx="5178247" cy="640080"/>
           </a:xfrm>
           <a:prstGeom prst="rect">
             <a:avLst/>
@@ -4693,24 +4478,266 @@
           <a:bodyPr wrap="square" lIns="0" tIns="0" rIns="0" bIns="0" rtlCol="0" anchor="t"/>
           <a:lstStyle/>
           <a:p>
-            <a:pPr indent="0" marL="0">
-              <a:lnSpc>
-                <a:spcPts val="1800"/>
-              </a:lnSpc>
+            <a:pPr algn="just"/>
+            <a:r>
+              <a:rPr lang="en-HK" sz="1200" dirty="0"/>
+              <a:t>Active demand, take-up, the share of occupiers expanding, large requirements, space under offer, one sector's take-up, and the named lettings. Each with its source and its date.</a:t>
+            </a:r>
+            <a:endParaRPr lang="en-US" sz="1200" dirty="0"/>
+          </a:p>
+        </p:txBody>
+      </p:sp>
+      <p:sp>
+        <p:nvSpPr>
+          <p:cNvPr id="15" name="Text 12"/>
+          <p:cNvSpPr txBox="1"/>
+          <p:nvPr/>
+        </p:nvSpPr>
+        <p:spPr>
+          <a:xfrm>
+            <a:off x="5989320" y="3712464"/>
+            <a:ext cx="365760" cy="365760"/>
+          </a:xfrm>
+          <a:prstGeom prst="rect">
+            <a:avLst/>
+          </a:prstGeom>
+          <a:noFill/>
+          <a:ln/>
+        </p:spPr>
+        <p:txBody>
+          <a:bodyPr wrap="square" lIns="0" tIns="0" rIns="0" bIns="0" rtlCol="0" anchor="t"/>
+          <a:lstStyle/>
+          <a:p>
+            <a:pPr marL="0" indent="0">
               <a:buNone/>
             </a:pPr>
             <a:r>
-              <a:rPr lang="en-US" sz="1300" i="1" dirty="0">
+              <a:rPr lang="en-US" sz="2100" b="1" dirty="0">
                 <a:solidFill>
-                  <a:srgbClr val="141414"/>
+                  <a:srgbClr val="9B2C2C"/>
                 </a:solidFill>
                 <a:latin typeface="Cambria" pitchFamily="34" charset="0"/>
                 <a:ea typeface="Cambria" pitchFamily="34" charset="-122"/>
                 <a:cs typeface="Cambria" pitchFamily="34" charset="-120"/>
               </a:rPr>
-              <a:t>Every number stated in the demo comes from a tool call, never from the model’s memory.</a:t>
-            </a:r>
-            <a:endParaRPr lang="en-US" sz="1300" dirty="0"/>
+              <a:t>3</a:t>
+            </a:r>
+            <a:endParaRPr lang="en-US" sz="2100" dirty="0"/>
+          </a:p>
+        </p:txBody>
+      </p:sp>
+      <p:sp>
+        <p:nvSpPr>
+          <p:cNvPr id="16" name="Text 13"/>
+          <p:cNvSpPr txBox="1"/>
+          <p:nvPr/>
+        </p:nvSpPr>
+        <p:spPr>
+          <a:xfrm>
+            <a:off x="6373368" y="3758184"/>
+            <a:ext cx="5178247" cy="274320"/>
+          </a:xfrm>
+          <a:prstGeom prst="rect">
+            <a:avLst/>
+          </a:prstGeom>
+          <a:noFill/>
+          <a:ln/>
+        </p:spPr>
+        <p:txBody>
+          <a:bodyPr wrap="square" lIns="0" tIns="0" rIns="0" bIns="0" rtlCol="0" anchor="t"/>
+          <a:lstStyle/>
+          <a:p>
+            <a:r>
+              <a:rPr lang="en-HK" sz="1400" b="1" dirty="0">
+                <a:latin typeface="Calibri" panose="020F0502020204030204" pitchFamily="34" charset="0"/>
+                <a:cs typeface="Calibri" panose="020F0502020204030204" pitchFamily="34" charset="0"/>
+              </a:rPr>
+              <a:t>Found a gap, and stayed with the source.</a:t>
+            </a:r>
+            <a:endParaRPr lang="en-US" sz="1400" b="1" dirty="0">
+              <a:latin typeface="Calibri" panose="020F0502020204030204" pitchFamily="34" charset="0"/>
+              <a:cs typeface="Calibri" panose="020F0502020204030204" pitchFamily="34" charset="0"/>
+            </a:endParaRPr>
+          </a:p>
+        </p:txBody>
+      </p:sp>
+      <p:sp>
+        <p:nvSpPr>
+          <p:cNvPr id="17" name="Text 14"/>
+          <p:cNvSpPr txBox="1"/>
+          <p:nvPr/>
+        </p:nvSpPr>
+        <p:spPr>
+          <a:xfrm>
+            <a:off x="6373368" y="4050792"/>
+            <a:ext cx="5178247" cy="640080"/>
+          </a:xfrm>
+          <a:prstGeom prst="rect">
+            <a:avLst/>
+          </a:prstGeom>
+          <a:noFill/>
+          <a:ln/>
+        </p:spPr>
+        <p:txBody>
+          <a:bodyPr wrap="square" lIns="0" tIns="0" rIns="0" bIns="0" rtlCol="0" anchor="t"/>
+          <a:lstStyle/>
+          <a:p>
+            <a:pPr marL="0" indent="0" algn="just">
+              <a:lnSpc>
+                <a:spcPts val="1550"/>
+              </a:lnSpc>
+              <a:buNone/>
+            </a:pPr>
+            <a:r>
+              <a:rPr lang="en-US" sz="1200" dirty="0">
+                <a:solidFill>
+                  <a:srgbClr val="141414"/>
+                </a:solidFill>
+                <a:latin typeface="Calibri" pitchFamily="34" charset="0"/>
+                <a:ea typeface="Calibri" pitchFamily="34" charset="-122"/>
+                <a:cs typeface="Calibri" pitchFamily="34" charset="-120"/>
+              </a:rPr>
+              <a:t>Tech &amp; Media take-up is </a:t>
+            </a:r>
+            <a:r>
+              <a:rPr lang="en-US" sz="1200" b="1" dirty="0">
+                <a:solidFill>
+                  <a:srgbClr val="141414"/>
+                </a:solidFill>
+                <a:latin typeface="Calibri" pitchFamily="34" charset="0"/>
+                <a:ea typeface="Calibri" pitchFamily="34" charset="-122"/>
+                <a:cs typeface="Calibri" pitchFamily="34" charset="-120"/>
+              </a:rPr>
+              <a:t>not published</a:t>
+            </a:r>
+            <a:r>
+              <a:rPr lang="en-US" sz="1200" dirty="0">
+                <a:solidFill>
+                  <a:srgbClr val="141414"/>
+                </a:solidFill>
+                <a:latin typeface="Calibri" pitchFamily="34" charset="0"/>
+                <a:ea typeface="Calibri" pitchFamily="34" charset="-122"/>
+                <a:cs typeface="Calibri" pitchFamily="34" charset="-120"/>
+              </a:rPr>
+              <a:t> for this half. Instead of estimating one, it reported the change the source does give: 64% above the long-run average.</a:t>
+            </a:r>
+            <a:endParaRPr lang="en-US" sz="1200" dirty="0"/>
+          </a:p>
+        </p:txBody>
+      </p:sp>
+      <p:sp>
+        <p:nvSpPr>
+          <p:cNvPr id="19" name="Text 16"/>
+          <p:cNvSpPr txBox="1"/>
+          <p:nvPr/>
+        </p:nvSpPr>
+        <p:spPr>
+          <a:xfrm>
+            <a:off x="5989320" y="4718304"/>
+            <a:ext cx="365760" cy="365760"/>
+          </a:xfrm>
+          <a:prstGeom prst="rect">
+            <a:avLst/>
+          </a:prstGeom>
+          <a:noFill/>
+          <a:ln/>
+        </p:spPr>
+        <p:txBody>
+          <a:bodyPr wrap="square" lIns="0" tIns="0" rIns="0" bIns="0" rtlCol="0" anchor="t"/>
+          <a:lstStyle/>
+          <a:p>
+            <a:pPr marL="0" indent="0">
+              <a:buNone/>
+            </a:pPr>
+            <a:r>
+              <a:rPr lang="en-US" sz="2100" b="1" dirty="0">
+                <a:solidFill>
+                  <a:srgbClr val="9B2C2C"/>
+                </a:solidFill>
+                <a:latin typeface="Cambria" pitchFamily="34" charset="0"/>
+                <a:ea typeface="Cambria" pitchFamily="34" charset="-122"/>
+                <a:cs typeface="Cambria" pitchFamily="34" charset="-120"/>
+              </a:rPr>
+              <a:t>4</a:t>
+            </a:r>
+            <a:endParaRPr lang="en-US" sz="2100" dirty="0"/>
+          </a:p>
+        </p:txBody>
+      </p:sp>
+      <p:sp>
+        <p:nvSpPr>
+          <p:cNvPr id="20" name="Text 17"/>
+          <p:cNvSpPr txBox="1"/>
+          <p:nvPr/>
+        </p:nvSpPr>
+        <p:spPr>
+          <a:xfrm>
+            <a:off x="6373368" y="4764024"/>
+            <a:ext cx="5178247" cy="274320"/>
+          </a:xfrm>
+          <a:prstGeom prst="rect">
+            <a:avLst/>
+          </a:prstGeom>
+          <a:noFill/>
+          <a:ln/>
+        </p:spPr>
+        <p:txBody>
+          <a:bodyPr wrap="square" lIns="0" tIns="0" rIns="0" bIns="0" rtlCol="0" anchor="t"/>
+          <a:lstStyle/>
+          <a:p>
+            <a:r>
+              <a:rPr lang="en-HK" sz="1400" b="1" dirty="0">
+                <a:latin typeface="Calibri" panose="020F0502020204030204" pitchFamily="34" charset="0"/>
+                <a:cs typeface="Calibri" panose="020F0502020204030204" pitchFamily="34" charset="0"/>
+              </a:rPr>
+              <a:t>Turned findings into strategies for your portfolio.</a:t>
+            </a:r>
+            <a:endParaRPr lang="en-US" sz="1400" b="1" dirty="0">
+              <a:latin typeface="Calibri" panose="020F0502020204030204" pitchFamily="34" charset="0"/>
+              <a:cs typeface="Calibri" panose="020F0502020204030204" pitchFamily="34" charset="0"/>
+            </a:endParaRPr>
+          </a:p>
+        </p:txBody>
+      </p:sp>
+      <p:sp>
+        <p:nvSpPr>
+          <p:cNvPr id="21" name="Text 18"/>
+          <p:cNvSpPr txBox="1"/>
+          <p:nvPr/>
+        </p:nvSpPr>
+        <p:spPr>
+          <a:xfrm>
+            <a:off x="6373368" y="5056632"/>
+            <a:ext cx="5178247" cy="640080"/>
+          </a:xfrm>
+          <a:prstGeom prst="rect">
+            <a:avLst/>
+          </a:prstGeom>
+          <a:noFill/>
+          <a:ln/>
+        </p:spPr>
+        <p:txBody>
+          <a:bodyPr wrap="square" lIns="0" tIns="0" rIns="0" bIns="0" rtlCol="0" anchor="t"/>
+          <a:lstStyle/>
+          <a:p>
+            <a:pPr marL="0" indent="0" algn="just">
+              <a:lnSpc>
+                <a:spcPts val="1550"/>
+              </a:lnSpc>
+              <a:buNone/>
+            </a:pPr>
+            <a:r>
+              <a:rPr lang="en-US" sz="1200" dirty="0">
+                <a:solidFill>
+                  <a:srgbClr val="141414"/>
+                </a:solidFill>
+                <a:latin typeface="Calibri" pitchFamily="34" charset="0"/>
+                <a:ea typeface="Calibri" pitchFamily="34" charset="-122"/>
+                <a:cs typeface="Calibri" pitchFamily="34" charset="-120"/>
+              </a:rPr>
+              <a:t>The response closes on 99 City Road and Regent Quarter, and on a decision, rather than on Central London in general.</a:t>
+            </a:r>
+            <a:endParaRPr lang="en-US" sz="1200" dirty="0"/>
           </a:p>
         </p:txBody>
       </p:sp>
@@ -5015,4 +5042,319 @@
     </a:ext>
   </a:extLst>
 </a:theme>
+</file>
+
+<file path=ppt/theme/theme2.xml><?xml version="1.0" encoding="utf-8"?>
+<a:theme xmlns:a="http://schemas.openxmlformats.org/drawingml/2006/main" name="Office Theme">
+  <a:themeElements>
+    <a:clrScheme name="Office">
+      <a:dk1>
+        <a:sysClr val="windowText" lastClr="000000"/>
+      </a:dk1>
+      <a:lt1>
+        <a:sysClr val="window" lastClr="FFFFFF"/>
+      </a:lt1>
+      <a:dk2>
+        <a:srgbClr val="0E2841"/>
+      </a:dk2>
+      <a:lt2>
+        <a:srgbClr val="E8E8E8"/>
+      </a:lt2>
+      <a:accent1>
+        <a:srgbClr val="156082"/>
+      </a:accent1>
+      <a:accent2>
+        <a:srgbClr val="E97132"/>
+      </a:accent2>
+      <a:accent3>
+        <a:srgbClr val="196B24"/>
+      </a:accent3>
+      <a:accent4>
+        <a:srgbClr val="0F9ED5"/>
+      </a:accent4>
+      <a:accent5>
+        <a:srgbClr val="A02B93"/>
+      </a:accent5>
+      <a:accent6>
+        <a:srgbClr val="4EA72E"/>
+      </a:accent6>
+      <a:hlink>
+        <a:srgbClr val="467886"/>
+      </a:hlink>
+      <a:folHlink>
+        <a:srgbClr val="96607D"/>
+      </a:folHlink>
+    </a:clrScheme>
+    <a:fontScheme name="Office">
+      <a:majorFont>
+        <a:latin typeface="Aptos Display" panose="02110004020202020204"/>
+        <a:ea typeface=""/>
+        <a:cs typeface=""/>
+        <a:font script="Jpan" typeface="游ゴシック Light"/>
+        <a:font script="Hang" typeface="맑은 고딕"/>
+        <a:font script="Hans" typeface="等线 Light"/>
+        <a:font script="Hant" typeface="新細明體"/>
+        <a:font script="Arab" typeface="Times New Roman"/>
+        <a:font script="Hebr" typeface="Times New Roman"/>
+        <a:font script="Thai" typeface="Angsana New"/>
+        <a:font script="Ethi" typeface="Nyala"/>
+        <a:font script="Beng" typeface="Vrinda"/>
+        <a:font script="Gujr" typeface="Shruti"/>
+        <a:font script="Khmr" typeface="MoolBoran"/>
+        <a:font script="Knda" typeface="Tunga"/>
+        <a:font script="Guru" typeface="Raavi"/>
+        <a:font script="Cans" typeface="Euphemia"/>
+        <a:font script="Cher" typeface="Plantagenet Cherokee"/>
+        <a:font script="Yiii" typeface="Microsoft Yi Baiti"/>
+        <a:font script="Tibt" typeface="Microsoft Himalaya"/>
+        <a:font script="Thaa" typeface="MV Boli"/>
+        <a:font script="Deva" typeface="Mangal"/>
+        <a:font script="Telu" typeface="Gautami"/>
+        <a:font script="Taml" typeface="Latha"/>
+        <a:font script="Syrc" typeface="Estrangelo Edessa"/>
+        <a:font script="Orya" typeface="Kalinga"/>
+        <a:font script="Mlym" typeface="Kartika"/>
+        <a:font script="Laoo" typeface="DokChampa"/>
+        <a:font script="Sinh" typeface="Iskoola Pota"/>
+        <a:font script="Mong" typeface="Mongolian Baiti"/>
+        <a:font script="Viet" typeface="Times New Roman"/>
+        <a:font script="Uigh" typeface="Microsoft Uighur"/>
+        <a:font script="Geor" typeface="Sylfaen"/>
+        <a:font script="Armn" typeface="Arial"/>
+        <a:font script="Bugi" typeface="Leelawadee UI"/>
+        <a:font script="Bopo" typeface="Microsoft JhengHei"/>
+        <a:font script="Java" typeface="Javanese Text"/>
+        <a:font script="Lisu" typeface="Segoe UI"/>
+        <a:font script="Mymr" typeface="Myanmar Text"/>
+        <a:font script="Nkoo" typeface="Ebrima"/>
+        <a:font script="Olck" typeface="Nirmala UI"/>
+        <a:font script="Osma" typeface="Ebrima"/>
+        <a:font script="Phag" typeface="Phagspa"/>
+        <a:font script="Syrn" typeface="Estrangelo Edessa"/>
+        <a:font script="Syrj" typeface="Estrangelo Edessa"/>
+        <a:font script="Syre" typeface="Estrangelo Edessa"/>
+        <a:font script="Sora" typeface="Nirmala UI"/>
+        <a:font script="Tale" typeface="Microsoft Tai Le"/>
+        <a:font script="Talu" typeface="Microsoft New Tai Lue"/>
+        <a:font script="Tfng" typeface="Ebrima"/>
+      </a:majorFont>
+      <a:minorFont>
+        <a:latin typeface="Aptos" panose="02110004020202020204"/>
+        <a:ea typeface=""/>
+        <a:cs typeface=""/>
+        <a:font script="Jpan" typeface="游ゴシック"/>
+        <a:font script="Hang" typeface="맑은 고딕"/>
+        <a:font script="Hans" typeface="等线"/>
+        <a:font script="Hant" typeface="新細明體"/>
+        <a:font script="Arab" typeface="Arial"/>
+        <a:font script="Hebr" typeface="Arial"/>
+        <a:font script="Thai" typeface="Cordia New"/>
+        <a:font script="Ethi" typeface="Nyala"/>
+        <a:font script="Beng" typeface="Vrinda"/>
+        <a:font script="Gujr" typeface="Shruti"/>
+        <a:font script="Khmr" typeface="DaunPenh"/>
+        <a:font script="Knda" typeface="Tunga"/>
+        <a:font script="Guru" typeface="Raavi"/>
+        <a:font script="Cans" typeface="Euphemia"/>
+        <a:font script="Cher" typeface="Plantagenet Cherokee"/>
+        <a:font script="Yiii" typeface="Microsoft Yi Baiti"/>
+        <a:font script="Tibt" typeface="Microsoft Himalaya"/>
+        <a:font script="Thaa" typeface="MV Boli"/>
+        <a:font script="Deva" typeface="Mangal"/>
+        <a:font script="Telu" typeface="Gautami"/>
+        <a:font script="Taml" typeface="Latha"/>
+        <a:font script="Syrc" typeface="Estrangelo Edessa"/>
+        <a:font script="Orya" typeface="Kalinga"/>
+        <a:font script="Mlym" typeface="Kartika"/>
+        <a:font script="Laoo" typeface="DokChampa"/>
+        <a:font script="Sinh" typeface="Iskoola Pota"/>
+        <a:font script="Mong" typeface="Mongolian Baiti"/>
+        <a:font script="Viet" typeface="Arial"/>
+        <a:font script="Uigh" typeface="Microsoft Uighur"/>
+        <a:font script="Geor" typeface="Sylfaen"/>
+        <a:font script="Armn" typeface="Arial"/>
+        <a:font script="Bugi" typeface="Leelawadee UI"/>
+        <a:font script="Bopo" typeface="Microsoft JhengHei"/>
+        <a:font script="Java" typeface="Javanese Text"/>
+        <a:font script="Lisu" typeface="Segoe UI"/>
+        <a:font script="Mymr" typeface="Myanmar Text"/>
+        <a:font script="Nkoo" typeface="Ebrima"/>
+        <a:font script="Olck" typeface="Nirmala UI"/>
+        <a:font script="Osma" typeface="Ebrima"/>
+        <a:font script="Phag" typeface="Phagspa"/>
+        <a:font script="Syrn" typeface="Estrangelo Edessa"/>
+        <a:font script="Syrj" typeface="Estrangelo Edessa"/>
+        <a:font script="Syre" typeface="Estrangelo Edessa"/>
+        <a:font script="Sora" typeface="Nirmala UI"/>
+        <a:font script="Tale" typeface="Microsoft Tai Le"/>
+        <a:font script="Talu" typeface="Microsoft New Tai Lue"/>
+        <a:font script="Tfng" typeface="Ebrima"/>
+      </a:minorFont>
+    </a:fontScheme>
+    <a:fmtScheme name="Office">
+      <a:fillStyleLst>
+        <a:solidFill>
+          <a:schemeClr val="phClr"/>
+        </a:solidFill>
+        <a:gradFill rotWithShape="1">
+          <a:gsLst>
+            <a:gs pos="0">
+              <a:schemeClr val="phClr">
+                <a:lumMod val="110000"/>
+                <a:satMod val="105000"/>
+                <a:tint val="67000"/>
+              </a:schemeClr>
+            </a:gs>
+            <a:gs pos="50000">
+              <a:schemeClr val="phClr">
+                <a:lumMod val="105000"/>
+                <a:satMod val="103000"/>
+                <a:tint val="73000"/>
+              </a:schemeClr>
+            </a:gs>
+            <a:gs pos="100000">
+              <a:schemeClr val="phClr">
+                <a:lumMod val="105000"/>
+                <a:satMod val="109000"/>
+                <a:tint val="81000"/>
+              </a:schemeClr>
+            </a:gs>
+          </a:gsLst>
+          <a:lin ang="5400000" scaled="0"/>
+        </a:gradFill>
+        <a:gradFill rotWithShape="1">
+          <a:gsLst>
+            <a:gs pos="0">
+              <a:schemeClr val="phClr">
+                <a:satMod val="103000"/>
+                <a:lumMod val="102000"/>
+                <a:tint val="94000"/>
+              </a:schemeClr>
+            </a:gs>
+            <a:gs pos="50000">
+              <a:schemeClr val="phClr">
+                <a:satMod val="110000"/>
+                <a:lumMod val="100000"/>
+                <a:shade val="100000"/>
+              </a:schemeClr>
+            </a:gs>
+            <a:gs pos="100000">
+              <a:schemeClr val="phClr">
+                <a:lumMod val="99000"/>
+                <a:satMod val="120000"/>
+                <a:shade val="78000"/>
+              </a:schemeClr>
+            </a:gs>
+          </a:gsLst>
+          <a:lin ang="5400000" scaled="0"/>
+        </a:gradFill>
+      </a:fillStyleLst>
+      <a:lnStyleLst>
+        <a:ln w="12700" cap="flat" cmpd="sng" algn="ctr">
+          <a:solidFill>
+            <a:schemeClr val="phClr"/>
+          </a:solidFill>
+          <a:prstDash val="solid"/>
+          <a:miter lim="800000"/>
+        </a:ln>
+        <a:ln w="19050" cap="flat" cmpd="sng" algn="ctr">
+          <a:solidFill>
+            <a:schemeClr val="phClr"/>
+          </a:solidFill>
+          <a:prstDash val="solid"/>
+          <a:miter lim="800000"/>
+        </a:ln>
+        <a:ln w="25400" cap="flat" cmpd="sng" algn="ctr">
+          <a:solidFill>
+            <a:schemeClr val="phClr"/>
+          </a:solidFill>
+          <a:prstDash val="solid"/>
+          <a:miter lim="800000"/>
+        </a:ln>
+      </a:lnStyleLst>
+      <a:effectStyleLst>
+        <a:effectStyle>
+          <a:effectLst/>
+        </a:effectStyle>
+        <a:effectStyle>
+          <a:effectLst/>
+        </a:effectStyle>
+        <a:effectStyle>
+          <a:effectLst>
+            <a:outerShdw blurRad="57150" dist="19050" dir="5400000" algn="ctr" rotWithShape="0">
+              <a:srgbClr val="000000">
+                <a:alpha val="63000"/>
+              </a:srgbClr>
+            </a:outerShdw>
+          </a:effectLst>
+        </a:effectStyle>
+      </a:effectStyleLst>
+      <a:bgFillStyleLst>
+        <a:solidFill>
+          <a:schemeClr val="phClr"/>
+        </a:solidFill>
+        <a:solidFill>
+          <a:schemeClr val="phClr">
+            <a:tint val="95000"/>
+            <a:satMod val="170000"/>
+          </a:schemeClr>
+        </a:solidFill>
+        <a:gradFill rotWithShape="1">
+          <a:gsLst>
+            <a:gs pos="0">
+              <a:schemeClr val="phClr">
+                <a:tint val="93000"/>
+                <a:satMod val="150000"/>
+                <a:shade val="98000"/>
+                <a:lumMod val="102000"/>
+              </a:schemeClr>
+            </a:gs>
+            <a:gs pos="50000">
+              <a:schemeClr val="phClr">
+                <a:tint val="98000"/>
+                <a:satMod val="130000"/>
+                <a:shade val="90000"/>
+                <a:lumMod val="103000"/>
+              </a:schemeClr>
+            </a:gs>
+            <a:gs pos="100000">
+              <a:schemeClr val="phClr">
+                <a:shade val="63000"/>
+                <a:satMod val="120000"/>
+              </a:schemeClr>
+            </a:gs>
+          </a:gsLst>
+          <a:lin ang="5400000" scaled="0"/>
+        </a:gradFill>
+      </a:bgFillStyleLst>
+    </a:fmtScheme>
+  </a:themeElements>
+  <a:objectDefaults>
+    <a:lnDef>
+      <a:spPr/>
+      <a:bodyPr/>
+      <a:lstStyle/>
+      <a:style>
+        <a:lnRef idx="2">
+          <a:schemeClr val="accent1"/>
+        </a:lnRef>
+        <a:fillRef idx="0">
+          <a:schemeClr val="accent1"/>
+        </a:fillRef>
+        <a:effectRef idx="1">
+          <a:schemeClr val="accent1"/>
+        </a:effectRef>
+        <a:fontRef idx="minor">
+          <a:schemeClr val="tx1"/>
+        </a:fontRef>
+      </a:style>
+    </a:lnDef>
+  </a:objectDefaults>
+  <a:extraClrSchemeLst/>
+  <a:extLst>
+    <a:ext uri="{05A4C25C-085E-4340-85A3-A5531E510DB2}">
+      <thm15:themeFamily xmlns:thm15="http://schemas.microsoft.com/office/thememl/2012/main" name="Office Theme" id="{2E142A2C-CD16-42D6-873A-C26D2A0506FA}" vid="{1BDDFF52-6CD6-40A5-AB3C-68EB2F1E4D0A}"/>
+    </a:ext>
+  </a:extLst>
+</a:theme>
 </file>
</xml_diff>

<commit_message>
updated slides and README
</commit_message>
<xml_diff>
--- a/slides/cre-ai-agent-system.pptx
+++ b/slides/cre-ai-agent-system.pptx
@@ -1137,7 +1137,7 @@
                 <a:ea typeface="Calibri" pitchFamily="34" charset="-122"/>
                 <a:cs typeface="Calibri" pitchFamily="34" charset="-120"/>
               </a:rPr>
-              <a:t>The Proposition | The Solution | Demo</a:t>
+              <a:t>Proposition | Solution | Demo</a:t>
             </a:r>
             <a:endParaRPr lang="en-US" sz="2600" dirty="0"/>
           </a:p>
@@ -1253,7 +1253,7 @@
         </p:nvSpPr>
         <p:spPr>
           <a:xfrm>
-            <a:off x="640080" y="5287441"/>
+            <a:off x="640079" y="5834977"/>
             <a:ext cx="10911535" cy="292608"/>
           </a:xfrm>
           <a:prstGeom prst="rect">
@@ -1270,7 +1270,7 @@
               <a:buNone/>
             </a:pPr>
             <a:r>
-              <a:rPr lang="en-US" sz="1500" b="0" i="1" kern="0" dirty="0">
+              <a:rPr lang="en-US" sz="2000" b="0" i="1" kern="0" dirty="0">
                 <a:solidFill>
                   <a:srgbClr val="E6E0D2"/>
                 </a:solidFill>
@@ -1280,7 +1280,7 @@
               </a:rPr>
               <a:t>Do Good and Do Well, with Love</a:t>
             </a:r>
-            <a:endParaRPr lang="en-US" sz="1100" dirty="0"/>
+            <a:endParaRPr lang="en-US" sz="2000" dirty="0"/>
           </a:p>
         </p:txBody>
       </p:sp>
@@ -1350,7 +1350,7 @@
                 <a:ea typeface="Calibri" pitchFamily="34" charset="-122"/>
                 <a:cs typeface="Calibri" pitchFamily="34" charset="-120"/>
               </a:rPr>
-              <a:t>THE PROPOSITION</a:t>
+              <a:t>PROPOSITION</a:t>
             </a:r>
             <a:endParaRPr lang="en-US" sz="1200" dirty="0"/>
           </a:p>
@@ -1365,7 +1365,7 @@
         <p:spPr>
           <a:xfrm>
             <a:off x="640080" y="841248"/>
-            <a:ext cx="8138160" cy="658368"/>
+            <a:ext cx="10058400" cy="658368"/>
           </a:xfrm>
           <a:prstGeom prst="rect">
             <a:avLst/>
@@ -1389,7 +1389,7 @@
                 <a:ea typeface="Cambria" pitchFamily="34" charset="-122"/>
                 <a:cs typeface="Cambria" pitchFamily="34" charset="-120"/>
               </a:rPr>
-              <a:t>Everyone has AI. Almost nobody trusts it.</a:t>
+              <a:t>Monitoring is tedious, yet AI cannot be trusted.</a:t>
             </a:r>
             <a:endParaRPr lang="en-US" sz="3400" dirty="0"/>
           </a:p>
@@ -1403,7 +1403,7 @@
         </p:nvSpPr>
         <p:spPr>
           <a:xfrm>
-            <a:off x="640080" y="1627632"/>
+            <a:off x="640080" y="1429194"/>
             <a:ext cx="8394192" cy="365760"/>
           </a:xfrm>
           <a:prstGeom prst="rect">
@@ -1416,14 +1416,26 @@
           <a:bodyPr wrap="square" lIns="0" tIns="0" rIns="0" bIns="0" rtlCol="0" anchor="t"/>
           <a:lstStyle/>
           <a:p>
-            <a:pPr marL="0" indent="0">
-              <a:lnSpc>
-                <a:spcPts val="2400"/>
-              </a:lnSpc>
-              <a:buNone/>
-            </a:pPr>
-            <a:r>
-              <a:rPr lang="en-US" sz="1750" dirty="0">
+            <a:r>
+              <a:rPr lang="en-HK" sz="1600" b="1" dirty="0"/>
+              <a:t>66%</a:t>
+            </a:r>
+            <a:r>
+              <a:rPr lang="en-HK" sz="1600" dirty="0"/>
+              <a:t> of CRE professionals use AI weekly or daily; </a:t>
+            </a:r>
+            <a:r>
+              <a:rPr lang="en-US" sz="1600" dirty="0">
+                <a:solidFill>
+                  <a:srgbClr val="141414"/>
+                </a:solidFill>
+                <a:latin typeface="Calibri" pitchFamily="34" charset="0"/>
+                <a:cs typeface="Calibri" pitchFamily="34" charset="-120"/>
+              </a:rPr>
+              <a:t>o</a:t>
+            </a:r>
+            <a:r>
+              <a:rPr lang="en-US" sz="1600" dirty="0">
                 <a:solidFill>
                   <a:srgbClr val="141414"/>
                 </a:solidFill>
@@ -1431,7 +1443,7 @@
                 <a:ea typeface="Calibri" pitchFamily="34" charset="-122"/>
                 <a:cs typeface="Calibri" pitchFamily="34" charset="-120"/>
               </a:rPr>
-              <a:t>Only </a:t>
+              <a:t>nly </a:t>
             </a:r>
             <a:r>
               <a:rPr lang="en-US" sz="2400" b="1" dirty="0">
@@ -1445,7 +1457,7 @@
               <a:t>5%</a:t>
             </a:r>
             <a:r>
-              <a:rPr lang="en-US" sz="1750" dirty="0">
+              <a:rPr lang="en-US" sz="1600" dirty="0">
                 <a:solidFill>
                   <a:srgbClr val="141414"/>
                 </a:solidFill>
@@ -1453,67 +1465,45 @@
                 <a:ea typeface="Calibri" pitchFamily="34" charset="-122"/>
                 <a:cs typeface="Calibri" pitchFamily="34" charset="-120"/>
               </a:rPr>
-              <a:t> trust it enough to inform a deal decision, and </a:t>
-            </a:r>
-            <a:r>
-              <a:rPr lang="en-US" sz="1750" b="1" dirty="0">
-                <a:solidFill>
-                  <a:srgbClr val="9B2C2C"/>
+              <a:t> trust it enough to inform a deal.</a:t>
+            </a:r>
+            <a:endParaRPr lang="en-US" sz="1600" dirty="0"/>
+          </a:p>
+        </p:txBody>
+      </p:sp>
+      <p:sp>
+        <p:nvSpPr>
+          <p:cNvPr id="5" name="Text 3"/>
+          <p:cNvSpPr txBox="1"/>
+          <p:nvPr/>
+        </p:nvSpPr>
+        <p:spPr>
+          <a:xfrm>
+            <a:off x="640080" y="1837944"/>
+            <a:ext cx="8394192" cy="219456"/>
+          </a:xfrm>
+          <a:prstGeom prst="rect">
+            <a:avLst/>
+          </a:prstGeom>
+          <a:noFill/>
+          <a:ln/>
+        </p:spPr>
+        <p:txBody>
+          <a:bodyPr wrap="square" lIns="0" tIns="0" rIns="0" bIns="0" rtlCol="0" anchor="t"/>
+          <a:lstStyle/>
+          <a:p>
+            <a:pPr marL="0" indent="0">
+              <a:buNone/>
+            </a:pPr>
+            <a:r>
+              <a:rPr lang="en-US" sz="1000" i="1" dirty="0">
+                <a:solidFill>
+                  <a:srgbClr val="5C564C"/>
                 </a:solidFill>
                 <a:latin typeface="Calibri" pitchFamily="34" charset="0"/>
                 <a:ea typeface="Calibri" pitchFamily="34" charset="-122"/>
                 <a:cs typeface="Calibri" pitchFamily="34" charset="-120"/>
               </a:rPr>
-              <a:t>32%</a:t>
-            </a:r>
-            <a:r>
-              <a:rPr lang="en-US" sz="1750" dirty="0">
-                <a:solidFill>
-                  <a:srgbClr val="141414"/>
-                </a:solidFill>
-                <a:latin typeface="Calibri" pitchFamily="34" charset="0"/>
-                <a:ea typeface="Calibri" pitchFamily="34" charset="-122"/>
-                <a:cs typeface="Calibri" pitchFamily="34" charset="-120"/>
-              </a:rPr>
-              <a:t> cite accuracy as their concern.</a:t>
-            </a:r>
-            <a:endParaRPr lang="en-US" sz="1750" dirty="0"/>
-          </a:p>
-        </p:txBody>
-      </p:sp>
-      <p:sp>
-        <p:nvSpPr>
-          <p:cNvPr id="5" name="Text 3"/>
-          <p:cNvSpPr txBox="1"/>
-          <p:nvPr/>
-        </p:nvSpPr>
-        <p:spPr>
-          <a:xfrm>
-            <a:off x="640080" y="2048256"/>
-            <a:ext cx="8394192" cy="219456"/>
-          </a:xfrm>
-          <a:prstGeom prst="rect">
-            <a:avLst/>
-          </a:prstGeom>
-          <a:noFill/>
-          <a:ln/>
-        </p:spPr>
-        <p:txBody>
-          <a:bodyPr wrap="square" lIns="0" tIns="0" rIns="0" bIns="0" rtlCol="0" anchor="t"/>
-          <a:lstStyle/>
-          <a:p>
-            <a:pPr marL="0" indent="0">
-              <a:buNone/>
-            </a:pPr>
-            <a:r>
-              <a:rPr lang="en-US" sz="1000" i="1" dirty="0">
-                <a:solidFill>
-                  <a:srgbClr val="5C564C"/>
-                </a:solidFill>
-                <a:latin typeface="Calibri" pitchFamily="34" charset="0"/>
-                <a:ea typeface="Calibri" pitchFamily="34" charset="-122"/>
-                <a:cs typeface="Calibri" pitchFamily="34" charset="-120"/>
-              </a:rPr>
               <a:t>First American Data &amp; Analytics / DealGround, survey of 255 CRE professionals, May 2026</a:t>
             </a:r>
             <a:endParaRPr lang="en-US" sz="1000" dirty="0"/>
@@ -1528,8 +1518,8 @@
         </p:nvSpPr>
         <p:spPr>
           <a:xfrm>
-            <a:off x="499404" y="3511297"/>
-            <a:ext cx="7818120" cy="1243584"/>
+            <a:off x="499403" y="2185416"/>
+            <a:ext cx="8138159" cy="841248"/>
           </a:xfrm>
           <a:prstGeom prst="rect">
             <a:avLst/>
@@ -1555,8 +1545,8 @@
         </p:nvSpPr>
         <p:spPr>
           <a:xfrm>
-            <a:off x="810300" y="3767329"/>
-            <a:ext cx="7196328" cy="731520"/>
+            <a:off x="810299" y="2321992"/>
+            <a:ext cx="7323605" cy="616915"/>
           </a:xfrm>
           <a:prstGeom prst="rect">
             <a:avLst/>
@@ -1568,46 +1558,115 @@
           <a:bodyPr wrap="square" lIns="0" tIns="0" rIns="0" bIns="0" rtlCol="0" anchor="t"/>
           <a:lstStyle/>
           <a:p>
-            <a:pPr marL="0" indent="0" algn="just">
-              <a:lnSpc>
-                <a:spcPts val="2000"/>
-              </a:lnSpc>
-              <a:buNone/>
-            </a:pPr>
-            <a:r>
-              <a:rPr lang="en-US" sz="1500" dirty="0">
+            <a:r>
+              <a:rPr lang="en-HK" sz="1600" b="1" dirty="0">
+                <a:solidFill>
+                  <a:srgbClr val="9B2C2C"/>
+                </a:solidFill>
+              </a:rPr>
+              <a:t>Multiple</a:t>
+            </a:r>
+            <a:r>
+              <a:rPr sz="1600" b="1" dirty="0">
+                <a:solidFill>
+                  <a:srgbClr val="9B2C2C"/>
+                </a:solidFill>
+              </a:rPr>
+              <a:t> </a:t>
+            </a:r>
+            <a:r>
+              <a:rPr lang="en-US" sz="1600" b="1" dirty="0">
+                <a:solidFill>
+                  <a:srgbClr val="9B2C2C"/>
+                </a:solidFill>
+              </a:rPr>
+              <a:t>interrelated </a:t>
+            </a:r>
+            <a:r>
+              <a:rPr sz="1600" b="1" dirty="0">
+                <a:solidFill>
+                  <a:srgbClr val="9B2C2C"/>
+                </a:solidFill>
+              </a:rPr>
+              <a:t>areas to</a:t>
+            </a:r>
+            <a:r>
+              <a:rPr lang="en-US" sz="1600" b="1" dirty="0">
+                <a:solidFill>
+                  <a:srgbClr val="9B2C2C"/>
+                </a:solidFill>
+              </a:rPr>
+              <a:t> be</a:t>
+            </a:r>
+            <a:r>
+              <a:rPr sz="1600" b="1" dirty="0">
+                <a:solidFill>
+                  <a:srgbClr val="9B2C2C"/>
+                </a:solidFill>
+              </a:rPr>
+              <a:t> track</a:t>
+            </a:r>
+            <a:r>
+              <a:rPr lang="en-US" sz="1600" b="1" dirty="0">
+                <a:solidFill>
+                  <a:srgbClr val="9B2C2C"/>
+                </a:solidFill>
+              </a:rPr>
+              <a:t>ed</a:t>
+            </a:r>
+            <a:r>
+              <a:rPr lang="en-US" sz="1600" b="1" dirty="0">
                 <a:solidFill>
                   <a:srgbClr val="141414"/>
                 </a:solidFill>
-                <a:latin typeface="Calibri" pitchFamily="34" charset="0"/>
-                <a:ea typeface="Calibri" pitchFamily="34" charset="-122"/>
-                <a:cs typeface="Calibri" pitchFamily="34" charset="-120"/>
-              </a:rPr>
-              <a:t>General-purpose AI replies with whatever it retrieves from the web and whatever it was trained on. It might </a:t>
-            </a:r>
-            <a:r>
-              <a:rPr lang="en-US" sz="1500" b="1" dirty="0">
-                <a:solidFill>
-                  <a:srgbClr val="9B2C2C"/>
-                </a:solidFill>
-                <a:latin typeface="Calibri" pitchFamily="34" charset="0"/>
-                <a:ea typeface="Calibri" pitchFamily="34" charset="-122"/>
-                <a:cs typeface="Calibri" pitchFamily="34" charset="-120"/>
-              </a:rPr>
-              <a:t>hallucinate</a:t>
-            </a:r>
-            <a:r>
-              <a:rPr lang="en-US" sz="1500" dirty="0">
+                <a:latin typeface="Calibri"/>
+              </a:rPr>
+              <a:t>, </a:t>
+            </a:r>
+            <a:r>
+              <a:rPr lang="en-US" sz="1600" dirty="0">
                 <a:solidFill>
                   <a:srgbClr val="141414"/>
                 </a:solidFill>
-                <a:latin typeface="Calibri" pitchFamily="34" charset="0"/>
-                <a:ea typeface="Calibri" pitchFamily="34" charset="-122"/>
-                <a:cs typeface="Calibri" pitchFamily="34" charset="-120"/>
-              </a:rPr>
-              <a:t>: inventing a figure that does not exist, attaching a source that does not say it, or doing the arithmetic wrongly.</a:t>
-            </a:r>
-            <a:endParaRPr lang="en-US" sz="1500" dirty="0"/>
+                <a:latin typeface="Calibri"/>
+              </a:rPr>
+              <a:t>while the world keeps moving rapidly. </a:t>
+            </a:r>
+            <a:br>
+              <a:rPr lang="en-US" sz="1600" dirty="0">
+                <a:solidFill>
+                  <a:srgbClr val="141414"/>
+                </a:solidFill>
+                <a:latin typeface="Calibri"/>
+              </a:rPr>
+            </a:br>
+            <a:r>
+              <a:rPr lang="en-HK" sz="1600" dirty="0">
+                <a:solidFill>
+                  <a:srgbClr val="141414"/>
+                </a:solidFill>
+                <a:latin typeface="Cambria"/>
+              </a:rPr>
+              <a:t>→</a:t>
+            </a:r>
+            <a:r>
+              <a:rPr lang="en-US" sz="1600" dirty="0">
+                <a:solidFill>
+                  <a:srgbClr val="141414"/>
+                </a:solidFill>
+                <a:latin typeface="Calibri"/>
+              </a:rPr>
+              <a:t> </a:t>
+            </a:r>
+            <a:r>
+              <a:rPr lang="en-HK" sz="1600" dirty="0"/>
+              <a:t>Analysis by hand puts you </a:t>
+            </a:r>
+            <a:r>
+              <a:rPr lang="en-HK" sz="1600" b="1" dirty="0"/>
+              <a:t>behind the market.</a:t>
+            </a:r>
+            <a:endParaRPr lang="en-US" sz="1600" b="1" dirty="0"/>
           </a:p>
         </p:txBody>
       </p:sp>
@@ -1619,7 +1678,7 @@
         </p:nvSpPr>
         <p:spPr>
           <a:xfrm>
-            <a:off x="4298736" y="4818889"/>
+            <a:off x="4229675" y="3140964"/>
             <a:ext cx="212975" cy="329184"/>
           </a:xfrm>
           <a:prstGeom prst="downArrow">
@@ -1646,8 +1705,8 @@
         </p:nvSpPr>
         <p:spPr>
           <a:xfrm>
-            <a:off x="499404" y="5212081"/>
-            <a:ext cx="7818120" cy="1024128"/>
+            <a:off x="499404" y="3584448"/>
+            <a:ext cx="8138158" cy="932688"/>
           </a:xfrm>
           <a:prstGeom prst="rect">
             <a:avLst/>
@@ -1674,8 +1733,8 @@
         </p:nvSpPr>
         <p:spPr>
           <a:xfrm>
-            <a:off x="810300" y="5468113"/>
-            <a:ext cx="7196328" cy="512064"/>
+            <a:off x="810298" y="3744787"/>
+            <a:ext cx="7323607" cy="566290"/>
           </a:xfrm>
           <a:prstGeom prst="rect">
             <a:avLst/>
@@ -1687,31 +1746,110 @@
           <a:bodyPr wrap="square" lIns="0" tIns="0" rIns="0" bIns="0" rtlCol="0" anchor="t"/>
           <a:lstStyle/>
           <a:p>
-            <a:pPr marL="0" indent="0" algn="l">
+            <a:pPr>
               <a:lnSpc>
                 <a:spcPts val="2000"/>
               </a:lnSpc>
-              <a:buNone/>
             </a:pPr>
             <a:r>
-              <a:rPr sz="1500" b="1">
+              <a:rPr sz="1600" b="0" dirty="0">
                 <a:solidFill>
                   <a:srgbClr val="141414"/>
                 </a:solidFill>
                 <a:latin typeface="Calibri"/>
               </a:rPr>
-              <a:t>The power of AI goes unused</a:t>
-            </a:r>
-            <a:r>
-              <a:rPr sz="1500" b="0">
+              <a:t>General-purpose</a:t>
+            </a:r>
+            <a:r>
+              <a:rPr lang="en-US" sz="1600" b="0" dirty="0">
                 <a:solidFill>
                   <a:srgbClr val="141414"/>
                 </a:solidFill>
                 <a:latin typeface="Calibri"/>
               </a:rPr>
-              <a:t>, because the analyst drills back down to the source anyway: the geography, blueprints, lease terms, floor plans, and the reversion maths by hand.</a:t>
-            </a:r>
-            <a:endParaRPr lang="en-US" sz="1500" dirty="0"/>
+              <a:t> AI</a:t>
+            </a:r>
+            <a:r>
+              <a:rPr sz="1600" b="0" dirty="0">
+                <a:solidFill>
+                  <a:srgbClr val="141414"/>
+                </a:solidFill>
+                <a:latin typeface="Calibri"/>
+              </a:rPr>
+              <a:t> might </a:t>
+            </a:r>
+            <a:r>
+              <a:rPr sz="1600" b="1" dirty="0">
+                <a:solidFill>
+                  <a:srgbClr val="9B2C2C"/>
+                </a:solidFill>
+                <a:latin typeface="Calibri"/>
+              </a:rPr>
+              <a:t>hallucinate</a:t>
+            </a:r>
+            <a:r>
+              <a:rPr sz="1600" b="0" dirty="0">
+                <a:solidFill>
+                  <a:srgbClr val="141414"/>
+                </a:solidFill>
+                <a:latin typeface="Calibri"/>
+              </a:rPr>
+              <a:t>: inventing a figure, getting the arithmetic wrong. </a:t>
+            </a:r>
+            <a:br>
+              <a:rPr lang="en-US" sz="1600" b="0" dirty="0">
+                <a:solidFill>
+                  <a:srgbClr val="141414"/>
+                </a:solidFill>
+                <a:latin typeface="Calibri"/>
+              </a:rPr>
+            </a:br>
+            <a:r>
+              <a:rPr lang="en-HK" sz="1600" dirty="0">
+                <a:solidFill>
+                  <a:srgbClr val="141414"/>
+                </a:solidFill>
+                <a:latin typeface="Cambria"/>
+              </a:rPr>
+              <a:t>→</a:t>
+            </a:r>
+            <a:r>
+              <a:rPr sz="1600" b="1" dirty="0">
+                <a:solidFill>
+                  <a:srgbClr val="141414"/>
+                </a:solidFill>
+                <a:latin typeface="Calibri"/>
+              </a:rPr>
+              <a:t> </a:t>
+            </a:r>
+            <a:r>
+              <a:rPr lang="en-US" sz="1600" b="1" dirty="0">
+                <a:solidFill>
+                  <a:srgbClr val="141414"/>
+                </a:solidFill>
+                <a:latin typeface="Calibri"/>
+              </a:rPr>
+              <a:t>T</a:t>
+            </a:r>
+            <a:r>
+              <a:rPr sz="1600" b="1" dirty="0">
+                <a:solidFill>
+                  <a:srgbClr val="141414"/>
+                </a:solidFill>
+                <a:latin typeface="Calibri"/>
+              </a:rPr>
+              <a:t>he power of AI goes unused</a:t>
+            </a:r>
+            <a:r>
+              <a:rPr sz="1600" b="0" dirty="0">
+                <a:solidFill>
+                  <a:srgbClr val="141414"/>
+                </a:solidFill>
+                <a:latin typeface="Calibri"/>
+              </a:rPr>
+              <a:t>: the analyst redoes the work by hand.</a:t>
+            </a:r>
+            <a:endParaRPr lang="en-US" sz="1600" dirty="0"/>
           </a:p>
         </p:txBody>
       </p:sp>
@@ -1725,23 +1863,235 @@
         </p:nvPicPr>
         <p:blipFill>
           <a:blip r:embed="rId3"/>
+          <a:srcRect l="1" r="325" b="43544"/>
           <a:stretch>
             <a:fillRect/>
           </a:stretch>
         </p:blipFill>
         <p:spPr>
           <a:xfrm>
-            <a:off x="9345167" y="1627632"/>
-            <a:ext cx="2514600" cy="2761488"/>
+            <a:off x="9372012" y="3584448"/>
+            <a:ext cx="2185955" cy="1359692"/>
           </a:xfrm>
           <a:prstGeom prst="rect">
             <a:avLst/>
           </a:prstGeom>
         </p:spPr>
       </p:pic>
+      <p:sp>
+        <p:nvSpPr>
+          <p:cNvPr id="14" name="Shape 10"/>
+          <p:cNvSpPr/>
+          <p:nvPr/>
+        </p:nvSpPr>
+        <p:spPr>
+          <a:xfrm>
+            <a:off x="499403" y="5074920"/>
+            <a:ext cx="8138160" cy="1125350"/>
+          </a:xfrm>
+          <a:prstGeom prst="rect">
+            <a:avLst/>
+          </a:prstGeom>
+          <a:solidFill>
+            <a:srgbClr val="E3DAC5"/>
+          </a:solidFill>
+          <a:ln/>
+        </p:spPr>
+        <p:txBody>
+          <a:bodyPr/>
+          <a:lstStyle/>
+          <a:p>
+            <a:endParaRPr lang="en-US"/>
+          </a:p>
+        </p:txBody>
+      </p:sp>
+      <p:sp>
+        <p:nvSpPr>
+          <p:cNvPr id="15" name="Text 11"/>
+          <p:cNvSpPr txBox="1"/>
+          <p:nvPr/>
+        </p:nvSpPr>
+        <p:spPr>
+          <a:xfrm>
+            <a:off x="810298" y="5264421"/>
+            <a:ext cx="7323607" cy="804672"/>
+          </a:xfrm>
+          <a:prstGeom prst="rect">
+            <a:avLst/>
+          </a:prstGeom>
+          <a:noFill/>
+          <a:ln/>
+        </p:spPr>
+        <p:txBody>
+          <a:bodyPr wrap="square" lIns="0" tIns="0" rIns="0" bIns="0" rtlCol="0" anchor="ctr"/>
+          <a:lstStyle/>
+          <a:p>
+            <a:pPr>
+              <a:lnSpc>
+                <a:spcPts val="2200"/>
+              </a:lnSpc>
+            </a:pPr>
+            <a:r>
+              <a:rPr lang="en-HK" sz="1600" b="0" dirty="0">
+                <a:solidFill>
+                  <a:srgbClr val="141414"/>
+                </a:solidFill>
+                <a:latin typeface="Calibri" panose="020F0502020204030204" pitchFamily="34" charset="0"/>
+                <a:cs typeface="Calibri" panose="020F0502020204030204" pitchFamily="34" charset="0"/>
+              </a:rPr>
+              <a:t>The solution: </a:t>
+            </a:r>
+            <a:r>
+              <a:rPr b="1" dirty="0">
+                <a:solidFill>
+                  <a:srgbClr val="9B2C2C"/>
+                </a:solidFill>
+                <a:latin typeface="Calibri" panose="020F0502020204030204" pitchFamily="34" charset="0"/>
+                <a:cs typeface="Calibri" panose="020F0502020204030204" pitchFamily="34" charset="0"/>
+              </a:rPr>
+              <a:t>bridg</a:t>
+            </a:r>
+            <a:r>
+              <a:rPr lang="en-US" b="1" dirty="0">
+                <a:solidFill>
+                  <a:srgbClr val="9B2C2C"/>
+                </a:solidFill>
+                <a:latin typeface="Calibri" panose="020F0502020204030204" pitchFamily="34" charset="0"/>
+                <a:cs typeface="Calibri" panose="020F0502020204030204" pitchFamily="34" charset="0"/>
+              </a:rPr>
+              <a:t>ing</a:t>
+            </a:r>
+            <a:r>
+              <a:rPr b="1" dirty="0">
+                <a:solidFill>
+                  <a:srgbClr val="9B2C2C"/>
+                </a:solidFill>
+                <a:latin typeface="Calibri" panose="020F0502020204030204" pitchFamily="34" charset="0"/>
+                <a:cs typeface="Calibri" panose="020F0502020204030204" pitchFamily="34" charset="0"/>
+              </a:rPr>
+              <a:t> the trust gap</a:t>
+            </a:r>
+            <a:r>
+              <a:rPr lang="en-US" dirty="0">
+                <a:latin typeface="Calibri" panose="020F0502020204030204" pitchFamily="34" charset="0"/>
+                <a:cs typeface="Calibri" panose="020F0502020204030204" pitchFamily="34" charset="0"/>
+              </a:rPr>
+              <a:t> </a:t>
+            </a:r>
+            <a:r>
+              <a:rPr lang="en-HK" sz="1600" b="0" dirty="0">
+                <a:solidFill>
+                  <a:srgbClr val="141414"/>
+                </a:solidFill>
+                <a:latin typeface="Calibri" panose="020F0502020204030204" pitchFamily="34" charset="0"/>
+                <a:cs typeface="Calibri" panose="020F0502020204030204" pitchFamily="34" charset="0"/>
+              </a:rPr>
+              <a:t>by an</a:t>
+            </a:r>
+            <a:r>
+              <a:rPr sz="1600" b="0" dirty="0">
+                <a:solidFill>
+                  <a:srgbClr val="141414"/>
+                </a:solidFill>
+                <a:latin typeface="Calibri" panose="020F0502020204030204" pitchFamily="34" charset="0"/>
+                <a:cs typeface="Calibri" panose="020F0502020204030204" pitchFamily="34" charset="0"/>
+              </a:rPr>
+              <a:t> AI</a:t>
+            </a:r>
+            <a:r>
+              <a:rPr lang="en-US" sz="1600" b="0" dirty="0">
+                <a:solidFill>
+                  <a:srgbClr val="141414"/>
+                </a:solidFill>
+                <a:latin typeface="Calibri" panose="020F0502020204030204" pitchFamily="34" charset="0"/>
+                <a:cs typeface="Calibri" panose="020F0502020204030204" pitchFamily="34" charset="0"/>
+              </a:rPr>
+              <a:t> agent grounded</a:t>
+            </a:r>
+            <a:r>
+              <a:rPr sz="1600" b="0" dirty="0">
+                <a:solidFill>
+                  <a:srgbClr val="141414"/>
+                </a:solidFill>
+                <a:latin typeface="Calibri" panose="020F0502020204030204" pitchFamily="34" charset="0"/>
+                <a:cs typeface="Calibri" panose="020F0502020204030204" pitchFamily="34" charset="0"/>
+              </a:rPr>
+              <a:t> with credible information and robust agentic tools</a:t>
+            </a:r>
+            <a:r>
+              <a:rPr lang="en-US" sz="1600" b="0" dirty="0">
+                <a:solidFill>
+                  <a:srgbClr val="141414"/>
+                </a:solidFill>
+                <a:latin typeface="Calibri" panose="020F0502020204030204" pitchFamily="34" charset="0"/>
+                <a:cs typeface="Calibri" panose="020F0502020204030204" pitchFamily="34" charset="0"/>
+              </a:rPr>
+              <a:t>.</a:t>
+            </a:r>
+            <a:br>
+              <a:rPr lang="en-US" sz="1600" b="0" dirty="0">
+                <a:solidFill>
+                  <a:srgbClr val="141414"/>
+                </a:solidFill>
+                <a:latin typeface="Calibri" panose="020F0502020204030204" pitchFamily="34" charset="0"/>
+                <a:cs typeface="Calibri" panose="020F0502020204030204" pitchFamily="34" charset="0"/>
+              </a:rPr>
+            </a:br>
+            <a:r>
+              <a:rPr lang="en-HK" sz="1600" dirty="0">
+                <a:solidFill>
+                  <a:srgbClr val="141414"/>
+                </a:solidFill>
+                <a:latin typeface="Cambria"/>
+              </a:rPr>
+              <a:t>→</a:t>
+            </a:r>
+            <a:r>
+              <a:rPr sz="1600" b="0" dirty="0">
+                <a:solidFill>
+                  <a:srgbClr val="141414"/>
+                </a:solidFill>
+                <a:latin typeface="Calibri" panose="020F0502020204030204" pitchFamily="34" charset="0"/>
+                <a:cs typeface="Calibri" panose="020F0502020204030204" pitchFamily="34" charset="0"/>
+              </a:rPr>
+              <a:t>  </a:t>
+            </a:r>
+            <a:r>
+              <a:rPr lang="en-US" b="1" dirty="0">
+                <a:solidFill>
+                  <a:srgbClr val="141414"/>
+                </a:solidFill>
+                <a:latin typeface="Calibri" panose="020F0502020204030204" pitchFamily="34" charset="0"/>
+                <a:cs typeface="Calibri" panose="020F0502020204030204" pitchFamily="34" charset="0"/>
+              </a:rPr>
+              <a:t>This</a:t>
+            </a:r>
+            <a:r>
+              <a:rPr b="1" dirty="0">
+                <a:solidFill>
+                  <a:srgbClr val="141414"/>
+                </a:solidFill>
+                <a:latin typeface="Calibri" panose="020F0502020204030204" pitchFamily="34" charset="0"/>
+                <a:cs typeface="Calibri" panose="020F0502020204030204" pitchFamily="34" charset="0"/>
+              </a:rPr>
+              <a:t> CRE AI Agent System</a:t>
+            </a:r>
+            <a:endParaRPr lang="en-US" dirty="0">
+              <a:latin typeface="Calibri" panose="020F0502020204030204" pitchFamily="34" charset="0"/>
+              <a:cs typeface="Calibri" panose="020F0502020204030204" pitchFamily="34" charset="0"/>
+            </a:endParaRPr>
+          </a:p>
+        </p:txBody>
+      </p:sp>
       <p:pic>
         <p:nvPicPr>
-          <p:cNvPr id="12" name="Image 1" descr="/Users/ethanlee/Desktop/projects/cre_market_agent/slides/assets/problem-claude-misalignment.png"/>
+          <p:cNvPr id="16" name="Picture 15" descr="During Covid, people leaving London chose non-urban areas over big cities |  Centre for Cities">
+            <a:extLst>
+              <a:ext uri="{FF2B5EF4-FFF2-40B4-BE49-F238E27FC236}">
+                <a16:creationId xmlns:a16="http://schemas.microsoft.com/office/drawing/2014/main" id="{D2CF25E7-9D02-C30B-2D65-01D27FC231F5}"/>
+              </a:ext>
+            </a:extLst>
+          </p:cNvPr>
           <p:cNvPicPr>
             <a:picLocks noChangeAspect="1"/>
           </p:cNvPicPr>
@@ -1749,14 +2099,15 @@
         </p:nvPicPr>
         <p:blipFill>
           <a:blip r:embed="rId4"/>
+          <a:srcRect r="31989" b="18018"/>
           <a:stretch>
             <a:fillRect/>
           </a:stretch>
         </p:blipFill>
         <p:spPr>
           <a:xfrm>
-            <a:off x="9345167" y="4579940"/>
-            <a:ext cx="2514600" cy="905256"/>
+            <a:off x="9126993" y="1739788"/>
+            <a:ext cx="2669475" cy="1684019"/>
           </a:xfrm>
           <a:prstGeom prst="rect">
             <a:avLst/>
@@ -1765,62 +2116,26 @@
       </p:pic>
       <p:sp>
         <p:nvSpPr>
-          <p:cNvPr id="13" name="Text 9"/>
-          <p:cNvSpPr txBox="1"/>
-          <p:nvPr/>
-        </p:nvSpPr>
-        <p:spPr>
-          <a:xfrm>
-            <a:off x="9345167" y="5724145"/>
-            <a:ext cx="2514600" cy="457200"/>
-          </a:xfrm>
-          <a:prstGeom prst="rect">
+          <p:cNvPr id="12" name="Shape 6">
+            <a:extLst>
+              <a:ext uri="{FF2B5EF4-FFF2-40B4-BE49-F238E27FC236}">
+                <a16:creationId xmlns:a16="http://schemas.microsoft.com/office/drawing/2014/main" id="{1C4281EC-4683-CA50-887A-6763F89DED4F}"/>
+              </a:ext>
+            </a:extLst>
+          </p:cNvPr>
+          <p:cNvSpPr/>
+          <p:nvPr/>
+        </p:nvSpPr>
+        <p:spPr>
+          <a:xfrm>
+            <a:off x="4232125" y="4631436"/>
+            <a:ext cx="212975" cy="329184"/>
+          </a:xfrm>
+          <a:prstGeom prst="downArrow">
             <a:avLst/>
           </a:prstGeom>
-          <a:noFill/>
-          <a:ln/>
-        </p:spPr>
-        <p:txBody>
-          <a:bodyPr wrap="square" lIns="0" tIns="0" rIns="0" bIns="0" rtlCol="0" anchor="t"/>
-          <a:lstStyle/>
-          <a:p>
-            <a:pPr marL="0" indent="0" algn="ctr">
-              <a:lnSpc>
-                <a:spcPts val="1350"/>
-              </a:lnSpc>
-              <a:buNone/>
-            </a:pPr>
-            <a:r>
-              <a:rPr lang="en-US" sz="1050" i="1" dirty="0">
-                <a:solidFill>
-                  <a:srgbClr val="5C564C"/>
-                </a:solidFill>
-                <a:latin typeface="Calibri" pitchFamily="34" charset="0"/>
-                <a:ea typeface="Calibri" pitchFamily="34" charset="-122"/>
-                <a:cs typeface="Calibri" pitchFamily="34" charset="-120"/>
-              </a:rPr>
-              <a:t>Infamous hallucination and misalignment cases of ChatGPT &amp; Claude</a:t>
-            </a:r>
-            <a:endParaRPr lang="en-US" sz="1050" dirty="0"/>
-          </a:p>
-        </p:txBody>
-      </p:sp>
-      <p:sp>
-        <p:nvSpPr>
-          <p:cNvPr id="14" name="Shape 10"/>
-          <p:cNvSpPr/>
-          <p:nvPr/>
-        </p:nvSpPr>
-        <p:spPr>
-          <a:xfrm>
-            <a:off x="499404" y="2395728"/>
-            <a:ext cx="8138160" cy="804672"/>
-          </a:xfrm>
-          <a:prstGeom prst="rect">
-            <a:avLst/>
-          </a:prstGeom>
           <a:solidFill>
-            <a:srgbClr val="E3DAC5"/>
+            <a:srgbClr val="9B2C2C"/>
           </a:solidFill>
           <a:ln/>
         </p:spPr>
@@ -1829,82 +2144,6 @@
           <a:lstStyle/>
           <a:p>
             <a:endParaRPr lang="en-US"/>
-          </a:p>
-        </p:txBody>
-      </p:sp>
-      <p:sp>
-        <p:nvSpPr>
-          <p:cNvPr id="15" name="Text 11"/>
-          <p:cNvSpPr txBox="1"/>
-          <p:nvPr/>
-        </p:nvSpPr>
-        <p:spPr>
-          <a:xfrm>
-            <a:off x="810299" y="2395728"/>
-            <a:ext cx="7967941" cy="804672"/>
-          </a:xfrm>
-          <a:prstGeom prst="rect">
-            <a:avLst/>
-          </a:prstGeom>
-          <a:noFill/>
-          <a:ln/>
-        </p:spPr>
-        <p:txBody>
-          <a:bodyPr wrap="square" lIns="0" tIns="0" rIns="0" bIns="0" rtlCol="0" anchor="ctr"/>
-          <a:lstStyle/>
-          <a:p>
-            <a:pPr marL="0" indent="0" algn="l">
-              <a:lnSpc>
-                <a:spcPts val="2200"/>
-              </a:lnSpc>
-              <a:buNone/>
-            </a:pPr>
-            <a:r>
-              <a:rPr sz="1450" b="0" dirty="0">
-                <a:solidFill>
-                  <a:srgbClr val="141414"/>
-                </a:solidFill>
-                <a:latin typeface="Cambria"/>
-              </a:rPr>
-              <a:t>The solution: </a:t>
-            </a:r>
-            <a:r>
-              <a:rPr sz="1700" b="1" dirty="0">
-                <a:solidFill>
-                  <a:srgbClr val="9B2C2C"/>
-                </a:solidFill>
-                <a:latin typeface="Cambria"/>
-              </a:rPr>
-              <a:t>bridge the trust gap</a:t>
-            </a:r>
-            <a:endParaRPr lang="en-US" sz="1450" dirty="0"/>
-          </a:p>
-          <a:p>
-            <a:pPr marL="0" indent="0" algn="l">
-              <a:lnSpc>
-                <a:spcPts val="2000"/>
-              </a:lnSpc>
-              <a:buNone/>
-            </a:pPr>
-            <a:r>
-              <a:rPr sz="1450" b="0" dirty="0">
-                <a:solidFill>
-                  <a:srgbClr val="141414"/>
-                </a:solidFill>
-                <a:latin typeface="Cambria"/>
-              </a:rPr>
-              <a:t>by grounding AI with credible information and robust agentic tools  →  </a:t>
-            </a:r>
-            <a:r>
-              <a:rPr sz="1450" b="1" dirty="0">
-                <a:solidFill>
-                  <a:srgbClr val="141414"/>
-                </a:solidFill>
-                <a:latin typeface="Cambria"/>
-              </a:rPr>
-              <a:t>our CRE AI Agent System</a:t>
-            </a:r>
-            <a:endParaRPr lang="en-US" sz="1450" dirty="0"/>
           </a:p>
         </p:txBody>
       </p:sp>
@@ -1966,7 +2205,7 @@
               <a:buNone/>
             </a:pPr>
             <a:r>
-              <a:rPr lang="en-US" sz="1500" b="1" kern="0" spc="200" dirty="0">
+              <a:rPr lang="en-US" sz="1600" b="1" kern="0" spc="200" dirty="0">
                 <a:solidFill>
                   <a:srgbClr val="9B2C2C"/>
                 </a:solidFill>
@@ -1974,17 +2213,6 @@
                 <a:ea typeface="Calibri" pitchFamily="34" charset="-122"/>
                 <a:cs typeface="Calibri" pitchFamily="34" charset="-120"/>
               </a:rPr>
-              <a:t>THE </a:t>
-            </a:r>
-            <a:r>
-              <a:rPr lang="en-US" sz="1600" b="1" kern="0" spc="200" dirty="0">
-                <a:solidFill>
-                  <a:srgbClr val="9B2C2C"/>
-                </a:solidFill>
-                <a:latin typeface="Calibri" pitchFamily="34" charset="0"/>
-                <a:ea typeface="Calibri" pitchFamily="34" charset="-122"/>
-                <a:cs typeface="Calibri" pitchFamily="34" charset="-120"/>
-              </a:rPr>
               <a:t>SOLUTION</a:t>
             </a:r>
             <a:endParaRPr lang="en-US" sz="1100" dirty="0"/>
@@ -2024,7 +2252,7 @@
                 <a:ea typeface="Cambria" pitchFamily="34" charset="-122"/>
                 <a:cs typeface="Cambria" pitchFamily="34" charset="-120"/>
               </a:rPr>
-              <a:t>Rapid, Reliable, and Relevant AI Agent</a:t>
+              <a:t>A Rapid, Reliable, and Relevant AI Agent</a:t>
             </a:r>
             <a:endParaRPr lang="en-US" sz="3400" dirty="0"/>
           </a:p>
@@ -2039,7 +2267,7 @@
           <p:nvPr>
             <p:extLst>
               <p:ext uri="{D42A27DB-BD31-4B8C-83A1-F6EECF244321}">
-                <p14:modId xmlns:p14="http://schemas.microsoft.com/office/powerpoint/2010/main" val="3765204647"/>
+                <p14:modId xmlns:p14="http://schemas.microsoft.com/office/powerpoint/2010/main" val="390585590"/>
               </p:ext>
             </p:extLst>
           </p:nvPr>
@@ -4504,7 +4732,7 @@
               <a:buNone/>
             </a:pPr>
             <a:r>
-              <a:rPr lang="en-US" sz="1500" b="1" kern="0" spc="200" dirty="0">
+              <a:rPr lang="en-US" sz="1600" b="1" kern="0" spc="200" dirty="0">
                 <a:solidFill>
                   <a:srgbClr val="9B2C2C"/>
                 </a:solidFill>
@@ -4512,31 +4740,9 @@
                 <a:ea typeface="Calibri" pitchFamily="34" charset="-122"/>
                 <a:cs typeface="Calibri" pitchFamily="34" charset="-120"/>
               </a:rPr>
-              <a:t>DEMO  ·  OCCUPIER </a:t>
-            </a:r>
-            <a:r>
-              <a:rPr lang="en-US" sz="1600" b="1" kern="0" spc="200" dirty="0">
-                <a:solidFill>
-                  <a:srgbClr val="9B2C2C"/>
-                </a:solidFill>
-                <a:latin typeface="Calibri" pitchFamily="34" charset="0"/>
-                <a:ea typeface="Calibri" pitchFamily="34" charset="-122"/>
-                <a:cs typeface="Calibri" pitchFamily="34" charset="-120"/>
-              </a:rPr>
-              <a:t>DEMAND</a:t>
-            </a:r>
-            <a:r>
-              <a:rPr lang="en-US" sz="1500" b="1" kern="0" spc="200" dirty="0">
-                <a:solidFill>
-                  <a:srgbClr val="9B2C2C"/>
-                </a:solidFill>
-                <a:latin typeface="Calibri" pitchFamily="34" charset="0"/>
-                <a:ea typeface="Calibri" pitchFamily="34" charset="-122"/>
-                <a:cs typeface="Calibri" pitchFamily="34" charset="-120"/>
-              </a:rPr>
-              <a:t> DRIVERS</a:t>
-            </a:r>
-            <a:endParaRPr lang="en-US" sz="1100" dirty="0"/>
+              <a:t>DEMO  ·  OCCUPIER DEMAND DRIVERS</a:t>
+            </a:r>
+            <a:endParaRPr lang="en-US" sz="1600" dirty="0"/>
           </a:p>
         </p:txBody>
       </p:sp>
@@ -5364,8 +5570,8 @@
         </p:nvSpPr>
         <p:spPr>
           <a:xfrm>
-            <a:off x="5649178" y="6437376"/>
-            <a:ext cx="1106393" cy="369332"/>
+            <a:off x="5484069" y="6252710"/>
+            <a:ext cx="1436612" cy="369332"/>
           </a:xfrm>
           <a:prstGeom prst="rect">
             <a:avLst/>
@@ -5383,7 +5589,7 @@
                 <a:latin typeface="Cambria" panose="02040503050406030204" pitchFamily="18" charset="0"/>
                 <a:cs typeface="Calibri" panose="020F0502020204030204" pitchFamily="34" charset="0"/>
               </a:rPr>
-              <a:t>THE END</a:t>
+              <a:t>~THE END~</a:t>
             </a:r>
           </a:p>
         </p:txBody>

</xml_diff>